<commit_message>
feat: update design sheets with new figures for thesis
</commit_message>
<xml_diff>
--- a/thesis/figures/design-doc/design_sheet.pptx
+++ b/thesis/figures/design-doc/design_sheet.pptx
@@ -5,7 +5,7 @@
     <p:sldMasterId id="2147483648" r:id="rId1"/>
   </p:sldMasterIdLst>
   <p:notesMasterIdLst>
-    <p:notesMasterId r:id="rId17"/>
+    <p:notesMasterId r:id="rId15"/>
   </p:notesMasterIdLst>
   <p:sldIdLst>
     <p:sldId id="256" r:id="rId4"/>
@@ -19,8 +19,6 @@
     <p:sldId id="264" r:id="rId12"/>
     <p:sldId id="265" r:id="rId13"/>
     <p:sldId id="266" r:id="rId14"/>
-    <p:sldId id="267" r:id="rId15"/>
-    <p:sldId id="268" r:id="rId16"/>
   </p:sldIdLst>
   <p:sldSz cx="12192000" cy="6858000"/>
   <p:notesSz cx="6858000" cy="9144000"/>
@@ -146,7 +144,7 @@
       </p:grpSpPr>
       <p:sp>
         <p:nvSpPr>
-          <p:cNvPr id="586924748" name="Header Placeholder 1"/>
+          <p:cNvPr id="242525026" name="Header Placeholder 1"/>
           <p:cNvSpPr>
             <a:spLocks noGrp="1"/>
           </p:cNvSpPr>
@@ -180,7 +178,7 @@
       </p:sp>
       <p:sp>
         <p:nvSpPr>
-          <p:cNvPr id="397658550" name="Date Placeholder 2"/>
+          <p:cNvPr id="339299227" name="Date Placeholder 2"/>
           <p:cNvSpPr>
             <a:spLocks noGrp="1"/>
           </p:cNvSpPr>
@@ -218,7 +216,7 @@
       </p:sp>
       <p:sp>
         <p:nvSpPr>
-          <p:cNvPr id="954714842" name="Slide Image Placeholder 3"/>
+          <p:cNvPr id="662585447" name="Slide Image Placeholder 3"/>
           <p:cNvSpPr>
             <a:spLocks noChangeAspect="1" noGrp="1" noRot="1"/>
           </p:cNvSpPr>
@@ -254,7 +252,7 @@
       </p:sp>
       <p:sp>
         <p:nvSpPr>
-          <p:cNvPr id="702849808" name="Notes Placeholder 4"/>
+          <p:cNvPr id="1680219969" name="Notes Placeholder 4"/>
           <p:cNvSpPr>
             <a:spLocks noGrp="1"/>
           </p:cNvSpPr>
@@ -328,7 +326,7 @@
       </p:sp>
       <p:sp>
         <p:nvSpPr>
-          <p:cNvPr id="941489389" name="Footer Placeholder 5"/>
+          <p:cNvPr id="848093800" name="Footer Placeholder 5"/>
           <p:cNvSpPr>
             <a:spLocks noGrp="1"/>
           </p:cNvSpPr>
@@ -362,7 +360,7 @@
       </p:sp>
       <p:sp>
         <p:nvSpPr>
-          <p:cNvPr id="917082559" name="Slide Number Placeholder 6"/>
+          <p:cNvPr id="237869761" name="Slide Number Placeholder 6"/>
           <p:cNvSpPr>
             <a:spLocks noGrp="1"/>
           </p:cNvSpPr>
@@ -515,7 +513,7 @@
       </p:grpSpPr>
       <p:sp>
         <p:nvSpPr>
-          <p:cNvPr id="71539712" name="Slide Image Placeholder 1"/>
+          <p:cNvPr id="806050207" name="Slide Image Placeholder 1"/>
           <p:cNvSpPr>
             <a:spLocks noChangeAspect="1" noGrp="1" noRot="1"/>
           </p:cNvSpPr>
@@ -527,7 +525,7 @@
       </p:sp>
       <p:sp>
         <p:nvSpPr>
-          <p:cNvPr id="292924430" name="Notes Placeholder 2"/>
+          <p:cNvPr id="444048143" name="Notes Placeholder 2"/>
           <p:cNvSpPr>
             <a:spLocks noGrp="1"/>
           </p:cNvSpPr>
@@ -549,7 +547,7 @@
       </p:sp>
       <p:sp>
         <p:nvSpPr>
-          <p:cNvPr id="1768211861" name="Slide Number Placeholder 3"/>
+          <p:cNvPr id="1805363114" name="Slide Number Placeholder 3"/>
           <p:cNvSpPr>
             <a:spLocks noGrp="1"/>
           </p:cNvSpPr>
@@ -600,7 +598,7 @@
       </p:grpSpPr>
       <p:sp>
         <p:nvSpPr>
-          <p:cNvPr id="417771971" name="Slide Image Placeholder 1"/>
+          <p:cNvPr id="206829158" name="Slide Image Placeholder 1"/>
           <p:cNvSpPr>
             <a:spLocks noChangeAspect="1" noGrp="1" noRot="1"/>
           </p:cNvSpPr>
@@ -612,7 +610,7 @@
       </p:sp>
       <p:sp>
         <p:nvSpPr>
-          <p:cNvPr id="1555664419" name="Notes Placeholder 2"/>
+          <p:cNvPr id="251580563" name="Notes Placeholder 2"/>
           <p:cNvSpPr>
             <a:spLocks noGrp="1"/>
           </p:cNvSpPr>
@@ -634,7 +632,7 @@
       </p:sp>
       <p:sp>
         <p:nvSpPr>
-          <p:cNvPr id="511241611" name="Slide Number Placeholder 3"/>
+          <p:cNvPr id="796381878" name="Slide Number Placeholder 3"/>
           <p:cNvSpPr>
             <a:spLocks noGrp="1"/>
           </p:cNvSpPr>
@@ -685,7 +683,7 @@
       </p:grpSpPr>
       <p:sp>
         <p:nvSpPr>
-          <p:cNvPr id="1469607497" name="Slide Image Placeholder 1"/>
+          <p:cNvPr id="1456743905" name="Slide Image Placeholder 1"/>
           <p:cNvSpPr>
             <a:spLocks noChangeAspect="1" noGrp="1" noRot="1"/>
           </p:cNvSpPr>
@@ -697,7 +695,7 @@
       </p:sp>
       <p:sp>
         <p:nvSpPr>
-          <p:cNvPr id="598114943" name="Notes Placeholder 2"/>
+          <p:cNvPr id="542740182" name="Notes Placeholder 2"/>
           <p:cNvSpPr>
             <a:spLocks noGrp="1"/>
           </p:cNvSpPr>
@@ -719,7 +717,7 @@
       </p:sp>
       <p:sp>
         <p:nvSpPr>
-          <p:cNvPr id="907012522" name="Slide Number Placeholder 3"/>
+          <p:cNvPr id="1373515709" name="Slide Number Placeholder 3"/>
           <p:cNvSpPr>
             <a:spLocks noGrp="1"/>
           </p:cNvSpPr>
@@ -736,176 +734,6 @@
               <a:defRPr/>
             </a:pPr>
             <a:fld id="{E9E375C2-3154-48BF-B5AF-FE2DB6926948}" type="slidenum">
-              <a:rPr/>
-              <a:t/>
-            </a:fld>
-            <a:endParaRPr/>
-          </a:p>
-        </p:txBody>
-      </p:sp>
-    </p:spTree>
-  </p:cSld>
-  <p:clrMapOvr>
-    <a:masterClrMapping/>
-  </p:clrMapOvr>
-</p:notes>
-</file>
-
-<file path=ppt/notesSlides/notesSlide12.xml><?xml version="1.0" encoding="utf-8"?>
-<p:notes xmlns:a="http://schemas.openxmlformats.org/drawingml/2006/main" xmlns:r="http://schemas.openxmlformats.org/officeDocument/2006/relationships" xmlns:p="http://schemas.openxmlformats.org/presentationml/2006/main" xmlns:m="http://schemas.openxmlformats.org/officeDocument/2006/math" xmlns:w="http://schemas.openxmlformats.org/wordprocessingml/2006/main">
-  <p:cSld name="">
-    <p:spTree>
-      <p:nvGrpSpPr>
-        <p:cNvPr id="1" name=""/>
-        <p:cNvGrpSpPr/>
-        <p:nvPr/>
-      </p:nvGrpSpPr>
-      <p:grpSpPr bwMode="auto">
-        <a:xfrm>
-          <a:off x="0" y="0"/>
-          <a:ext cx="0" cy="0"/>
-          <a:chOff x="0" y="0"/>
-          <a:chExt cx="0" cy="0"/>
-        </a:xfrm>
-      </p:grpSpPr>
-      <p:sp>
-        <p:nvSpPr>
-          <p:cNvPr id="1823366987" name="Slide Image Placeholder 1"/>
-          <p:cNvSpPr>
-            <a:spLocks noChangeAspect="1" noGrp="1" noRot="1"/>
-          </p:cNvSpPr>
-          <p:nvPr>
-            <p:ph type="sldImg"/>
-          </p:nvPr>
-        </p:nvSpPr>
-        <p:spPr bwMode="auto"/>
-      </p:sp>
-      <p:sp>
-        <p:nvSpPr>
-          <p:cNvPr id="1013408304" name="Notes Placeholder 2"/>
-          <p:cNvSpPr>
-            <a:spLocks noGrp="1"/>
-          </p:cNvSpPr>
-          <p:nvPr>
-            <p:ph type="body" idx="1"/>
-          </p:nvPr>
-        </p:nvSpPr>
-        <p:spPr bwMode="auto"/>
-        <p:txBody>
-          <a:bodyPr/>
-          <a:lstStyle/>
-          <a:p>
-            <a:pPr>
-              <a:defRPr/>
-            </a:pPr>
-            <a:endParaRPr/>
-          </a:p>
-        </p:txBody>
-      </p:sp>
-      <p:sp>
-        <p:nvSpPr>
-          <p:cNvPr id="869031278" name="Slide Number Placeholder 3"/>
-          <p:cNvSpPr>
-            <a:spLocks noGrp="1"/>
-          </p:cNvSpPr>
-          <p:nvPr>
-            <p:ph type="sldNum" sz="quarter" idx="10"/>
-          </p:nvPr>
-        </p:nvSpPr>
-        <p:spPr bwMode="auto"/>
-        <p:txBody>
-          <a:bodyPr/>
-          <a:lstStyle/>
-          <a:p>
-            <a:pPr>
-              <a:defRPr/>
-            </a:pPr>
-            <a:fld id="{B1EEDEA1-B5C4-7AD9-4069-FFCB4626DF2A}" type="slidenum">
-              <a:rPr/>
-              <a:t/>
-            </a:fld>
-            <a:endParaRPr/>
-          </a:p>
-        </p:txBody>
-      </p:sp>
-    </p:spTree>
-  </p:cSld>
-  <p:clrMapOvr>
-    <a:masterClrMapping/>
-  </p:clrMapOvr>
-</p:notes>
-</file>
-
-<file path=ppt/notesSlides/notesSlide13.xml><?xml version="1.0" encoding="utf-8"?>
-<p:notes xmlns:a="http://schemas.openxmlformats.org/drawingml/2006/main" xmlns:r="http://schemas.openxmlformats.org/officeDocument/2006/relationships" xmlns:p="http://schemas.openxmlformats.org/presentationml/2006/main" xmlns:m="http://schemas.openxmlformats.org/officeDocument/2006/math" xmlns:w="http://schemas.openxmlformats.org/wordprocessingml/2006/main">
-  <p:cSld name="">
-    <p:spTree>
-      <p:nvGrpSpPr>
-        <p:cNvPr id="1" name=""/>
-        <p:cNvGrpSpPr/>
-        <p:nvPr/>
-      </p:nvGrpSpPr>
-      <p:grpSpPr bwMode="auto">
-        <a:xfrm>
-          <a:off x="0" y="0"/>
-          <a:ext cx="0" cy="0"/>
-          <a:chOff x="0" y="0"/>
-          <a:chExt cx="0" cy="0"/>
-        </a:xfrm>
-      </p:grpSpPr>
-      <p:sp>
-        <p:nvSpPr>
-          <p:cNvPr id="493117289" name="Slide Image Placeholder 1"/>
-          <p:cNvSpPr>
-            <a:spLocks noChangeAspect="1" noGrp="1" noRot="1"/>
-          </p:cNvSpPr>
-          <p:nvPr>
-            <p:ph type="sldImg"/>
-          </p:nvPr>
-        </p:nvSpPr>
-        <p:spPr bwMode="auto"/>
-      </p:sp>
-      <p:sp>
-        <p:nvSpPr>
-          <p:cNvPr id="1149686278" name="Notes Placeholder 2"/>
-          <p:cNvSpPr>
-            <a:spLocks noGrp="1"/>
-          </p:cNvSpPr>
-          <p:nvPr>
-            <p:ph type="body" idx="1"/>
-          </p:nvPr>
-        </p:nvSpPr>
-        <p:spPr bwMode="auto"/>
-        <p:txBody>
-          <a:bodyPr/>
-          <a:lstStyle/>
-          <a:p>
-            <a:pPr>
-              <a:defRPr/>
-            </a:pPr>
-            <a:endParaRPr/>
-          </a:p>
-        </p:txBody>
-      </p:sp>
-      <p:sp>
-        <p:nvSpPr>
-          <p:cNvPr id="1183285457" name="Slide Number Placeholder 3"/>
-          <p:cNvSpPr>
-            <a:spLocks noGrp="1"/>
-          </p:cNvSpPr>
-          <p:nvPr>
-            <p:ph type="sldNum" sz="quarter" idx="10"/>
-          </p:nvPr>
-        </p:nvSpPr>
-        <p:spPr bwMode="auto"/>
-        <p:txBody>
-          <a:bodyPr/>
-          <a:lstStyle/>
-          <a:p>
-            <a:pPr>
-              <a:defRPr/>
-            </a:pPr>
-            <a:fld id="{0F78B7EB-D52E-2D30-7509-C1F35CBF65DD}" type="slidenum">
               <a:rPr/>
               <a:t/>
             </a:fld>
@@ -940,7 +768,7 @@
       </p:grpSpPr>
       <p:sp>
         <p:nvSpPr>
-          <p:cNvPr id="1756150314" name="Slide Image Placeholder 1"/>
+          <p:cNvPr id="338941716" name="Slide Image Placeholder 1"/>
           <p:cNvSpPr>
             <a:spLocks noChangeAspect="1" noGrp="1" noRot="1"/>
           </p:cNvSpPr>
@@ -957,7 +785,7 @@
       </p:sp>
       <p:sp>
         <p:nvSpPr>
-          <p:cNvPr id="1523715482" name="Notes Placeholder 2"/>
+          <p:cNvPr id="1319207048" name="Notes Placeholder 2"/>
           <p:cNvSpPr>
             <a:spLocks noGrp="1"/>
           </p:cNvSpPr>
@@ -982,7 +810,7 @@
       </p:sp>
       <p:sp>
         <p:nvSpPr>
-          <p:cNvPr id="1193988812" name="Slide Number Placeholder 3"/>
+          <p:cNvPr id="297688104" name="Slide Number Placeholder 3"/>
           <p:cNvSpPr>
             <a:spLocks noGrp="1"/>
           </p:cNvSpPr>
@@ -1033,7 +861,7 @@
       </p:grpSpPr>
       <p:sp>
         <p:nvSpPr>
-          <p:cNvPr id="52798949" name="Slide Image Placeholder 1"/>
+          <p:cNvPr id="905070558" name="Slide Image Placeholder 1"/>
           <p:cNvSpPr>
             <a:spLocks noChangeAspect="1" noGrp="1" noRot="1"/>
           </p:cNvSpPr>
@@ -1045,7 +873,7 @@
       </p:sp>
       <p:sp>
         <p:nvSpPr>
-          <p:cNvPr id="691455901" name="Notes Placeholder 2"/>
+          <p:cNvPr id="1762841550" name="Notes Placeholder 2"/>
           <p:cNvSpPr>
             <a:spLocks noGrp="1"/>
           </p:cNvSpPr>
@@ -1067,7 +895,7 @@
       </p:sp>
       <p:sp>
         <p:nvSpPr>
-          <p:cNvPr id="1659474175" name="Slide Number Placeholder 3"/>
+          <p:cNvPr id="1048858222" name="Slide Number Placeholder 3"/>
           <p:cNvSpPr>
             <a:spLocks noGrp="1"/>
           </p:cNvSpPr>
@@ -1118,7 +946,7 @@
       </p:grpSpPr>
       <p:sp>
         <p:nvSpPr>
-          <p:cNvPr id="2011276638" name="Slide Image Placeholder 1"/>
+          <p:cNvPr id="334873153" name="Slide Image Placeholder 1"/>
           <p:cNvSpPr>
             <a:spLocks noChangeAspect="1" noGrp="1" noRot="1"/>
           </p:cNvSpPr>
@@ -1130,7 +958,7 @@
       </p:sp>
       <p:sp>
         <p:nvSpPr>
-          <p:cNvPr id="814879639" name="Notes Placeholder 2"/>
+          <p:cNvPr id="309443021" name="Notes Placeholder 2"/>
           <p:cNvSpPr>
             <a:spLocks noGrp="1"/>
           </p:cNvSpPr>
@@ -1152,7 +980,7 @@
       </p:sp>
       <p:sp>
         <p:nvSpPr>
-          <p:cNvPr id="214506844" name="Slide Number Placeholder 3"/>
+          <p:cNvPr id="2120264221" name="Slide Number Placeholder 3"/>
           <p:cNvSpPr>
             <a:spLocks noGrp="1"/>
           </p:cNvSpPr>
@@ -1203,7 +1031,7 @@
       </p:grpSpPr>
       <p:sp>
         <p:nvSpPr>
-          <p:cNvPr id="528699282" name="Slide Image Placeholder 1"/>
+          <p:cNvPr id="1323508414" name="Slide Image Placeholder 1"/>
           <p:cNvSpPr>
             <a:spLocks noChangeAspect="1" noGrp="1" noRot="1"/>
           </p:cNvSpPr>
@@ -1215,7 +1043,7 @@
       </p:sp>
       <p:sp>
         <p:nvSpPr>
-          <p:cNvPr id="783715832" name="Notes Placeholder 2"/>
+          <p:cNvPr id="1999467061" name="Notes Placeholder 2"/>
           <p:cNvSpPr>
             <a:spLocks noGrp="1"/>
           </p:cNvSpPr>
@@ -1237,7 +1065,7 @@
       </p:sp>
       <p:sp>
         <p:nvSpPr>
-          <p:cNvPr id="1792891625" name="Slide Number Placeholder 3"/>
+          <p:cNvPr id="904644954" name="Slide Number Placeholder 3"/>
           <p:cNvSpPr>
             <a:spLocks noGrp="1"/>
           </p:cNvSpPr>
@@ -1288,7 +1116,7 @@
       </p:grpSpPr>
       <p:sp>
         <p:nvSpPr>
-          <p:cNvPr id="794375509" name="Slide Image Placeholder 1"/>
+          <p:cNvPr id="1264386909" name="Slide Image Placeholder 1"/>
           <p:cNvSpPr>
             <a:spLocks noChangeAspect="1" noGrp="1" noRot="1"/>
           </p:cNvSpPr>
@@ -1300,7 +1128,7 @@
       </p:sp>
       <p:sp>
         <p:nvSpPr>
-          <p:cNvPr id="2048496873" name="Notes Placeholder 2"/>
+          <p:cNvPr id="567319186" name="Notes Placeholder 2"/>
           <p:cNvSpPr>
             <a:spLocks noGrp="1"/>
           </p:cNvSpPr>
@@ -1322,7 +1150,7 @@
       </p:sp>
       <p:sp>
         <p:nvSpPr>
-          <p:cNvPr id="2006744560" name="Slide Number Placeholder 3"/>
+          <p:cNvPr id="137638838" name="Slide Number Placeholder 3"/>
           <p:cNvSpPr>
             <a:spLocks noGrp="1"/>
           </p:cNvSpPr>
@@ -1373,7 +1201,7 @@
       </p:grpSpPr>
       <p:sp>
         <p:nvSpPr>
-          <p:cNvPr id="1811148790" name="Slide Image Placeholder 1"/>
+          <p:cNvPr id="1360615962" name="Slide Image Placeholder 1"/>
           <p:cNvSpPr>
             <a:spLocks noChangeAspect="1" noGrp="1" noRot="1"/>
           </p:cNvSpPr>
@@ -1390,7 +1218,7 @@
       </p:sp>
       <p:sp>
         <p:nvSpPr>
-          <p:cNvPr id="556967040" name="Notes Placeholder 2"/>
+          <p:cNvPr id="2086722912" name="Notes Placeholder 2"/>
           <p:cNvSpPr>
             <a:spLocks noGrp="1"/>
           </p:cNvSpPr>
@@ -1415,7 +1243,7 @@
       </p:sp>
       <p:sp>
         <p:nvSpPr>
-          <p:cNvPr id="969523315" name="Slide Number Placeholder 3"/>
+          <p:cNvPr id="171436960" name="Slide Number Placeholder 3"/>
           <p:cNvSpPr>
             <a:spLocks noGrp="1"/>
           </p:cNvSpPr>
@@ -1466,7 +1294,7 @@
       </p:grpSpPr>
       <p:sp>
         <p:nvSpPr>
-          <p:cNvPr id="1831414639" name="Slide Image Placeholder 1"/>
+          <p:cNvPr id="528784184" name="Slide Image Placeholder 1"/>
           <p:cNvSpPr>
             <a:spLocks noChangeAspect="1" noGrp="1" noRot="1"/>
           </p:cNvSpPr>
@@ -1483,7 +1311,7 @@
       </p:sp>
       <p:sp>
         <p:nvSpPr>
-          <p:cNvPr id="755167184" name="Notes Placeholder 2"/>
+          <p:cNvPr id="1639206760" name="Notes Placeholder 2"/>
           <p:cNvSpPr>
             <a:spLocks noGrp="1"/>
           </p:cNvSpPr>
@@ -1508,7 +1336,7 @@
       </p:sp>
       <p:sp>
         <p:nvSpPr>
-          <p:cNvPr id="1726309956" name="Slide Number Placeholder 3"/>
+          <p:cNvPr id="243665319" name="Slide Number Placeholder 3"/>
           <p:cNvSpPr>
             <a:spLocks noGrp="1"/>
           </p:cNvSpPr>
@@ -1559,7 +1387,7 @@
       </p:grpSpPr>
       <p:sp>
         <p:nvSpPr>
-          <p:cNvPr id="800972707" name="Slide Image Placeholder 1"/>
+          <p:cNvPr id="1999109334" name="Slide Image Placeholder 1"/>
           <p:cNvSpPr>
             <a:spLocks noChangeAspect="1" noGrp="1" noRot="1"/>
           </p:cNvSpPr>
@@ -1571,7 +1399,7 @@
       </p:sp>
       <p:sp>
         <p:nvSpPr>
-          <p:cNvPr id="1251238983" name="Notes Placeholder 2"/>
+          <p:cNvPr id="2085803209" name="Notes Placeholder 2"/>
           <p:cNvSpPr>
             <a:spLocks noGrp="1"/>
           </p:cNvSpPr>
@@ -1593,7 +1421,7 @@
       </p:sp>
       <p:sp>
         <p:nvSpPr>
-          <p:cNvPr id="79864017" name="Slide Number Placeholder 3"/>
+          <p:cNvPr id="539841633" name="Slide Number Placeholder 3"/>
           <p:cNvSpPr>
             <a:spLocks noGrp="1"/>
           </p:cNvSpPr>
@@ -1644,7 +1472,7 @@
       </p:grpSpPr>
       <p:sp>
         <p:nvSpPr>
-          <p:cNvPr id="714184206" name="Title 1"/>
+          <p:cNvPr id="1942701461" name="Title 1"/>
           <p:cNvSpPr>
             <a:spLocks noGrp="1"/>
           </p:cNvSpPr>
@@ -1679,7 +1507,7 @@
       </p:sp>
       <p:sp>
         <p:nvSpPr>
-          <p:cNvPr id="1629194733" name="Subtitle 2"/>
+          <p:cNvPr id="1478871097" name="Subtitle 2"/>
           <p:cNvSpPr>
             <a:spLocks noGrp="1"/>
           </p:cNvSpPr>
@@ -1747,7 +1575,7 @@
       </p:sp>
       <p:sp>
         <p:nvSpPr>
-          <p:cNvPr id="916435109" name="Date Placeholder 3"/>
+          <p:cNvPr id="275103995" name="Date Placeholder 3"/>
           <p:cNvSpPr>
             <a:spLocks noGrp="1"/>
           </p:cNvSpPr>
@@ -1773,7 +1601,7 @@
       </p:sp>
       <p:sp>
         <p:nvSpPr>
-          <p:cNvPr id="100205529" name="Footer Placeholder 4"/>
+          <p:cNvPr id="829274542" name="Footer Placeholder 4"/>
           <p:cNvSpPr>
             <a:spLocks noGrp="1"/>
           </p:cNvSpPr>
@@ -1795,7 +1623,7 @@
       </p:sp>
       <p:sp>
         <p:nvSpPr>
-          <p:cNvPr id="1002619789" name="Slide Number Placeholder 5"/>
+          <p:cNvPr id="1283860535" name="Slide Number Placeholder 5"/>
           <p:cNvSpPr>
             <a:spLocks noGrp="1"/>
           </p:cNvSpPr>
@@ -1846,7 +1674,7 @@
       </p:grpSpPr>
       <p:sp>
         <p:nvSpPr>
-          <p:cNvPr id="254322740" name="Title 1"/>
+          <p:cNvPr id="1465010205" name="Title 1"/>
           <p:cNvSpPr>
             <a:spLocks noGrp="1"/>
           </p:cNvSpPr>
@@ -1872,7 +1700,7 @@
       </p:sp>
       <p:sp>
         <p:nvSpPr>
-          <p:cNvPr id="1414178071" name="Vertical Text Placeholder 2"/>
+          <p:cNvPr id="857435940" name="Vertical Text Placeholder 2"/>
           <p:cNvSpPr>
             <a:spLocks noGrp="1"/>
           </p:cNvSpPr>
@@ -1938,7 +1766,7 @@
       </p:sp>
       <p:sp>
         <p:nvSpPr>
-          <p:cNvPr id="602820896" name="Date Placeholder 3"/>
+          <p:cNvPr id="244446161" name="Date Placeholder 3"/>
           <p:cNvSpPr>
             <a:spLocks noGrp="1"/>
           </p:cNvSpPr>
@@ -1964,7 +1792,7 @@
       </p:sp>
       <p:sp>
         <p:nvSpPr>
-          <p:cNvPr id="369293169" name="Footer Placeholder 4"/>
+          <p:cNvPr id="484209624" name="Footer Placeholder 4"/>
           <p:cNvSpPr>
             <a:spLocks noGrp="1"/>
           </p:cNvSpPr>
@@ -1986,7 +1814,7 @@
       </p:sp>
       <p:sp>
         <p:nvSpPr>
-          <p:cNvPr id="178909882" name="Slide Number Placeholder 5"/>
+          <p:cNvPr id="1788500921" name="Slide Number Placeholder 5"/>
           <p:cNvSpPr>
             <a:spLocks noGrp="1"/>
           </p:cNvSpPr>
@@ -2037,7 +1865,7 @@
       </p:grpSpPr>
       <p:sp>
         <p:nvSpPr>
-          <p:cNvPr id="65939156" name="Vertical Title 1"/>
+          <p:cNvPr id="365132060" name="Vertical Title 1"/>
           <p:cNvSpPr>
             <a:spLocks noGrp="1"/>
           </p:cNvSpPr>
@@ -2068,7 +1896,7 @@
       </p:sp>
       <p:sp>
         <p:nvSpPr>
-          <p:cNvPr id="714204816" name="Vertical Text Placeholder 2"/>
+          <p:cNvPr id="1866563866" name="Vertical Text Placeholder 2"/>
           <p:cNvSpPr>
             <a:spLocks noGrp="1"/>
           </p:cNvSpPr>
@@ -2139,7 +1967,7 @@
       </p:sp>
       <p:sp>
         <p:nvSpPr>
-          <p:cNvPr id="2116404635" name="Date Placeholder 3"/>
+          <p:cNvPr id="2128042035" name="Date Placeholder 3"/>
           <p:cNvSpPr>
             <a:spLocks noGrp="1"/>
           </p:cNvSpPr>
@@ -2165,7 +1993,7 @@
       </p:sp>
       <p:sp>
         <p:nvSpPr>
-          <p:cNvPr id="1569049222" name="Footer Placeholder 4"/>
+          <p:cNvPr id="235769871" name="Footer Placeholder 4"/>
           <p:cNvSpPr>
             <a:spLocks noGrp="1"/>
           </p:cNvSpPr>
@@ -2187,7 +2015,7 @@
       </p:sp>
       <p:sp>
         <p:nvSpPr>
-          <p:cNvPr id="1740097079" name="Slide Number Placeholder 5"/>
+          <p:cNvPr id="1183524710" name="Slide Number Placeholder 5"/>
           <p:cNvSpPr>
             <a:spLocks noGrp="1"/>
           </p:cNvSpPr>
@@ -2238,7 +2066,7 @@
       </p:grpSpPr>
       <p:sp>
         <p:nvSpPr>
-          <p:cNvPr id="290931954" name="Title 1"/>
+          <p:cNvPr id="724847494" name="Title 1"/>
           <p:cNvSpPr>
             <a:spLocks noGrp="1"/>
           </p:cNvSpPr>
@@ -2264,7 +2092,7 @@
       </p:sp>
       <p:sp>
         <p:nvSpPr>
-          <p:cNvPr id="207723373" name="Content Placeholder 2"/>
+          <p:cNvPr id="2066636675" name="Content Placeholder 2"/>
           <p:cNvSpPr>
             <a:spLocks noGrp="1"/>
           </p:cNvSpPr>
@@ -2330,7 +2158,7 @@
       </p:sp>
       <p:sp>
         <p:nvSpPr>
-          <p:cNvPr id="668498641" name="Date Placeholder 3"/>
+          <p:cNvPr id="1028177447" name="Date Placeholder 3"/>
           <p:cNvSpPr>
             <a:spLocks noGrp="1"/>
           </p:cNvSpPr>
@@ -2356,7 +2184,7 @@
       </p:sp>
       <p:sp>
         <p:nvSpPr>
-          <p:cNvPr id="1740105772" name="Footer Placeholder 4"/>
+          <p:cNvPr id="1029286317" name="Footer Placeholder 4"/>
           <p:cNvSpPr>
             <a:spLocks noGrp="1"/>
           </p:cNvSpPr>
@@ -2378,7 +2206,7 @@
       </p:sp>
       <p:sp>
         <p:nvSpPr>
-          <p:cNvPr id="298430867" name="Slide Number Placeholder 5"/>
+          <p:cNvPr id="256533868" name="Slide Number Placeholder 5"/>
           <p:cNvSpPr>
             <a:spLocks noGrp="1"/>
           </p:cNvSpPr>
@@ -2429,7 +2257,7 @@
       </p:grpSpPr>
       <p:sp>
         <p:nvSpPr>
-          <p:cNvPr id="645709828" name="Title 1"/>
+          <p:cNvPr id="1749976915" name="Title 1"/>
           <p:cNvSpPr>
             <a:spLocks noGrp="1"/>
           </p:cNvSpPr>
@@ -2464,7 +2292,7 @@
       </p:sp>
       <p:sp>
         <p:nvSpPr>
-          <p:cNvPr id="558599968" name="Text Placeholder 2"/>
+          <p:cNvPr id="1665480431" name="Text Placeholder 2"/>
           <p:cNvSpPr>
             <a:spLocks noGrp="1"/>
           </p:cNvSpPr>
@@ -2586,7 +2414,7 @@
       </p:sp>
       <p:sp>
         <p:nvSpPr>
-          <p:cNvPr id="2090569296" name="Date Placeholder 3"/>
+          <p:cNvPr id="858004028" name="Date Placeholder 3"/>
           <p:cNvSpPr>
             <a:spLocks noGrp="1"/>
           </p:cNvSpPr>
@@ -2612,7 +2440,7 @@
       </p:sp>
       <p:sp>
         <p:nvSpPr>
-          <p:cNvPr id="1043118580" name="Footer Placeholder 4"/>
+          <p:cNvPr id="901535260" name="Footer Placeholder 4"/>
           <p:cNvSpPr>
             <a:spLocks noGrp="1"/>
           </p:cNvSpPr>
@@ -2634,7 +2462,7 @@
       </p:sp>
       <p:sp>
         <p:nvSpPr>
-          <p:cNvPr id="2044270370" name="Slide Number Placeholder 5"/>
+          <p:cNvPr id="1336738004" name="Slide Number Placeholder 5"/>
           <p:cNvSpPr>
             <a:spLocks noGrp="1"/>
           </p:cNvSpPr>
@@ -2685,7 +2513,7 @@
       </p:grpSpPr>
       <p:sp>
         <p:nvSpPr>
-          <p:cNvPr id="1093058412" name="Title 1"/>
+          <p:cNvPr id="1119583293" name="Title 1"/>
           <p:cNvSpPr>
             <a:spLocks noGrp="1"/>
           </p:cNvSpPr>
@@ -2711,7 +2539,7 @@
       </p:sp>
       <p:sp>
         <p:nvSpPr>
-          <p:cNvPr id="1386899622" name="Content Placeholder 2"/>
+          <p:cNvPr id="761649499" name="Content Placeholder 2"/>
           <p:cNvSpPr>
             <a:spLocks noGrp="1"/>
           </p:cNvSpPr>
@@ -2782,7 +2610,7 @@
       </p:sp>
       <p:sp>
         <p:nvSpPr>
-          <p:cNvPr id="2008471144" name="Content Placeholder 3"/>
+          <p:cNvPr id="533089565" name="Content Placeholder 3"/>
           <p:cNvSpPr>
             <a:spLocks noGrp="1"/>
           </p:cNvSpPr>
@@ -2853,7 +2681,7 @@
       </p:sp>
       <p:sp>
         <p:nvSpPr>
-          <p:cNvPr id="2001631170" name="Date Placeholder 4"/>
+          <p:cNvPr id="2116268663" name="Date Placeholder 4"/>
           <p:cNvSpPr>
             <a:spLocks noGrp="1"/>
           </p:cNvSpPr>
@@ -2879,7 +2707,7 @@
       </p:sp>
       <p:sp>
         <p:nvSpPr>
-          <p:cNvPr id="1155071420" name="Footer Placeholder 5"/>
+          <p:cNvPr id="1514277338" name="Footer Placeholder 5"/>
           <p:cNvSpPr>
             <a:spLocks noGrp="1"/>
           </p:cNvSpPr>
@@ -2901,7 +2729,7 @@
       </p:sp>
       <p:sp>
         <p:nvSpPr>
-          <p:cNvPr id="765699055" name="Slide Number Placeholder 6"/>
+          <p:cNvPr id="211045917" name="Slide Number Placeholder 6"/>
           <p:cNvSpPr>
             <a:spLocks noGrp="1"/>
           </p:cNvSpPr>
@@ -2952,7 +2780,7 @@
       </p:grpSpPr>
       <p:sp>
         <p:nvSpPr>
-          <p:cNvPr id="415450012" name="Title 1"/>
+          <p:cNvPr id="1030582901" name="Title 1"/>
           <p:cNvSpPr>
             <a:spLocks noGrp="1"/>
           </p:cNvSpPr>
@@ -2983,7 +2811,7 @@
       </p:sp>
       <p:sp>
         <p:nvSpPr>
-          <p:cNvPr id="34105582" name="Text Placeholder 2"/>
+          <p:cNvPr id="2077752060" name="Text Placeholder 2"/>
           <p:cNvSpPr>
             <a:spLocks noGrp="1"/>
           </p:cNvSpPr>
@@ -3051,7 +2879,7 @@
       </p:sp>
       <p:sp>
         <p:nvSpPr>
-          <p:cNvPr id="778604294" name="Content Placeholder 3"/>
+          <p:cNvPr id="948142480" name="Content Placeholder 3"/>
           <p:cNvSpPr>
             <a:spLocks noGrp="1"/>
           </p:cNvSpPr>
@@ -3122,7 +2950,7 @@
       </p:sp>
       <p:sp>
         <p:nvSpPr>
-          <p:cNvPr id="414979725" name="Text Placeholder 4"/>
+          <p:cNvPr id="599644607" name="Text Placeholder 4"/>
           <p:cNvSpPr>
             <a:spLocks noGrp="1"/>
           </p:cNvSpPr>
@@ -3190,7 +3018,7 @@
       </p:sp>
       <p:sp>
         <p:nvSpPr>
-          <p:cNvPr id="835169431" name="Content Placeholder 5"/>
+          <p:cNvPr id="132612307" name="Content Placeholder 5"/>
           <p:cNvSpPr>
             <a:spLocks noGrp="1"/>
           </p:cNvSpPr>
@@ -3261,7 +3089,7 @@
       </p:sp>
       <p:sp>
         <p:nvSpPr>
-          <p:cNvPr id="216256052" name="Date Placeholder 6"/>
+          <p:cNvPr id="1062456643" name="Date Placeholder 6"/>
           <p:cNvSpPr>
             <a:spLocks noGrp="1"/>
           </p:cNvSpPr>
@@ -3287,7 +3115,7 @@
       </p:sp>
       <p:sp>
         <p:nvSpPr>
-          <p:cNvPr id="490082584" name="Footer Placeholder 7"/>
+          <p:cNvPr id="1662108307" name="Footer Placeholder 7"/>
           <p:cNvSpPr>
             <a:spLocks noGrp="1"/>
           </p:cNvSpPr>
@@ -3309,7 +3137,7 @@
       </p:sp>
       <p:sp>
         <p:nvSpPr>
-          <p:cNvPr id="1577036012" name="Slide Number Placeholder 8"/>
+          <p:cNvPr id="1772239346" name="Slide Number Placeholder 8"/>
           <p:cNvSpPr>
             <a:spLocks noGrp="1"/>
           </p:cNvSpPr>
@@ -3360,7 +3188,7 @@
       </p:grpSpPr>
       <p:sp>
         <p:nvSpPr>
-          <p:cNvPr id="1354114712" name="Title 1"/>
+          <p:cNvPr id="357632522" name="Title 1"/>
           <p:cNvSpPr>
             <a:spLocks noGrp="1"/>
           </p:cNvSpPr>
@@ -3386,7 +3214,7 @@
       </p:sp>
       <p:sp>
         <p:nvSpPr>
-          <p:cNvPr id="441863796" name="Date Placeholder 2"/>
+          <p:cNvPr id="1147440525" name="Date Placeholder 2"/>
           <p:cNvSpPr>
             <a:spLocks noGrp="1"/>
           </p:cNvSpPr>
@@ -3412,7 +3240,7 @@
       </p:sp>
       <p:sp>
         <p:nvSpPr>
-          <p:cNvPr id="291555508" name="Footer Placeholder 3"/>
+          <p:cNvPr id="105034028" name="Footer Placeholder 3"/>
           <p:cNvSpPr>
             <a:spLocks noGrp="1"/>
           </p:cNvSpPr>
@@ -3434,7 +3262,7 @@
       </p:sp>
       <p:sp>
         <p:nvSpPr>
-          <p:cNvPr id="1029859565" name="Slide Number Placeholder 4"/>
+          <p:cNvPr id="1978172466" name="Slide Number Placeholder 4"/>
           <p:cNvSpPr>
             <a:spLocks noGrp="1"/>
           </p:cNvSpPr>
@@ -3485,7 +3313,7 @@
       </p:grpSpPr>
       <p:sp>
         <p:nvSpPr>
-          <p:cNvPr id="1061561614" name="Date Placeholder 1"/>
+          <p:cNvPr id="1285117397" name="Date Placeholder 1"/>
           <p:cNvSpPr>
             <a:spLocks noGrp="1"/>
           </p:cNvSpPr>
@@ -3511,7 +3339,7 @@
       </p:sp>
       <p:sp>
         <p:nvSpPr>
-          <p:cNvPr id="645783051" name="Footer Placeholder 2"/>
+          <p:cNvPr id="1003290803" name="Footer Placeholder 2"/>
           <p:cNvSpPr>
             <a:spLocks noGrp="1"/>
           </p:cNvSpPr>
@@ -3533,7 +3361,7 @@
       </p:sp>
       <p:sp>
         <p:nvSpPr>
-          <p:cNvPr id="1161234177" name="Slide Number Placeholder 3"/>
+          <p:cNvPr id="681029555" name="Slide Number Placeholder 3"/>
           <p:cNvSpPr>
             <a:spLocks noGrp="1"/>
           </p:cNvSpPr>
@@ -3584,7 +3412,7 @@
       </p:grpSpPr>
       <p:sp>
         <p:nvSpPr>
-          <p:cNvPr id="387682153" name="Title 1"/>
+          <p:cNvPr id="678158066" name="Title 1"/>
           <p:cNvSpPr>
             <a:spLocks noGrp="1"/>
           </p:cNvSpPr>
@@ -3619,7 +3447,7 @@
       </p:sp>
       <p:sp>
         <p:nvSpPr>
-          <p:cNvPr id="1713689424" name="Content Placeholder 2"/>
+          <p:cNvPr id="128251859" name="Content Placeholder 2"/>
           <p:cNvSpPr>
             <a:spLocks noGrp="1"/>
           </p:cNvSpPr>
@@ -3718,7 +3546,7 @@
       </p:sp>
       <p:sp>
         <p:nvSpPr>
-          <p:cNvPr id="763851417" name="Text Placeholder 3"/>
+          <p:cNvPr id="1105983992" name="Text Placeholder 3"/>
           <p:cNvSpPr>
             <a:spLocks noGrp="1"/>
           </p:cNvSpPr>
@@ -3786,7 +3614,7 @@
       </p:sp>
       <p:sp>
         <p:nvSpPr>
-          <p:cNvPr id="689464584" name="Date Placeholder 4"/>
+          <p:cNvPr id="64823584" name="Date Placeholder 4"/>
           <p:cNvSpPr>
             <a:spLocks noGrp="1"/>
           </p:cNvSpPr>
@@ -3812,7 +3640,7 @@
       </p:sp>
       <p:sp>
         <p:nvSpPr>
-          <p:cNvPr id="1489025774" name="Footer Placeholder 5"/>
+          <p:cNvPr id="592535369" name="Footer Placeholder 5"/>
           <p:cNvSpPr>
             <a:spLocks noGrp="1"/>
           </p:cNvSpPr>
@@ -3834,7 +3662,7 @@
       </p:sp>
       <p:sp>
         <p:nvSpPr>
-          <p:cNvPr id="436399478" name="Slide Number Placeholder 6"/>
+          <p:cNvPr id="1042266541" name="Slide Number Placeholder 6"/>
           <p:cNvSpPr>
             <a:spLocks noGrp="1"/>
           </p:cNvSpPr>
@@ -3885,7 +3713,7 @@
       </p:grpSpPr>
       <p:sp>
         <p:nvSpPr>
-          <p:cNvPr id="997630714" name="Title 1"/>
+          <p:cNvPr id="713659903" name="Title 1"/>
           <p:cNvSpPr>
             <a:spLocks noGrp="1"/>
           </p:cNvSpPr>
@@ -3920,7 +3748,7 @@
       </p:sp>
       <p:sp>
         <p:nvSpPr>
-          <p:cNvPr id="666760984" name="Picture Placeholder 2"/>
+          <p:cNvPr id="989521794" name="Picture Placeholder 2"/>
           <p:cNvSpPr>
             <a:spLocks noChangeAspect="1" noGrp="1"/>
           </p:cNvSpPr>
@@ -3988,7 +3816,7 @@
       </p:sp>
       <p:sp>
         <p:nvSpPr>
-          <p:cNvPr id="154487980" name="Text Placeholder 3"/>
+          <p:cNvPr id="1548188623" name="Text Placeholder 3"/>
           <p:cNvSpPr>
             <a:spLocks noGrp="1"/>
           </p:cNvSpPr>
@@ -4056,7 +3884,7 @@
       </p:sp>
       <p:sp>
         <p:nvSpPr>
-          <p:cNvPr id="1576069" name="Date Placeholder 4"/>
+          <p:cNvPr id="1574371352" name="Date Placeholder 4"/>
           <p:cNvSpPr>
             <a:spLocks noGrp="1"/>
           </p:cNvSpPr>
@@ -4082,7 +3910,7 @@
       </p:sp>
       <p:sp>
         <p:nvSpPr>
-          <p:cNvPr id="186894477" name="Footer Placeholder 5"/>
+          <p:cNvPr id="1970673107" name="Footer Placeholder 5"/>
           <p:cNvSpPr>
             <a:spLocks noGrp="1"/>
           </p:cNvSpPr>
@@ -4104,7 +3932,7 @@
       </p:sp>
       <p:sp>
         <p:nvSpPr>
-          <p:cNvPr id="1274856647" name="Slide Number Placeholder 6"/>
+          <p:cNvPr id="698852093" name="Slide Number Placeholder 6"/>
           <p:cNvSpPr>
             <a:spLocks noGrp="1"/>
           </p:cNvSpPr>
@@ -4160,7 +3988,7 @@
       </p:grpSpPr>
       <p:sp>
         <p:nvSpPr>
-          <p:cNvPr id="1248534828" name="Title Placeholder 1"/>
+          <p:cNvPr id="194607695" name="Title Placeholder 1"/>
           <p:cNvSpPr>
             <a:spLocks noGrp="1"/>
           </p:cNvSpPr>
@@ -4196,7 +4024,7 @@
       </p:sp>
       <p:sp>
         <p:nvSpPr>
-          <p:cNvPr id="347165669" name="Text Placeholder 2"/>
+          <p:cNvPr id="2113473307" name="Text Placeholder 2"/>
           <p:cNvSpPr>
             <a:spLocks noGrp="1"/>
           </p:cNvSpPr>
@@ -4272,7 +4100,7 @@
       </p:sp>
       <p:sp>
         <p:nvSpPr>
-          <p:cNvPr id="1694395029" name="Date Placeholder 3"/>
+          <p:cNvPr id="68179684" name="Date Placeholder 3"/>
           <p:cNvSpPr>
             <a:spLocks noGrp="1"/>
           </p:cNvSpPr>
@@ -4316,7 +4144,7 @@
       </p:sp>
       <p:sp>
         <p:nvSpPr>
-          <p:cNvPr id="1508954158" name="Footer Placeholder 4"/>
+          <p:cNvPr id="2104009947" name="Footer Placeholder 4"/>
           <p:cNvSpPr>
             <a:spLocks noGrp="1"/>
           </p:cNvSpPr>
@@ -4356,7 +4184,7 @@
       </p:sp>
       <p:sp>
         <p:nvSpPr>
-          <p:cNvPr id="2007138723" name="Slide Number Placeholder 5"/>
+          <p:cNvPr id="370844935" name="Slide Number Placeholder 5"/>
           <p:cNvSpPr>
             <a:spLocks noGrp="1"/>
           </p:cNvSpPr>
@@ -4716,7 +4544,7 @@
       </p:grpSpPr>
       <p:sp>
         <p:nvSpPr>
-          <p:cNvPr id="26993655" name="Title 1"/>
+          <p:cNvPr id="1055204318" name="Title 1"/>
           <p:cNvSpPr>
             <a:spLocks noGrp="1"/>
           </p:cNvSpPr>
@@ -4742,7 +4570,7 @@
       </p:sp>
       <p:sp>
         <p:nvSpPr>
-          <p:cNvPr id="1561973121" name=""/>
+          <p:cNvPr id="2038736794" name=""/>
           <p:cNvSpPr txBox="1"/>
           <p:nvPr/>
         </p:nvSpPr>
@@ -4774,7 +4602,7 @@
       </p:sp>
       <p:sp>
         <p:nvSpPr>
-          <p:cNvPr id="522187975" name=""/>
+          <p:cNvPr id="1526532383" name=""/>
           <p:cNvSpPr txBox="1"/>
           <p:nvPr/>
         </p:nvSpPr>
@@ -4839,7 +4667,7 @@
       </p:grpSpPr>
       <p:sp>
         <p:nvSpPr>
-          <p:cNvPr id="1289007288" name=""/>
+          <p:cNvPr id="1081410695" name=""/>
           <p:cNvSpPr txBox="1"/>
           <p:nvPr/>
         </p:nvSpPr>
@@ -4871,7 +4699,7 @@
       </p:sp>
       <p:sp>
         <p:nvSpPr>
-          <p:cNvPr id="1325347046" name=""/>
+          <p:cNvPr id="1404641680" name=""/>
           <p:cNvSpPr txBox="1"/>
           <p:nvPr/>
         </p:nvSpPr>
@@ -4903,7 +4731,7 @@
       </p:sp>
       <p:grpSp>
         <p:nvGrpSpPr>
-          <p:cNvPr id="312292077" name=""/>
+          <p:cNvPr id="2069807846" name=""/>
           <p:cNvGrpSpPr/>
           <p:nvPr/>
         </p:nvGrpSpPr>
@@ -6071,7 +5899,7 @@
       </p:grpSp>
       <p:grpSp>
         <p:nvGrpSpPr>
-          <p:cNvPr id="442841969" name=""/>
+          <p:cNvPr id="1184638299" name=""/>
           <p:cNvGrpSpPr/>
           <p:nvPr/>
         </p:nvGrpSpPr>
@@ -10715,7 +10543,7 @@
       </p:grpSpPr>
       <p:sp>
         <p:nvSpPr>
-          <p:cNvPr id="1709274762" name=""/>
+          <p:cNvPr id="505824395" name=""/>
           <p:cNvSpPr txBox="1"/>
           <p:nvPr/>
         </p:nvSpPr>
@@ -10747,7 +10575,7 @@
       </p:sp>
       <p:pic>
         <p:nvPicPr>
-          <p:cNvPr id="2054234467" name=""/>
+          <p:cNvPr id="2076413520" name=""/>
           <p:cNvPicPr>
             <a:picLocks noChangeAspect="1"/>
           </p:cNvPicPr>
@@ -10769,7 +10597,7 @@
       </p:pic>
       <p:sp>
         <p:nvSpPr>
-          <p:cNvPr id="862347865" name=""/>
+          <p:cNvPr id="2089461786" name=""/>
           <p:cNvSpPr txBox="1"/>
           <p:nvPr/>
         </p:nvSpPr>
@@ -10838,7 +10666,7 @@
       </p:sp>
       <p:sp>
         <p:nvSpPr>
-          <p:cNvPr id="1376260884" name=""/>
+          <p:cNvPr id="1218318881" name=""/>
           <p:cNvSpPr txBox="1"/>
           <p:nvPr/>
         </p:nvSpPr>
@@ -10884,127 +10712,6 @@
 </p:sld>
 </file>
 
-<file path=ppt/slides/slide12.xml><?xml version="1.0" encoding="utf-8"?>
-<p:sld xmlns:a="http://schemas.openxmlformats.org/drawingml/2006/main" xmlns:r="http://schemas.openxmlformats.org/officeDocument/2006/relationships" xmlns:p="http://schemas.openxmlformats.org/presentationml/2006/main" xmlns:m="http://schemas.openxmlformats.org/officeDocument/2006/math" xmlns:w="http://schemas.openxmlformats.org/wordprocessingml/2006/main" xmlns:mc="http://schemas.openxmlformats.org/markup-compatibility/2006" showMasterPhAnim="0" showMasterSp="1" show="1">
-  <p:cSld name="">
-    <p:spTree>
-      <p:nvGrpSpPr>
-        <p:cNvPr id="1" name=""/>
-        <p:cNvGrpSpPr/>
-        <p:nvPr/>
-      </p:nvGrpSpPr>
-      <p:grpSpPr bwMode="auto">
-        <a:xfrm>
-          <a:off x="0" y="0"/>
-          <a:ext cx="0" cy="0"/>
-          <a:chOff x="0" y="0"/>
-          <a:chExt cx="0" cy="0"/>
-        </a:xfrm>
-      </p:grpSpPr>
-      <p:sp>
-        <p:nvSpPr>
-          <p:cNvPr id="1112720695" name="Title 1"/>
-          <p:cNvSpPr>
-            <a:spLocks noGrp="1"/>
-          </p:cNvSpPr>
-          <p:nvPr>
-            <p:ph type="title"/>
-          </p:nvPr>
-        </p:nvSpPr>
-        <p:spPr bwMode="auto">
-          <a:xfrm>
-            <a:off x="2666999" y="2860674"/>
-            <a:ext cx="10515600" cy="1325562"/>
-          </a:xfrm>
-        </p:spPr>
-        <p:txBody>
-          <a:bodyPr vertOverflow="overflow" horzOverflow="overflow" vert="horz" wrap="square" lIns="91440" tIns="45720" rIns="91440" bIns="45720" numCol="1" spcCol="0" rtlCol="0" fromWordArt="0" anchor="ctr" anchorCtr="0" forceAA="0" upright="0" compatLnSpc="0">
-            <a:normAutofit fontScale="95000" lnSpcReduction="1000"/>
-          </a:bodyPr>
-          <a:lstStyle/>
-          <a:p>
-            <a:pPr>
-              <a:defRPr/>
-            </a:pPr>
-            <a:r>
-              <a:rPr lang="fr-FR" sz="9600"/>
-              <a:t>EXPORTS</a:t>
-            </a:r>
-            <a:endParaRPr sz="9600"/>
-          </a:p>
-        </p:txBody>
-      </p:sp>
-    </p:spTree>
-  </p:cSld>
-  <p:clrMapOvr>
-    <a:masterClrMapping/>
-  </p:clrMapOvr>
-  <mc:AlternateContent xmlns:mc="http://schemas.openxmlformats.org/markup-compatibility/2006">
-    <mc:Choice xmlns:p159="http://schemas.microsoft.com/office/powerpoint/2015/09/main" xmlns:p14="http://schemas.microsoft.com/office/powerpoint/2010/main" Requires="p159">
-      <p:transition p14:dur="500" advClick="1"/>
-    </mc:Choice>
-    <mc:Fallback>
-      <p:transition advClick="1"/>
-    </mc:Fallback>
-  </mc:AlternateContent>
-</p:sld>
-</file>
-
-<file path=ppt/slides/slide13.xml><?xml version="1.0" encoding="utf-8"?>
-<p:sld xmlns:a="http://schemas.openxmlformats.org/drawingml/2006/main" xmlns:r="http://schemas.openxmlformats.org/officeDocument/2006/relationships" xmlns:p="http://schemas.openxmlformats.org/presentationml/2006/main" xmlns:m="http://schemas.openxmlformats.org/officeDocument/2006/math" xmlns:w="http://schemas.openxmlformats.org/wordprocessingml/2006/main" xmlns:mc="http://schemas.openxmlformats.org/markup-compatibility/2006" showMasterPhAnim="0" showMasterSp="1" show="1">
-  <p:cSld name="">
-    <p:spTree>
-      <p:nvGrpSpPr>
-        <p:cNvPr id="1" name=""/>
-        <p:cNvGrpSpPr/>
-        <p:nvPr/>
-      </p:nvGrpSpPr>
-      <p:grpSpPr bwMode="auto">
-        <a:xfrm>
-          <a:off x="0" y="0"/>
-          <a:ext cx="0" cy="0"/>
-          <a:chOff x="0" y="0"/>
-          <a:chExt cx="0" cy="0"/>
-        </a:xfrm>
-      </p:grpSpPr>
-      <p:pic>
-        <p:nvPicPr>
-          <p:cNvPr id="282108636" name=""/>
-          <p:cNvPicPr>
-            <a:picLocks noChangeAspect="1"/>
-          </p:cNvPicPr>
-          <p:nvPr/>
-        </p:nvPicPr>
-        <p:blipFill rotWithShape="1">
-          <a:blip r:embed="rId3"/>
-          <a:stretch/>
-        </p:blipFill>
-        <p:spPr bwMode="auto">
-          <a:xfrm flipH="0" flipV="0">
-            <a:off x="257174" y="133868"/>
-            <a:ext cx="11517674" cy="6590260"/>
-          </a:xfrm>
-          <a:prstGeom prst="rect">
-            <a:avLst/>
-          </a:prstGeom>
-        </p:spPr>
-      </p:pic>
-    </p:spTree>
-  </p:cSld>
-  <p:clrMapOvr>
-    <a:masterClrMapping/>
-  </p:clrMapOvr>
-  <mc:AlternateContent xmlns:mc="http://schemas.openxmlformats.org/markup-compatibility/2006">
-    <mc:Choice xmlns:p159="http://schemas.microsoft.com/office/powerpoint/2015/09/main" xmlns:p14="http://schemas.microsoft.com/office/powerpoint/2010/main" Requires="p159">
-      <p:transition p14:dur="500" advClick="1"/>
-    </mc:Choice>
-    <mc:Fallback>
-      <p:transition advClick="1"/>
-    </mc:Fallback>
-  </mc:AlternateContent>
-</p:sld>
-</file>
-
 <file path=ppt/slides/slide2.xml><?xml version="1.0" encoding="utf-8"?>
 <p:sld xmlns:a="http://schemas.openxmlformats.org/drawingml/2006/main" xmlns:r="http://schemas.openxmlformats.org/officeDocument/2006/relationships" xmlns:p="http://schemas.openxmlformats.org/presentationml/2006/main" xmlns:m="http://schemas.openxmlformats.org/officeDocument/2006/math" xmlns:w="http://schemas.openxmlformats.org/wordprocessingml/2006/main" xmlns:mc="http://schemas.openxmlformats.org/markup-compatibility/2006" showMasterPhAnim="0" showMasterSp="1" show="1">
   <p:cSld name="">
@@ -11024,7 +10731,7 @@
       </p:grpSpPr>
       <p:grpSp>
         <p:nvGrpSpPr>
-          <p:cNvPr id="1515719815" name=""/>
+          <p:cNvPr id="1300829403" name=""/>
           <p:cNvGrpSpPr/>
           <p:nvPr/>
         </p:nvGrpSpPr>
@@ -11128,7 +10835,7 @@
       </p:grpSp>
       <p:sp>
         <p:nvSpPr>
-          <p:cNvPr id="1960519743" name=""/>
+          <p:cNvPr id="655461926" name=""/>
           <p:cNvSpPr txBox="1"/>
           <p:nvPr/>
         </p:nvSpPr>
@@ -11160,7 +10867,7 @@
       </p:sp>
       <p:sp>
         <p:nvSpPr>
-          <p:cNvPr id="1304143772" name=""/>
+          <p:cNvPr id="2140520989" name=""/>
           <p:cNvSpPr txBox="1"/>
           <p:nvPr/>
         </p:nvSpPr>
@@ -11192,7 +10899,7 @@
       </p:sp>
       <p:grpSp>
         <p:nvGrpSpPr>
-          <p:cNvPr id="982068016" name=""/>
+          <p:cNvPr id="793193433" name=""/>
           <p:cNvGrpSpPr/>
           <p:nvPr/>
         </p:nvGrpSpPr>
@@ -12887,7 +12594,7 @@
       </p:grpSpPr>
       <p:grpSp>
         <p:nvGrpSpPr>
-          <p:cNvPr id="1685640904" name=""/>
+          <p:cNvPr id="308144386" name=""/>
           <p:cNvGrpSpPr/>
           <p:nvPr/>
         </p:nvGrpSpPr>
@@ -13570,7 +13277,7 @@
       </p:grpSp>
       <p:sp>
         <p:nvSpPr>
-          <p:cNvPr id="1942736226" name=""/>
+          <p:cNvPr id="402557225" name=""/>
           <p:cNvSpPr txBox="1"/>
           <p:nvPr/>
         </p:nvSpPr>
@@ -13602,7 +13309,7 @@
       </p:sp>
       <p:grpSp>
         <p:nvGrpSpPr>
-          <p:cNvPr id="1867789809" name=""/>
+          <p:cNvPr id="628693984" name=""/>
           <p:cNvGrpSpPr/>
           <p:nvPr/>
         </p:nvGrpSpPr>
@@ -18062,7 +17769,7 @@
       </p:grpSp>
       <p:grpSp>
         <p:nvGrpSpPr>
-          <p:cNvPr id="549890142" name=""/>
+          <p:cNvPr id="1144310930" name=""/>
           <p:cNvGrpSpPr/>
           <p:nvPr/>
         </p:nvGrpSpPr>
@@ -18162,7 +17869,7 @@
       </p:grpSp>
       <p:grpSp>
         <p:nvGrpSpPr>
-          <p:cNvPr id="442777548" name=""/>
+          <p:cNvPr id="1524654918" name=""/>
           <p:cNvGrpSpPr/>
           <p:nvPr/>
         </p:nvGrpSpPr>
@@ -18283,7 +17990,7 @@
       </p:grpSp>
       <p:grpSp>
         <p:nvGrpSpPr>
-          <p:cNvPr id="1215089433" name=""/>
+          <p:cNvPr id="1726386834" name=""/>
           <p:cNvGrpSpPr/>
           <p:nvPr/>
         </p:nvGrpSpPr>
@@ -18383,7 +18090,7 @@
       </p:grpSp>
       <p:grpSp>
         <p:nvGrpSpPr>
-          <p:cNvPr id="1021583387" name=""/>
+          <p:cNvPr id="1712868132" name=""/>
           <p:cNvGrpSpPr/>
           <p:nvPr/>
         </p:nvGrpSpPr>
@@ -22849,7 +22556,7 @@
       </p:grpSpPr>
       <p:sp>
         <p:nvSpPr>
-          <p:cNvPr id="324187687" name=""/>
+          <p:cNvPr id="479925220" name=""/>
           <p:cNvSpPr txBox="1"/>
           <p:nvPr/>
         </p:nvSpPr>
@@ -22885,7 +22592,7 @@
       </p:sp>
       <p:grpSp>
         <p:nvGrpSpPr>
-          <p:cNvPr id="329405681" name=""/>
+          <p:cNvPr id="295023531" name=""/>
           <p:cNvGrpSpPr/>
           <p:nvPr/>
         </p:nvGrpSpPr>
@@ -27340,7 +27047,7 @@
       </p:grpSpPr>
       <p:sp>
         <p:nvSpPr>
-          <p:cNvPr id="1465201444" name="Title 1"/>
+          <p:cNvPr id="611040321" name="Title 1"/>
           <p:cNvSpPr>
             <a:spLocks noGrp="1"/>
           </p:cNvSpPr>
@@ -27371,7 +27078,7 @@
       </p:sp>
       <p:grpSp>
         <p:nvGrpSpPr>
-          <p:cNvPr id="1187473576" name=""/>
+          <p:cNvPr id="1560016957" name=""/>
           <p:cNvGrpSpPr/>
           <p:nvPr/>
         </p:nvGrpSpPr>
@@ -32587,7 +32294,7 @@
       </p:grpSp>
       <p:grpSp>
         <p:nvGrpSpPr>
-          <p:cNvPr id="1722820836" name=""/>
+          <p:cNvPr id="886245875" name=""/>
           <p:cNvGrpSpPr/>
           <p:nvPr/>
         </p:nvGrpSpPr>
@@ -36570,7 +36277,7 @@
       </p:grpSp>
       <p:grpSp>
         <p:nvGrpSpPr>
-          <p:cNvPr id="392250882" name=""/>
+          <p:cNvPr id="1770787412" name=""/>
           <p:cNvGrpSpPr/>
           <p:nvPr/>
         </p:nvGrpSpPr>
@@ -41048,7 +40755,7 @@
       </p:grpSpPr>
       <p:sp>
         <p:nvSpPr>
-          <p:cNvPr id="374948954" name=""/>
+          <p:cNvPr id="1439335853" name=""/>
           <p:cNvSpPr txBox="1"/>
           <p:nvPr/>
         </p:nvSpPr>
@@ -41087,7 +40794,7 @@
       </p:sp>
       <p:sp>
         <p:nvSpPr>
-          <p:cNvPr id="1350222359" name=""/>
+          <p:cNvPr id="1152344237" name=""/>
           <p:cNvSpPr txBox="1"/>
           <p:nvPr/>
         </p:nvSpPr>
@@ -41152,7 +40859,7 @@
       </p:grpSpPr>
       <p:grpSp>
         <p:nvGrpSpPr>
-          <p:cNvPr id="641083646" name=""/>
+          <p:cNvPr id="966098489" name=""/>
           <p:cNvGrpSpPr/>
           <p:nvPr/>
         </p:nvGrpSpPr>
@@ -42067,7 +41774,7 @@
       </p:grpSp>
       <p:sp>
         <p:nvSpPr>
-          <p:cNvPr id="469188280" name=""/>
+          <p:cNvPr id="421662770" name=""/>
           <p:cNvSpPr txBox="1"/>
           <p:nvPr/>
         </p:nvSpPr>
@@ -42151,7 +41858,7 @@
       </p:grpSpPr>
       <p:sp>
         <p:nvSpPr>
-          <p:cNvPr id="2027129552" name=""/>
+          <p:cNvPr id="1053807433" name=""/>
           <p:cNvSpPr txBox="1"/>
           <p:nvPr/>
         </p:nvSpPr>
@@ -42183,7 +41890,7 @@
       </p:sp>
       <p:grpSp>
         <p:nvGrpSpPr>
-          <p:cNvPr id="1236361349" name=""/>
+          <p:cNvPr id="1190919582" name=""/>
           <p:cNvGrpSpPr/>
           <p:nvPr/>
         </p:nvGrpSpPr>
@@ -43979,7 +43686,7 @@
       </p:grpSpPr>
       <p:sp>
         <p:nvSpPr>
-          <p:cNvPr id="1259363541" name=""/>
+          <p:cNvPr id="956553955" name=""/>
           <p:cNvSpPr txBox="1"/>
           <p:nvPr/>
         </p:nvSpPr>
@@ -44011,7 +43718,7 @@
       </p:sp>
       <p:grpSp>
         <p:nvGrpSpPr>
-          <p:cNvPr id="1287412571" name=""/>
+          <p:cNvPr id="1518597930" name=""/>
           <p:cNvGrpSpPr/>
           <p:nvPr/>
         </p:nvGrpSpPr>

</xml_diff>

<commit_message>
chore: reorganize all figures in proper folders
</commit_message>
<xml_diff>
--- a/thesis/figures/design-doc/design_sheet.pptx
+++ b/thesis/figures/design-doc/design_sheet.pptx
@@ -144,7 +144,7 @@
       </p:grpSpPr>
       <p:sp>
         <p:nvSpPr>
-          <p:cNvPr id="242525026" name="Header Placeholder 1"/>
+          <p:cNvPr id="745157988" name="Header Placeholder 1"/>
           <p:cNvSpPr>
             <a:spLocks noGrp="1"/>
           </p:cNvSpPr>
@@ -178,7 +178,7 @@
       </p:sp>
       <p:sp>
         <p:nvSpPr>
-          <p:cNvPr id="339299227" name="Date Placeholder 2"/>
+          <p:cNvPr id="1634728886" name="Date Placeholder 2"/>
           <p:cNvSpPr>
             <a:spLocks noGrp="1"/>
           </p:cNvSpPr>
@@ -216,7 +216,7 @@
       </p:sp>
       <p:sp>
         <p:nvSpPr>
-          <p:cNvPr id="662585447" name="Slide Image Placeholder 3"/>
+          <p:cNvPr id="429478728" name="Slide Image Placeholder 3"/>
           <p:cNvSpPr>
             <a:spLocks noChangeAspect="1" noGrp="1" noRot="1"/>
           </p:cNvSpPr>
@@ -252,7 +252,7 @@
       </p:sp>
       <p:sp>
         <p:nvSpPr>
-          <p:cNvPr id="1680219969" name="Notes Placeholder 4"/>
+          <p:cNvPr id="1215077332" name="Notes Placeholder 4"/>
           <p:cNvSpPr>
             <a:spLocks noGrp="1"/>
           </p:cNvSpPr>
@@ -326,7 +326,7 @@
       </p:sp>
       <p:sp>
         <p:nvSpPr>
-          <p:cNvPr id="848093800" name="Footer Placeholder 5"/>
+          <p:cNvPr id="1448536345" name="Footer Placeholder 5"/>
           <p:cNvSpPr>
             <a:spLocks noGrp="1"/>
           </p:cNvSpPr>
@@ -360,7 +360,7 @@
       </p:sp>
       <p:sp>
         <p:nvSpPr>
-          <p:cNvPr id="237869761" name="Slide Number Placeholder 6"/>
+          <p:cNvPr id="587060117" name="Slide Number Placeholder 6"/>
           <p:cNvSpPr>
             <a:spLocks noGrp="1"/>
           </p:cNvSpPr>
@@ -513,7 +513,7 @@
       </p:grpSpPr>
       <p:sp>
         <p:nvSpPr>
-          <p:cNvPr id="806050207" name="Slide Image Placeholder 1"/>
+          <p:cNvPr id="157807144" name="Slide Image Placeholder 1"/>
           <p:cNvSpPr>
             <a:spLocks noChangeAspect="1" noGrp="1" noRot="1"/>
           </p:cNvSpPr>
@@ -525,7 +525,7 @@
       </p:sp>
       <p:sp>
         <p:nvSpPr>
-          <p:cNvPr id="444048143" name="Notes Placeholder 2"/>
+          <p:cNvPr id="2143130942" name="Notes Placeholder 2"/>
           <p:cNvSpPr>
             <a:spLocks noGrp="1"/>
           </p:cNvSpPr>
@@ -547,7 +547,7 @@
       </p:sp>
       <p:sp>
         <p:nvSpPr>
-          <p:cNvPr id="1805363114" name="Slide Number Placeholder 3"/>
+          <p:cNvPr id="355924774" name="Slide Number Placeholder 3"/>
           <p:cNvSpPr>
             <a:spLocks noGrp="1"/>
           </p:cNvSpPr>
@@ -598,7 +598,7 @@
       </p:grpSpPr>
       <p:sp>
         <p:nvSpPr>
-          <p:cNvPr id="206829158" name="Slide Image Placeholder 1"/>
+          <p:cNvPr id="1081307341" name="Slide Image Placeholder 1"/>
           <p:cNvSpPr>
             <a:spLocks noChangeAspect="1" noGrp="1" noRot="1"/>
           </p:cNvSpPr>
@@ -610,7 +610,7 @@
       </p:sp>
       <p:sp>
         <p:nvSpPr>
-          <p:cNvPr id="251580563" name="Notes Placeholder 2"/>
+          <p:cNvPr id="565026017" name="Notes Placeholder 2"/>
           <p:cNvSpPr>
             <a:spLocks noGrp="1"/>
           </p:cNvSpPr>
@@ -632,7 +632,7 @@
       </p:sp>
       <p:sp>
         <p:nvSpPr>
-          <p:cNvPr id="796381878" name="Slide Number Placeholder 3"/>
+          <p:cNvPr id="1105204660" name="Slide Number Placeholder 3"/>
           <p:cNvSpPr>
             <a:spLocks noGrp="1"/>
           </p:cNvSpPr>
@@ -683,7 +683,7 @@
       </p:grpSpPr>
       <p:sp>
         <p:nvSpPr>
-          <p:cNvPr id="1456743905" name="Slide Image Placeholder 1"/>
+          <p:cNvPr id="205451129" name="Slide Image Placeholder 1"/>
           <p:cNvSpPr>
             <a:spLocks noChangeAspect="1" noGrp="1" noRot="1"/>
           </p:cNvSpPr>
@@ -695,7 +695,7 @@
       </p:sp>
       <p:sp>
         <p:nvSpPr>
-          <p:cNvPr id="542740182" name="Notes Placeholder 2"/>
+          <p:cNvPr id="1196995200" name="Notes Placeholder 2"/>
           <p:cNvSpPr>
             <a:spLocks noGrp="1"/>
           </p:cNvSpPr>
@@ -717,7 +717,7 @@
       </p:sp>
       <p:sp>
         <p:nvSpPr>
-          <p:cNvPr id="1373515709" name="Slide Number Placeholder 3"/>
+          <p:cNvPr id="910326534" name="Slide Number Placeholder 3"/>
           <p:cNvSpPr>
             <a:spLocks noGrp="1"/>
           </p:cNvSpPr>
@@ -768,7 +768,7 @@
       </p:grpSpPr>
       <p:sp>
         <p:nvSpPr>
-          <p:cNvPr id="338941716" name="Slide Image Placeholder 1"/>
+          <p:cNvPr id="84983245" name="Slide Image Placeholder 1"/>
           <p:cNvSpPr>
             <a:spLocks noChangeAspect="1" noGrp="1" noRot="1"/>
           </p:cNvSpPr>
@@ -785,7 +785,7 @@
       </p:sp>
       <p:sp>
         <p:nvSpPr>
-          <p:cNvPr id="1319207048" name="Notes Placeholder 2"/>
+          <p:cNvPr id="1923954819" name="Notes Placeholder 2"/>
           <p:cNvSpPr>
             <a:spLocks noGrp="1"/>
           </p:cNvSpPr>
@@ -810,7 +810,7 @@
       </p:sp>
       <p:sp>
         <p:nvSpPr>
-          <p:cNvPr id="297688104" name="Slide Number Placeholder 3"/>
+          <p:cNvPr id="524746742" name="Slide Number Placeholder 3"/>
           <p:cNvSpPr>
             <a:spLocks noGrp="1"/>
           </p:cNvSpPr>
@@ -861,7 +861,7 @@
       </p:grpSpPr>
       <p:sp>
         <p:nvSpPr>
-          <p:cNvPr id="905070558" name="Slide Image Placeholder 1"/>
+          <p:cNvPr id="29683934" name="Slide Image Placeholder 1"/>
           <p:cNvSpPr>
             <a:spLocks noChangeAspect="1" noGrp="1" noRot="1"/>
           </p:cNvSpPr>
@@ -873,7 +873,7 @@
       </p:sp>
       <p:sp>
         <p:nvSpPr>
-          <p:cNvPr id="1762841550" name="Notes Placeholder 2"/>
+          <p:cNvPr id="1540084142" name="Notes Placeholder 2"/>
           <p:cNvSpPr>
             <a:spLocks noGrp="1"/>
           </p:cNvSpPr>
@@ -895,7 +895,7 @@
       </p:sp>
       <p:sp>
         <p:nvSpPr>
-          <p:cNvPr id="1048858222" name="Slide Number Placeholder 3"/>
+          <p:cNvPr id="78584991" name="Slide Number Placeholder 3"/>
           <p:cNvSpPr>
             <a:spLocks noGrp="1"/>
           </p:cNvSpPr>
@@ -946,7 +946,7 @@
       </p:grpSpPr>
       <p:sp>
         <p:nvSpPr>
-          <p:cNvPr id="334873153" name="Slide Image Placeholder 1"/>
+          <p:cNvPr id="1680428133" name="Slide Image Placeholder 1"/>
           <p:cNvSpPr>
             <a:spLocks noChangeAspect="1" noGrp="1" noRot="1"/>
           </p:cNvSpPr>
@@ -958,7 +958,7 @@
       </p:sp>
       <p:sp>
         <p:nvSpPr>
-          <p:cNvPr id="309443021" name="Notes Placeholder 2"/>
+          <p:cNvPr id="653202770" name="Notes Placeholder 2"/>
           <p:cNvSpPr>
             <a:spLocks noGrp="1"/>
           </p:cNvSpPr>
@@ -980,7 +980,7 @@
       </p:sp>
       <p:sp>
         <p:nvSpPr>
-          <p:cNvPr id="2120264221" name="Slide Number Placeholder 3"/>
+          <p:cNvPr id="1894478261" name="Slide Number Placeholder 3"/>
           <p:cNvSpPr>
             <a:spLocks noGrp="1"/>
           </p:cNvSpPr>
@@ -1031,7 +1031,7 @@
       </p:grpSpPr>
       <p:sp>
         <p:nvSpPr>
-          <p:cNvPr id="1323508414" name="Slide Image Placeholder 1"/>
+          <p:cNvPr id="953983248" name="Slide Image Placeholder 1"/>
           <p:cNvSpPr>
             <a:spLocks noChangeAspect="1" noGrp="1" noRot="1"/>
           </p:cNvSpPr>
@@ -1043,7 +1043,7 @@
       </p:sp>
       <p:sp>
         <p:nvSpPr>
-          <p:cNvPr id="1999467061" name="Notes Placeholder 2"/>
+          <p:cNvPr id="672397186" name="Notes Placeholder 2"/>
           <p:cNvSpPr>
             <a:spLocks noGrp="1"/>
           </p:cNvSpPr>
@@ -1065,7 +1065,7 @@
       </p:sp>
       <p:sp>
         <p:nvSpPr>
-          <p:cNvPr id="904644954" name="Slide Number Placeholder 3"/>
+          <p:cNvPr id="12277989" name="Slide Number Placeholder 3"/>
           <p:cNvSpPr>
             <a:spLocks noGrp="1"/>
           </p:cNvSpPr>
@@ -1116,7 +1116,7 @@
       </p:grpSpPr>
       <p:sp>
         <p:nvSpPr>
-          <p:cNvPr id="1264386909" name="Slide Image Placeholder 1"/>
+          <p:cNvPr id="900663953" name="Slide Image Placeholder 1"/>
           <p:cNvSpPr>
             <a:spLocks noChangeAspect="1" noGrp="1" noRot="1"/>
           </p:cNvSpPr>
@@ -1128,7 +1128,7 @@
       </p:sp>
       <p:sp>
         <p:nvSpPr>
-          <p:cNvPr id="567319186" name="Notes Placeholder 2"/>
+          <p:cNvPr id="1066681815" name="Notes Placeholder 2"/>
           <p:cNvSpPr>
             <a:spLocks noGrp="1"/>
           </p:cNvSpPr>
@@ -1150,7 +1150,7 @@
       </p:sp>
       <p:sp>
         <p:nvSpPr>
-          <p:cNvPr id="137638838" name="Slide Number Placeholder 3"/>
+          <p:cNvPr id="1707470399" name="Slide Number Placeholder 3"/>
           <p:cNvSpPr>
             <a:spLocks noGrp="1"/>
           </p:cNvSpPr>
@@ -1201,7 +1201,7 @@
       </p:grpSpPr>
       <p:sp>
         <p:nvSpPr>
-          <p:cNvPr id="1360615962" name="Slide Image Placeholder 1"/>
+          <p:cNvPr id="1911051969" name="Slide Image Placeholder 1"/>
           <p:cNvSpPr>
             <a:spLocks noChangeAspect="1" noGrp="1" noRot="1"/>
           </p:cNvSpPr>
@@ -1218,7 +1218,7 @@
       </p:sp>
       <p:sp>
         <p:nvSpPr>
-          <p:cNvPr id="2086722912" name="Notes Placeholder 2"/>
+          <p:cNvPr id="2129689857" name="Notes Placeholder 2"/>
           <p:cNvSpPr>
             <a:spLocks noGrp="1"/>
           </p:cNvSpPr>
@@ -1243,7 +1243,7 @@
       </p:sp>
       <p:sp>
         <p:nvSpPr>
-          <p:cNvPr id="171436960" name="Slide Number Placeholder 3"/>
+          <p:cNvPr id="1730153798" name="Slide Number Placeholder 3"/>
           <p:cNvSpPr>
             <a:spLocks noGrp="1"/>
           </p:cNvSpPr>
@@ -1294,7 +1294,7 @@
       </p:grpSpPr>
       <p:sp>
         <p:nvSpPr>
-          <p:cNvPr id="528784184" name="Slide Image Placeholder 1"/>
+          <p:cNvPr id="1867574392" name="Slide Image Placeholder 1"/>
           <p:cNvSpPr>
             <a:spLocks noChangeAspect="1" noGrp="1" noRot="1"/>
           </p:cNvSpPr>
@@ -1311,7 +1311,7 @@
       </p:sp>
       <p:sp>
         <p:nvSpPr>
-          <p:cNvPr id="1639206760" name="Notes Placeholder 2"/>
+          <p:cNvPr id="1243770025" name="Notes Placeholder 2"/>
           <p:cNvSpPr>
             <a:spLocks noGrp="1"/>
           </p:cNvSpPr>
@@ -1336,7 +1336,7 @@
       </p:sp>
       <p:sp>
         <p:nvSpPr>
-          <p:cNvPr id="243665319" name="Slide Number Placeholder 3"/>
+          <p:cNvPr id="922364593" name="Slide Number Placeholder 3"/>
           <p:cNvSpPr>
             <a:spLocks noGrp="1"/>
           </p:cNvSpPr>
@@ -1387,7 +1387,7 @@
       </p:grpSpPr>
       <p:sp>
         <p:nvSpPr>
-          <p:cNvPr id="1999109334" name="Slide Image Placeholder 1"/>
+          <p:cNvPr id="1631182501" name="Slide Image Placeholder 1"/>
           <p:cNvSpPr>
             <a:spLocks noChangeAspect="1" noGrp="1" noRot="1"/>
           </p:cNvSpPr>
@@ -1399,7 +1399,7 @@
       </p:sp>
       <p:sp>
         <p:nvSpPr>
-          <p:cNvPr id="2085803209" name="Notes Placeholder 2"/>
+          <p:cNvPr id="1082390941" name="Notes Placeholder 2"/>
           <p:cNvSpPr>
             <a:spLocks noGrp="1"/>
           </p:cNvSpPr>
@@ -1421,7 +1421,7 @@
       </p:sp>
       <p:sp>
         <p:nvSpPr>
-          <p:cNvPr id="539841633" name="Slide Number Placeholder 3"/>
+          <p:cNvPr id="517914471" name="Slide Number Placeholder 3"/>
           <p:cNvSpPr>
             <a:spLocks noGrp="1"/>
           </p:cNvSpPr>
@@ -1472,7 +1472,7 @@
       </p:grpSpPr>
       <p:sp>
         <p:nvSpPr>
-          <p:cNvPr id="1942701461" name="Title 1"/>
+          <p:cNvPr id="592888786" name="Title 1"/>
           <p:cNvSpPr>
             <a:spLocks noGrp="1"/>
           </p:cNvSpPr>
@@ -1507,7 +1507,7 @@
       </p:sp>
       <p:sp>
         <p:nvSpPr>
-          <p:cNvPr id="1478871097" name="Subtitle 2"/>
+          <p:cNvPr id="1005704295" name="Subtitle 2"/>
           <p:cNvSpPr>
             <a:spLocks noGrp="1"/>
           </p:cNvSpPr>
@@ -1575,7 +1575,7 @@
       </p:sp>
       <p:sp>
         <p:nvSpPr>
-          <p:cNvPr id="275103995" name="Date Placeholder 3"/>
+          <p:cNvPr id="1711505272" name="Date Placeholder 3"/>
           <p:cNvSpPr>
             <a:spLocks noGrp="1"/>
           </p:cNvSpPr>
@@ -1601,7 +1601,7 @@
       </p:sp>
       <p:sp>
         <p:nvSpPr>
-          <p:cNvPr id="829274542" name="Footer Placeholder 4"/>
+          <p:cNvPr id="1592002526" name="Footer Placeholder 4"/>
           <p:cNvSpPr>
             <a:spLocks noGrp="1"/>
           </p:cNvSpPr>
@@ -1623,7 +1623,7 @@
       </p:sp>
       <p:sp>
         <p:nvSpPr>
-          <p:cNvPr id="1283860535" name="Slide Number Placeholder 5"/>
+          <p:cNvPr id="1493722351" name="Slide Number Placeholder 5"/>
           <p:cNvSpPr>
             <a:spLocks noGrp="1"/>
           </p:cNvSpPr>
@@ -1674,7 +1674,7 @@
       </p:grpSpPr>
       <p:sp>
         <p:nvSpPr>
-          <p:cNvPr id="1465010205" name="Title 1"/>
+          <p:cNvPr id="956856310" name="Title 1"/>
           <p:cNvSpPr>
             <a:spLocks noGrp="1"/>
           </p:cNvSpPr>
@@ -1700,7 +1700,7 @@
       </p:sp>
       <p:sp>
         <p:nvSpPr>
-          <p:cNvPr id="857435940" name="Vertical Text Placeholder 2"/>
+          <p:cNvPr id="1461947107" name="Vertical Text Placeholder 2"/>
           <p:cNvSpPr>
             <a:spLocks noGrp="1"/>
           </p:cNvSpPr>
@@ -1766,7 +1766,7 @@
       </p:sp>
       <p:sp>
         <p:nvSpPr>
-          <p:cNvPr id="244446161" name="Date Placeholder 3"/>
+          <p:cNvPr id="959637880" name="Date Placeholder 3"/>
           <p:cNvSpPr>
             <a:spLocks noGrp="1"/>
           </p:cNvSpPr>
@@ -1792,7 +1792,7 @@
       </p:sp>
       <p:sp>
         <p:nvSpPr>
-          <p:cNvPr id="484209624" name="Footer Placeholder 4"/>
+          <p:cNvPr id="2063679347" name="Footer Placeholder 4"/>
           <p:cNvSpPr>
             <a:spLocks noGrp="1"/>
           </p:cNvSpPr>
@@ -1814,7 +1814,7 @@
       </p:sp>
       <p:sp>
         <p:nvSpPr>
-          <p:cNvPr id="1788500921" name="Slide Number Placeholder 5"/>
+          <p:cNvPr id="1104028917" name="Slide Number Placeholder 5"/>
           <p:cNvSpPr>
             <a:spLocks noGrp="1"/>
           </p:cNvSpPr>
@@ -1865,7 +1865,7 @@
       </p:grpSpPr>
       <p:sp>
         <p:nvSpPr>
-          <p:cNvPr id="365132060" name="Vertical Title 1"/>
+          <p:cNvPr id="937122190" name="Vertical Title 1"/>
           <p:cNvSpPr>
             <a:spLocks noGrp="1"/>
           </p:cNvSpPr>
@@ -1896,7 +1896,7 @@
       </p:sp>
       <p:sp>
         <p:nvSpPr>
-          <p:cNvPr id="1866563866" name="Vertical Text Placeholder 2"/>
+          <p:cNvPr id="1780341717" name="Vertical Text Placeholder 2"/>
           <p:cNvSpPr>
             <a:spLocks noGrp="1"/>
           </p:cNvSpPr>
@@ -1967,7 +1967,7 @@
       </p:sp>
       <p:sp>
         <p:nvSpPr>
-          <p:cNvPr id="2128042035" name="Date Placeholder 3"/>
+          <p:cNvPr id="1683080832" name="Date Placeholder 3"/>
           <p:cNvSpPr>
             <a:spLocks noGrp="1"/>
           </p:cNvSpPr>
@@ -1993,7 +1993,7 @@
       </p:sp>
       <p:sp>
         <p:nvSpPr>
-          <p:cNvPr id="235769871" name="Footer Placeholder 4"/>
+          <p:cNvPr id="785901174" name="Footer Placeholder 4"/>
           <p:cNvSpPr>
             <a:spLocks noGrp="1"/>
           </p:cNvSpPr>
@@ -2015,7 +2015,7 @@
       </p:sp>
       <p:sp>
         <p:nvSpPr>
-          <p:cNvPr id="1183524710" name="Slide Number Placeholder 5"/>
+          <p:cNvPr id="1292400245" name="Slide Number Placeholder 5"/>
           <p:cNvSpPr>
             <a:spLocks noGrp="1"/>
           </p:cNvSpPr>
@@ -2066,7 +2066,7 @@
       </p:grpSpPr>
       <p:sp>
         <p:nvSpPr>
-          <p:cNvPr id="724847494" name="Title 1"/>
+          <p:cNvPr id="570541031" name="Title 1"/>
           <p:cNvSpPr>
             <a:spLocks noGrp="1"/>
           </p:cNvSpPr>
@@ -2092,7 +2092,7 @@
       </p:sp>
       <p:sp>
         <p:nvSpPr>
-          <p:cNvPr id="2066636675" name="Content Placeholder 2"/>
+          <p:cNvPr id="2066325849" name="Content Placeholder 2"/>
           <p:cNvSpPr>
             <a:spLocks noGrp="1"/>
           </p:cNvSpPr>
@@ -2158,7 +2158,7 @@
       </p:sp>
       <p:sp>
         <p:nvSpPr>
-          <p:cNvPr id="1028177447" name="Date Placeholder 3"/>
+          <p:cNvPr id="701999868" name="Date Placeholder 3"/>
           <p:cNvSpPr>
             <a:spLocks noGrp="1"/>
           </p:cNvSpPr>
@@ -2184,7 +2184,7 @@
       </p:sp>
       <p:sp>
         <p:nvSpPr>
-          <p:cNvPr id="1029286317" name="Footer Placeholder 4"/>
+          <p:cNvPr id="2081941188" name="Footer Placeholder 4"/>
           <p:cNvSpPr>
             <a:spLocks noGrp="1"/>
           </p:cNvSpPr>
@@ -2206,7 +2206,7 @@
       </p:sp>
       <p:sp>
         <p:nvSpPr>
-          <p:cNvPr id="256533868" name="Slide Number Placeholder 5"/>
+          <p:cNvPr id="290212087" name="Slide Number Placeholder 5"/>
           <p:cNvSpPr>
             <a:spLocks noGrp="1"/>
           </p:cNvSpPr>
@@ -2257,7 +2257,7 @@
       </p:grpSpPr>
       <p:sp>
         <p:nvSpPr>
-          <p:cNvPr id="1749976915" name="Title 1"/>
+          <p:cNvPr id="1354087386" name="Title 1"/>
           <p:cNvSpPr>
             <a:spLocks noGrp="1"/>
           </p:cNvSpPr>
@@ -2292,7 +2292,7 @@
       </p:sp>
       <p:sp>
         <p:nvSpPr>
-          <p:cNvPr id="1665480431" name="Text Placeholder 2"/>
+          <p:cNvPr id="1266631928" name="Text Placeholder 2"/>
           <p:cNvSpPr>
             <a:spLocks noGrp="1"/>
           </p:cNvSpPr>
@@ -2414,7 +2414,7 @@
       </p:sp>
       <p:sp>
         <p:nvSpPr>
-          <p:cNvPr id="858004028" name="Date Placeholder 3"/>
+          <p:cNvPr id="10808801" name="Date Placeholder 3"/>
           <p:cNvSpPr>
             <a:spLocks noGrp="1"/>
           </p:cNvSpPr>
@@ -2440,7 +2440,7 @@
       </p:sp>
       <p:sp>
         <p:nvSpPr>
-          <p:cNvPr id="901535260" name="Footer Placeholder 4"/>
+          <p:cNvPr id="748902014" name="Footer Placeholder 4"/>
           <p:cNvSpPr>
             <a:spLocks noGrp="1"/>
           </p:cNvSpPr>
@@ -2462,7 +2462,7 @@
       </p:sp>
       <p:sp>
         <p:nvSpPr>
-          <p:cNvPr id="1336738004" name="Slide Number Placeholder 5"/>
+          <p:cNvPr id="1709290803" name="Slide Number Placeholder 5"/>
           <p:cNvSpPr>
             <a:spLocks noGrp="1"/>
           </p:cNvSpPr>
@@ -2513,7 +2513,7 @@
       </p:grpSpPr>
       <p:sp>
         <p:nvSpPr>
-          <p:cNvPr id="1119583293" name="Title 1"/>
+          <p:cNvPr id="1676693902" name="Title 1"/>
           <p:cNvSpPr>
             <a:spLocks noGrp="1"/>
           </p:cNvSpPr>
@@ -2539,7 +2539,7 @@
       </p:sp>
       <p:sp>
         <p:nvSpPr>
-          <p:cNvPr id="761649499" name="Content Placeholder 2"/>
+          <p:cNvPr id="291876557" name="Content Placeholder 2"/>
           <p:cNvSpPr>
             <a:spLocks noGrp="1"/>
           </p:cNvSpPr>
@@ -2610,7 +2610,7 @@
       </p:sp>
       <p:sp>
         <p:nvSpPr>
-          <p:cNvPr id="533089565" name="Content Placeholder 3"/>
+          <p:cNvPr id="251188385" name="Content Placeholder 3"/>
           <p:cNvSpPr>
             <a:spLocks noGrp="1"/>
           </p:cNvSpPr>
@@ -2681,7 +2681,7 @@
       </p:sp>
       <p:sp>
         <p:nvSpPr>
-          <p:cNvPr id="2116268663" name="Date Placeholder 4"/>
+          <p:cNvPr id="64156340" name="Date Placeholder 4"/>
           <p:cNvSpPr>
             <a:spLocks noGrp="1"/>
           </p:cNvSpPr>
@@ -2707,7 +2707,7 @@
       </p:sp>
       <p:sp>
         <p:nvSpPr>
-          <p:cNvPr id="1514277338" name="Footer Placeholder 5"/>
+          <p:cNvPr id="1351680299" name="Footer Placeholder 5"/>
           <p:cNvSpPr>
             <a:spLocks noGrp="1"/>
           </p:cNvSpPr>
@@ -2729,7 +2729,7 @@
       </p:sp>
       <p:sp>
         <p:nvSpPr>
-          <p:cNvPr id="211045917" name="Slide Number Placeholder 6"/>
+          <p:cNvPr id="1197588645" name="Slide Number Placeholder 6"/>
           <p:cNvSpPr>
             <a:spLocks noGrp="1"/>
           </p:cNvSpPr>
@@ -2780,7 +2780,7 @@
       </p:grpSpPr>
       <p:sp>
         <p:nvSpPr>
-          <p:cNvPr id="1030582901" name="Title 1"/>
+          <p:cNvPr id="1471850792" name="Title 1"/>
           <p:cNvSpPr>
             <a:spLocks noGrp="1"/>
           </p:cNvSpPr>
@@ -2811,7 +2811,7 @@
       </p:sp>
       <p:sp>
         <p:nvSpPr>
-          <p:cNvPr id="2077752060" name="Text Placeholder 2"/>
+          <p:cNvPr id="1473162878" name="Text Placeholder 2"/>
           <p:cNvSpPr>
             <a:spLocks noGrp="1"/>
           </p:cNvSpPr>
@@ -2879,7 +2879,7 @@
       </p:sp>
       <p:sp>
         <p:nvSpPr>
-          <p:cNvPr id="948142480" name="Content Placeholder 3"/>
+          <p:cNvPr id="40620510" name="Content Placeholder 3"/>
           <p:cNvSpPr>
             <a:spLocks noGrp="1"/>
           </p:cNvSpPr>
@@ -2950,7 +2950,7 @@
       </p:sp>
       <p:sp>
         <p:nvSpPr>
-          <p:cNvPr id="599644607" name="Text Placeholder 4"/>
+          <p:cNvPr id="609149856" name="Text Placeholder 4"/>
           <p:cNvSpPr>
             <a:spLocks noGrp="1"/>
           </p:cNvSpPr>
@@ -3018,7 +3018,7 @@
       </p:sp>
       <p:sp>
         <p:nvSpPr>
-          <p:cNvPr id="132612307" name="Content Placeholder 5"/>
+          <p:cNvPr id="288081846" name="Content Placeholder 5"/>
           <p:cNvSpPr>
             <a:spLocks noGrp="1"/>
           </p:cNvSpPr>
@@ -3089,7 +3089,7 @@
       </p:sp>
       <p:sp>
         <p:nvSpPr>
-          <p:cNvPr id="1062456643" name="Date Placeholder 6"/>
+          <p:cNvPr id="1735525091" name="Date Placeholder 6"/>
           <p:cNvSpPr>
             <a:spLocks noGrp="1"/>
           </p:cNvSpPr>
@@ -3115,7 +3115,7 @@
       </p:sp>
       <p:sp>
         <p:nvSpPr>
-          <p:cNvPr id="1662108307" name="Footer Placeholder 7"/>
+          <p:cNvPr id="1064821437" name="Footer Placeholder 7"/>
           <p:cNvSpPr>
             <a:spLocks noGrp="1"/>
           </p:cNvSpPr>
@@ -3137,7 +3137,7 @@
       </p:sp>
       <p:sp>
         <p:nvSpPr>
-          <p:cNvPr id="1772239346" name="Slide Number Placeholder 8"/>
+          <p:cNvPr id="507640282" name="Slide Number Placeholder 8"/>
           <p:cNvSpPr>
             <a:spLocks noGrp="1"/>
           </p:cNvSpPr>
@@ -3188,7 +3188,7 @@
       </p:grpSpPr>
       <p:sp>
         <p:nvSpPr>
-          <p:cNvPr id="357632522" name="Title 1"/>
+          <p:cNvPr id="2034218380" name="Title 1"/>
           <p:cNvSpPr>
             <a:spLocks noGrp="1"/>
           </p:cNvSpPr>
@@ -3214,7 +3214,7 @@
       </p:sp>
       <p:sp>
         <p:nvSpPr>
-          <p:cNvPr id="1147440525" name="Date Placeholder 2"/>
+          <p:cNvPr id="604039831" name="Date Placeholder 2"/>
           <p:cNvSpPr>
             <a:spLocks noGrp="1"/>
           </p:cNvSpPr>
@@ -3240,7 +3240,7 @@
       </p:sp>
       <p:sp>
         <p:nvSpPr>
-          <p:cNvPr id="105034028" name="Footer Placeholder 3"/>
+          <p:cNvPr id="1599923175" name="Footer Placeholder 3"/>
           <p:cNvSpPr>
             <a:spLocks noGrp="1"/>
           </p:cNvSpPr>
@@ -3262,7 +3262,7 @@
       </p:sp>
       <p:sp>
         <p:nvSpPr>
-          <p:cNvPr id="1978172466" name="Slide Number Placeholder 4"/>
+          <p:cNvPr id="1072210186" name="Slide Number Placeholder 4"/>
           <p:cNvSpPr>
             <a:spLocks noGrp="1"/>
           </p:cNvSpPr>
@@ -3313,7 +3313,7 @@
       </p:grpSpPr>
       <p:sp>
         <p:nvSpPr>
-          <p:cNvPr id="1285117397" name="Date Placeholder 1"/>
+          <p:cNvPr id="1894577440" name="Date Placeholder 1"/>
           <p:cNvSpPr>
             <a:spLocks noGrp="1"/>
           </p:cNvSpPr>
@@ -3339,7 +3339,7 @@
       </p:sp>
       <p:sp>
         <p:nvSpPr>
-          <p:cNvPr id="1003290803" name="Footer Placeholder 2"/>
+          <p:cNvPr id="1167405486" name="Footer Placeholder 2"/>
           <p:cNvSpPr>
             <a:spLocks noGrp="1"/>
           </p:cNvSpPr>
@@ -3361,7 +3361,7 @@
       </p:sp>
       <p:sp>
         <p:nvSpPr>
-          <p:cNvPr id="681029555" name="Slide Number Placeholder 3"/>
+          <p:cNvPr id="470916519" name="Slide Number Placeholder 3"/>
           <p:cNvSpPr>
             <a:spLocks noGrp="1"/>
           </p:cNvSpPr>
@@ -3412,7 +3412,7 @@
       </p:grpSpPr>
       <p:sp>
         <p:nvSpPr>
-          <p:cNvPr id="678158066" name="Title 1"/>
+          <p:cNvPr id="1746297236" name="Title 1"/>
           <p:cNvSpPr>
             <a:spLocks noGrp="1"/>
           </p:cNvSpPr>
@@ -3447,7 +3447,7 @@
       </p:sp>
       <p:sp>
         <p:nvSpPr>
-          <p:cNvPr id="128251859" name="Content Placeholder 2"/>
+          <p:cNvPr id="918516433" name="Content Placeholder 2"/>
           <p:cNvSpPr>
             <a:spLocks noGrp="1"/>
           </p:cNvSpPr>
@@ -3546,7 +3546,7 @@
       </p:sp>
       <p:sp>
         <p:nvSpPr>
-          <p:cNvPr id="1105983992" name="Text Placeholder 3"/>
+          <p:cNvPr id="569442034" name="Text Placeholder 3"/>
           <p:cNvSpPr>
             <a:spLocks noGrp="1"/>
           </p:cNvSpPr>
@@ -3614,7 +3614,7 @@
       </p:sp>
       <p:sp>
         <p:nvSpPr>
-          <p:cNvPr id="64823584" name="Date Placeholder 4"/>
+          <p:cNvPr id="233412386" name="Date Placeholder 4"/>
           <p:cNvSpPr>
             <a:spLocks noGrp="1"/>
           </p:cNvSpPr>
@@ -3640,7 +3640,7 @@
       </p:sp>
       <p:sp>
         <p:nvSpPr>
-          <p:cNvPr id="592535369" name="Footer Placeholder 5"/>
+          <p:cNvPr id="470842525" name="Footer Placeholder 5"/>
           <p:cNvSpPr>
             <a:spLocks noGrp="1"/>
           </p:cNvSpPr>
@@ -3662,7 +3662,7 @@
       </p:sp>
       <p:sp>
         <p:nvSpPr>
-          <p:cNvPr id="1042266541" name="Slide Number Placeholder 6"/>
+          <p:cNvPr id="1794939163" name="Slide Number Placeholder 6"/>
           <p:cNvSpPr>
             <a:spLocks noGrp="1"/>
           </p:cNvSpPr>
@@ -3713,7 +3713,7 @@
       </p:grpSpPr>
       <p:sp>
         <p:nvSpPr>
-          <p:cNvPr id="713659903" name="Title 1"/>
+          <p:cNvPr id="1067701135" name="Title 1"/>
           <p:cNvSpPr>
             <a:spLocks noGrp="1"/>
           </p:cNvSpPr>
@@ -3748,7 +3748,7 @@
       </p:sp>
       <p:sp>
         <p:nvSpPr>
-          <p:cNvPr id="989521794" name="Picture Placeholder 2"/>
+          <p:cNvPr id="1832904442" name="Picture Placeholder 2"/>
           <p:cNvSpPr>
             <a:spLocks noChangeAspect="1" noGrp="1"/>
           </p:cNvSpPr>
@@ -3816,7 +3816,7 @@
       </p:sp>
       <p:sp>
         <p:nvSpPr>
-          <p:cNvPr id="1548188623" name="Text Placeholder 3"/>
+          <p:cNvPr id="2138620326" name="Text Placeholder 3"/>
           <p:cNvSpPr>
             <a:spLocks noGrp="1"/>
           </p:cNvSpPr>
@@ -3884,7 +3884,7 @@
       </p:sp>
       <p:sp>
         <p:nvSpPr>
-          <p:cNvPr id="1574371352" name="Date Placeholder 4"/>
+          <p:cNvPr id="1398743545" name="Date Placeholder 4"/>
           <p:cNvSpPr>
             <a:spLocks noGrp="1"/>
           </p:cNvSpPr>
@@ -3910,7 +3910,7 @@
       </p:sp>
       <p:sp>
         <p:nvSpPr>
-          <p:cNvPr id="1970673107" name="Footer Placeholder 5"/>
+          <p:cNvPr id="708888256" name="Footer Placeholder 5"/>
           <p:cNvSpPr>
             <a:spLocks noGrp="1"/>
           </p:cNvSpPr>
@@ -3932,7 +3932,7 @@
       </p:sp>
       <p:sp>
         <p:nvSpPr>
-          <p:cNvPr id="698852093" name="Slide Number Placeholder 6"/>
+          <p:cNvPr id="816261282" name="Slide Number Placeholder 6"/>
           <p:cNvSpPr>
             <a:spLocks noGrp="1"/>
           </p:cNvSpPr>
@@ -3988,7 +3988,7 @@
       </p:grpSpPr>
       <p:sp>
         <p:nvSpPr>
-          <p:cNvPr id="194607695" name="Title Placeholder 1"/>
+          <p:cNvPr id="1494072016" name="Title Placeholder 1"/>
           <p:cNvSpPr>
             <a:spLocks noGrp="1"/>
           </p:cNvSpPr>
@@ -4024,7 +4024,7 @@
       </p:sp>
       <p:sp>
         <p:nvSpPr>
-          <p:cNvPr id="2113473307" name="Text Placeholder 2"/>
+          <p:cNvPr id="324280743" name="Text Placeholder 2"/>
           <p:cNvSpPr>
             <a:spLocks noGrp="1"/>
           </p:cNvSpPr>
@@ -4100,7 +4100,7 @@
       </p:sp>
       <p:sp>
         <p:nvSpPr>
-          <p:cNvPr id="68179684" name="Date Placeholder 3"/>
+          <p:cNvPr id="1346120550" name="Date Placeholder 3"/>
           <p:cNvSpPr>
             <a:spLocks noGrp="1"/>
           </p:cNvSpPr>
@@ -4144,7 +4144,7 @@
       </p:sp>
       <p:sp>
         <p:nvSpPr>
-          <p:cNvPr id="2104009947" name="Footer Placeholder 4"/>
+          <p:cNvPr id="1346467942" name="Footer Placeholder 4"/>
           <p:cNvSpPr>
             <a:spLocks noGrp="1"/>
           </p:cNvSpPr>
@@ -4184,7 +4184,7 @@
       </p:sp>
       <p:sp>
         <p:nvSpPr>
-          <p:cNvPr id="370844935" name="Slide Number Placeholder 5"/>
+          <p:cNvPr id="378675503" name="Slide Number Placeholder 5"/>
           <p:cNvSpPr>
             <a:spLocks noGrp="1"/>
           </p:cNvSpPr>
@@ -4544,7 +4544,7 @@
       </p:grpSpPr>
       <p:sp>
         <p:nvSpPr>
-          <p:cNvPr id="1055204318" name="Title 1"/>
+          <p:cNvPr id="897108315" name="Title 1"/>
           <p:cNvSpPr>
             <a:spLocks noGrp="1"/>
           </p:cNvSpPr>
@@ -4570,13 +4570,13 @@
       </p:sp>
       <p:sp>
         <p:nvSpPr>
-          <p:cNvPr id="2038736794" name=""/>
+          <p:cNvPr id="904575039" name=""/>
           <p:cNvSpPr txBox="1"/>
           <p:nvPr/>
         </p:nvSpPr>
         <p:spPr bwMode="auto">
           <a:xfrm rot="0" flipH="0" flipV="0">
-            <a:off x="4516799" y="2114550"/>
+            <a:off x="6898048" y="447674"/>
             <a:ext cx="3237449" cy="640440"/>
           </a:xfrm>
           <a:prstGeom prst="rect">
@@ -4602,14 +4602,14 @@
       </p:sp>
       <p:sp>
         <p:nvSpPr>
-          <p:cNvPr id="1526532383" name=""/>
+          <p:cNvPr id="1606057476" name=""/>
           <p:cNvSpPr txBox="1"/>
           <p:nvPr/>
         </p:nvSpPr>
         <p:spPr bwMode="auto">
           <a:xfrm rot="0" flipH="0" flipV="0">
-            <a:off x="3848625" y="3524249"/>
-            <a:ext cx="3564494" cy="1463400"/>
+            <a:off x="569711" y="6139228"/>
+            <a:ext cx="5164443" cy="366119"/>
           </a:xfrm>
           <a:prstGeom prst="rect">
             <a:avLst/>
@@ -4625,13 +4625,1551 @@
               <a:defRPr/>
             </a:pPr>
             <a:r>
-              <a:rPr lang="fr-FR" sz="9000"/>
-              <a:t>TODO</a:t>
+              <a:rPr lang="fr-FR"/>
+              <a:t>performs entanglement swapping if successful</a:t>
             </a:r>
-            <a:endParaRPr sz="9000"/>
+            <a:endParaRPr/>
           </a:p>
         </p:txBody>
       </p:sp>
+      <p:grpSp>
+        <p:nvGrpSpPr>
+          <p:cNvPr id="1379054466" name=""/>
+          <p:cNvGrpSpPr/>
+          <p:nvPr/>
+        </p:nvGrpSpPr>
+        <p:grpSpPr bwMode="auto">
+          <a:xfrm>
+            <a:off x="3962781" y="2709412"/>
+            <a:ext cx="4539384" cy="3238569"/>
+            <a:chOff x="0" y="0"/>
+            <a:chExt cx="4539384" cy="3238569"/>
+          </a:xfrm>
+        </p:grpSpPr>
+        <p:cxnSp>
+          <p:nvCxnSpPr>
+            <p:cNvPr id="836709337" name=""/>
+            <p:cNvCxnSpPr/>
+            <p:nvPr/>
+          </p:nvCxnSpPr>
+          <p:spPr bwMode="auto">
+            <a:xfrm rot="10800000" flipH="0" flipV="0">
+              <a:off x="1769344" y="1667412"/>
+              <a:ext cx="1015143" cy="0"/>
+            </a:xfrm>
+            <a:prstGeom prst="line">
+              <a:avLst/>
+            </a:prstGeom>
+            <a:ln w="38100" cap="flat" cmpd="sng" algn="ctr">
+              <a:solidFill>
+                <a:schemeClr val="tx1"/>
+              </a:solidFill>
+              <a:prstDash val="solid"/>
+              <a:miter lim="800000"/>
+            </a:ln>
+          </p:spPr>
+          <p:style>
+            <a:lnRef idx="1">
+              <a:schemeClr val="accent1">
+                <a:shade val="50000"/>
+              </a:schemeClr>
+            </a:lnRef>
+            <a:fillRef idx="0">
+              <a:schemeClr val="accent1"/>
+            </a:fillRef>
+            <a:effectRef idx="0">
+              <a:schemeClr val="accent1"/>
+            </a:effectRef>
+            <a:fontRef idx="minor">
+              <a:schemeClr val="tx1"/>
+            </a:fontRef>
+          </p:style>
+        </p:cxnSp>
+        <p:grpSp>
+          <p:nvGrpSpPr>
+            <p:cNvPr id="2024767374" name=""/>
+            <p:cNvGrpSpPr/>
+            <p:nvPr/>
+          </p:nvGrpSpPr>
+          <p:grpSpPr bwMode="auto">
+            <a:xfrm rot="0" flipH="0" flipV="0">
+              <a:off x="1224405" y="646337"/>
+              <a:ext cx="833436" cy="2591870"/>
+              <a:chOff x="0" y="0"/>
+              <a:chExt cx="833436" cy="2591870"/>
+            </a:xfrm>
+          </p:grpSpPr>
+          <p:sp>
+            <p:nvSpPr>
+              <p:cNvPr id="86948411" name=""/>
+              <p:cNvSpPr/>
+              <p:nvPr/>
+            </p:nvSpPr>
+            <p:spPr bwMode="auto">
+              <a:xfrm rot="0" flipH="0" flipV="0">
+                <a:off x="288496" y="892672"/>
+                <a:ext cx="256442" cy="256442"/>
+              </a:xfrm>
+              <a:prstGeom prst="ellipse">
+                <a:avLst/>
+              </a:prstGeom>
+              <a:solidFill>
+                <a:schemeClr val="tx1"/>
+              </a:solidFill>
+              <a:ln w="12700" cap="flat" cmpd="sng" algn="ctr">
+                <a:solidFill>
+                  <a:schemeClr val="tx1"/>
+                </a:solidFill>
+                <a:prstDash val="solid"/>
+                <a:miter lim="800000"/>
+              </a:ln>
+            </p:spPr>
+            <p:style>
+              <a:lnRef idx="2">
+                <a:schemeClr val="accent1">
+                  <a:shade val="50000"/>
+                </a:schemeClr>
+              </a:lnRef>
+              <a:fillRef idx="1">
+                <a:schemeClr val="accent1"/>
+              </a:fillRef>
+              <a:effectRef idx="0">
+                <a:schemeClr val="accent1"/>
+              </a:effectRef>
+              <a:fontRef idx="minor">
+                <a:schemeClr val="lt1"/>
+              </a:fontRef>
+            </p:style>
+          </p:sp>
+          <p:cxnSp>
+            <p:nvCxnSpPr>
+              <p:cNvPr id="423907023" name=""/>
+              <p:cNvCxnSpPr>
+                <a:stCxn id="944509448" idx="0"/>
+                <a:endCxn id="86948411" idx="0"/>
+              </p:cNvCxnSpPr>
+              <p:nvPr/>
+            </p:nvCxnSpPr>
+            <p:spPr bwMode="auto">
+              <a:xfrm rot="5400000" flipH="0" flipV="1">
+                <a:off x="-36842" y="446336"/>
+                <a:ext cx="892672" cy="0"/>
+              </a:xfrm>
+              <a:prstGeom prst="line">
+                <a:avLst/>
+              </a:prstGeom>
+              <a:ln w="38100" cap="flat" cmpd="sng" algn="ctr">
+                <a:solidFill>
+                  <a:schemeClr val="tx1"/>
+                </a:solidFill>
+                <a:prstDash val="solid"/>
+                <a:miter lim="800000"/>
+              </a:ln>
+            </p:spPr>
+            <p:style>
+              <a:lnRef idx="1">
+                <a:schemeClr val="accent1">
+                  <a:shade val="50000"/>
+                </a:schemeClr>
+              </a:lnRef>
+              <a:fillRef idx="0">
+                <a:schemeClr val="accent1"/>
+              </a:fillRef>
+              <a:effectRef idx="0">
+                <a:schemeClr val="accent1"/>
+              </a:effectRef>
+              <a:fontRef idx="minor">
+                <a:schemeClr val="tx1"/>
+              </a:fontRef>
+            </p:style>
+          </p:cxnSp>
+          <p:cxnSp>
+            <p:nvCxnSpPr>
+              <p:cNvPr id="1537336436" name=""/>
+              <p:cNvCxnSpPr>
+                <a:stCxn id="778977024" idx="0"/>
+                <a:endCxn id="86948411" idx="4"/>
+              </p:cNvCxnSpPr>
+              <p:nvPr/>
+            </p:nvCxnSpPr>
+            <p:spPr bwMode="auto">
+              <a:xfrm rot="16199998" flipH="0" flipV="0">
+                <a:off x="40620" y="1525212"/>
+                <a:ext cx="752194" cy="0"/>
+              </a:xfrm>
+              <a:prstGeom prst="line">
+                <a:avLst/>
+              </a:prstGeom>
+              <a:ln w="38100" cap="flat" cmpd="sng" algn="ctr">
+                <a:solidFill>
+                  <a:schemeClr val="tx1"/>
+                </a:solidFill>
+                <a:prstDash val="solid"/>
+                <a:miter lim="800000"/>
+              </a:ln>
+            </p:spPr>
+            <p:style>
+              <a:lnRef idx="1">
+                <a:schemeClr val="accent1">
+                  <a:shade val="50000"/>
+                </a:schemeClr>
+              </a:lnRef>
+              <a:fillRef idx="0">
+                <a:schemeClr val="accent1"/>
+              </a:fillRef>
+              <a:effectRef idx="0">
+                <a:schemeClr val="accent1"/>
+              </a:effectRef>
+              <a:fontRef idx="minor">
+                <a:schemeClr val="tx1"/>
+              </a:fontRef>
+            </p:style>
+          </p:cxnSp>
+          <p:grpSp>
+            <p:nvGrpSpPr>
+              <p:cNvPr id="768490672" name=""/>
+              <p:cNvGrpSpPr/>
+              <p:nvPr/>
+            </p:nvGrpSpPr>
+            <p:grpSpPr bwMode="auto">
+              <a:xfrm>
+                <a:off x="0" y="1901308"/>
+                <a:ext cx="833436" cy="690561"/>
+                <a:chOff x="0" y="0"/>
+                <a:chExt cx="833436" cy="690561"/>
+              </a:xfrm>
+            </p:grpSpPr>
+            <p:sp>
+              <p:nvSpPr>
+                <p:cNvPr id="1095452921" name=""/>
+                <p:cNvSpPr txBox="1"/>
+                <p:nvPr/>
+              </p:nvSpPr>
+              <p:spPr bwMode="auto">
+                <a:xfrm rot="0" flipH="0" flipV="0">
+                  <a:off x="79568" y="101260"/>
+                  <a:ext cx="674299" cy="488039"/>
+                </a:xfrm>
+                <a:prstGeom prst="rect">
+                  <a:avLst/>
+                </a:prstGeom>
+                <a:noFill/>
+              </p:spPr>
+              <p:txBody>
+                <a:bodyPr vertOverflow="overflow" horzOverflow="overflow" vert="horz" wrap="square" lIns="91440" tIns="45720" rIns="91440" bIns="45720" numCol="1" spcCol="0" rtlCol="0" fromWordArt="0" anchor="t" anchorCtr="0" forceAA="0" upright="0" compatLnSpc="0">
+                  <a:spAutoFit/>
+                </a:bodyPr>
+                <a:p>
+                  <a:pPr algn="ctr">
+                    <a:defRPr/>
+                  </a:pPr>
+                  <mc:AlternateContent xmlns:mc="http://schemas.openxmlformats.org/markup-compatibility/2006" xmlns:m="http://schemas.openxmlformats.org/officeDocument/2006/math">
+                    <mc:Choice xmlns:a14="http://schemas.microsoft.com/office/drawing/2010/main" Requires="a14">
+                      <a14:m>
+                        <m:oMathPara>
+                          <m:oMathParaPr/>
+                          <m:oMath>
+                            <m:sSub>
+                              <m:sSubPr>
+                                <m:ctrlPr>
+                                  <a:rPr lang="fr-FR" sz="2600" b="1" i="1" u="none" strike="noStrike" cap="none" spc="0">
+                                    <a:solidFill>
+                                      <a:schemeClr val="tx1"/>
+                                    </a:solidFill>
+                                    <a:latin typeface="Cambria Math"/>
+                                    <a:ea typeface="Cambria Math"/>
+                                    <a:cs typeface="Cambria Math"/>
+                                  </a:rPr>
+                                </m:ctrlPr>
+                              </m:sSubPr>
+                              <m:e>
+                                <m:r>
+                                  <m:rPr>
+                                    <m:sty m:val="bi"/>
+                                  </m:rPr>
+                                  <a:rPr lang="fr-FR" sz="2600" u="none" strike="noStrike" cap="none" spc="0">
+                                    <a:solidFill>
+                                      <a:schemeClr val="tx1"/>
+                                    </a:solidFill>
+                                    <a:latin typeface="Cambria Math"/>
+                                    <a:ea typeface="Cambria Math"/>
+                                    <a:cs typeface="Cambria Math"/>
+                                  </a:rPr>
+                                  <m:t>M</m:t>
+                                </m:r>
+                              </m:e>
+                              <m:sub>
+                                <m:r>
+                                  <m:rPr>
+                                    <m:sty m:val="bi"/>
+                                  </m:rPr>
+                                  <a:rPr lang="fr-FR" sz="2600" u="none" strike="noStrike" cap="none" spc="0">
+                                    <a:solidFill>
+                                      <a:schemeClr val="tx1"/>
+                                    </a:solidFill>
+                                    <a:latin typeface="Cambria Math"/>
+                                    <a:ea typeface="Cambria Math"/>
+                                    <a:cs typeface="Cambria Math"/>
+                                  </a:rPr>
+                                  <m:t>X</m:t>
+                                </m:r>
+                              </m:sub>
+                            </m:sSub>
+                          </m:oMath>
+                        </m:oMathPara>
+                      </a14:m>
+                    </mc:Choice>
+                    <mc:Fallback/>
+                  </mc:AlternateContent>
+                  <a:endParaRPr sz="2600" b="1">
+                    <a:latin typeface="CMU Serif"/>
+                    <a:cs typeface="CMU Serif"/>
+                  </a:endParaRPr>
+                </a:p>
+              </p:txBody>
+            </p:sp>
+            <p:sp>
+              <p:nvSpPr>
+                <p:cNvPr id="778977024" name=""/>
+                <p:cNvSpPr/>
+                <p:nvPr/>
+              </p:nvSpPr>
+              <p:spPr bwMode="auto">
+                <a:xfrm rot="0" flipH="0" flipV="0">
+                  <a:off x="0" y="0"/>
+                  <a:ext cx="833437" cy="690562"/>
+                </a:xfrm>
+                <a:prstGeom prst="rect">
+                  <a:avLst/>
+                </a:prstGeom>
+                <a:noFill/>
+                <a:ln w="28575" cap="flat" cmpd="sng" algn="ctr">
+                  <a:solidFill>
+                    <a:schemeClr val="tx1"/>
+                  </a:solidFill>
+                  <a:prstDash val="solid"/>
+                  <a:miter lim="800000"/>
+                </a:ln>
+              </p:spPr>
+              <p:style>
+                <a:lnRef idx="2">
+                  <a:schemeClr val="accent1">
+                    <a:shade val="50000"/>
+                  </a:schemeClr>
+                </a:lnRef>
+                <a:fillRef idx="1">
+                  <a:schemeClr val="accent1"/>
+                </a:fillRef>
+                <a:effectRef idx="0">
+                  <a:schemeClr val="accent1"/>
+                </a:effectRef>
+                <a:fontRef idx="minor">
+                  <a:schemeClr val="lt1"/>
+                </a:fontRef>
+              </p:style>
+            </p:sp>
+          </p:grpSp>
+        </p:grpSp>
+        <p:sp>
+          <p:nvSpPr>
+            <p:cNvPr id="218570844" name=""/>
+            <p:cNvSpPr/>
+            <p:nvPr/>
+          </p:nvSpPr>
+          <p:spPr bwMode="auto">
+            <a:xfrm rot="0" flipH="0" flipV="0">
+              <a:off x="2784487" y="1539370"/>
+              <a:ext cx="256441" cy="256441"/>
+            </a:xfrm>
+            <a:prstGeom prst="ellipse">
+              <a:avLst/>
+            </a:prstGeom>
+            <a:solidFill>
+              <a:schemeClr val="tx1"/>
+            </a:solidFill>
+            <a:ln w="12700" cap="flat" cmpd="sng" algn="ctr">
+              <a:solidFill>
+                <a:schemeClr val="tx1"/>
+              </a:solidFill>
+              <a:prstDash val="solid"/>
+              <a:miter lim="800000"/>
+            </a:ln>
+          </p:spPr>
+          <p:style>
+            <a:lnRef idx="2">
+              <a:schemeClr val="accent1">
+                <a:shade val="50000"/>
+              </a:schemeClr>
+            </a:lnRef>
+            <a:fillRef idx="1">
+              <a:schemeClr val="accent1"/>
+            </a:fillRef>
+            <a:effectRef idx="0">
+              <a:schemeClr val="accent1"/>
+            </a:effectRef>
+            <a:fontRef idx="minor">
+              <a:schemeClr val="lt1"/>
+            </a:fontRef>
+          </p:style>
+        </p:sp>
+        <p:cxnSp>
+          <p:nvCxnSpPr>
+            <p:cNvPr id="48137112" name=""/>
+            <p:cNvCxnSpPr>
+              <a:stCxn id="704602629" idx="4"/>
+              <a:endCxn id="218570844" idx="0"/>
+            </p:cNvCxnSpPr>
+            <p:nvPr/>
+          </p:nvCxnSpPr>
+          <p:spPr bwMode="auto">
+            <a:xfrm rot="5400000" flipH="0" flipV="0">
+              <a:off x="2466192" y="1092854"/>
+              <a:ext cx="893032" cy="0"/>
+            </a:xfrm>
+            <a:prstGeom prst="line">
+              <a:avLst/>
+            </a:prstGeom>
+            <a:ln w="38100" cap="flat" cmpd="sng" algn="ctr">
+              <a:solidFill>
+                <a:schemeClr val="tx1"/>
+              </a:solidFill>
+              <a:prstDash val="solid"/>
+              <a:miter lim="800000"/>
+            </a:ln>
+          </p:spPr>
+          <p:style>
+            <a:lnRef idx="1">
+              <a:schemeClr val="accent1">
+                <a:shade val="50000"/>
+              </a:schemeClr>
+            </a:lnRef>
+            <a:fillRef idx="0">
+              <a:schemeClr val="accent1"/>
+            </a:fillRef>
+            <a:effectRef idx="0">
+              <a:schemeClr val="accent1"/>
+            </a:effectRef>
+            <a:fontRef idx="minor">
+              <a:schemeClr val="tx1"/>
+            </a:fontRef>
+          </p:style>
+        </p:cxnSp>
+        <p:cxnSp>
+          <p:nvCxnSpPr>
+            <p:cNvPr id="867181916" name=""/>
+            <p:cNvCxnSpPr/>
+            <p:nvPr/>
+          </p:nvCxnSpPr>
+          <p:spPr bwMode="auto">
+            <a:xfrm rot="16199998" flipH="0" flipV="0">
+              <a:off x="2536611" y="2171909"/>
+              <a:ext cx="752193" cy="0"/>
+            </a:xfrm>
+            <a:prstGeom prst="line">
+              <a:avLst/>
+            </a:prstGeom>
+            <a:ln w="38100" cap="flat" cmpd="sng" algn="ctr">
+              <a:solidFill>
+                <a:schemeClr val="tx1"/>
+              </a:solidFill>
+              <a:prstDash val="solid"/>
+              <a:miter lim="800000"/>
+            </a:ln>
+          </p:spPr>
+          <p:style>
+            <a:lnRef idx="1">
+              <a:schemeClr val="accent1">
+                <a:shade val="50000"/>
+              </a:schemeClr>
+            </a:lnRef>
+            <a:fillRef idx="0">
+              <a:schemeClr val="accent1"/>
+            </a:fillRef>
+            <a:effectRef idx="0">
+              <a:schemeClr val="accent1"/>
+            </a:effectRef>
+            <a:fontRef idx="minor">
+              <a:schemeClr val="tx1"/>
+            </a:fontRef>
+          </p:style>
+        </p:cxnSp>
+        <p:grpSp>
+          <p:nvGrpSpPr>
+            <p:cNvPr id="1338636670" name=""/>
+            <p:cNvGrpSpPr/>
+            <p:nvPr/>
+          </p:nvGrpSpPr>
+          <p:grpSpPr bwMode="auto">
+            <a:xfrm rot="0" flipH="0" flipV="0">
+              <a:off x="2495991" y="2548008"/>
+              <a:ext cx="833436" cy="690561"/>
+              <a:chOff x="0" y="0"/>
+              <a:chExt cx="833436" cy="690561"/>
+            </a:xfrm>
+          </p:grpSpPr>
+          <p:sp>
+            <p:nvSpPr>
+              <p:cNvPr id="607237220" name=""/>
+              <p:cNvSpPr txBox="1"/>
+              <p:nvPr/>
+            </p:nvSpPr>
+            <p:spPr bwMode="auto">
+              <a:xfrm rot="0" flipH="0" flipV="0">
+                <a:off x="79567" y="101259"/>
+                <a:ext cx="674658" cy="488039"/>
+              </a:xfrm>
+              <a:prstGeom prst="rect">
+                <a:avLst/>
+              </a:prstGeom>
+              <a:noFill/>
+            </p:spPr>
+            <p:txBody>
+              <a:bodyPr vertOverflow="overflow" horzOverflow="overflow" vert="horz" wrap="square" lIns="91440" tIns="45720" rIns="91440" bIns="45720" numCol="1" spcCol="0" rtlCol="0" fromWordArt="0" anchor="t" anchorCtr="0" forceAA="0" upright="0" compatLnSpc="0">
+                <a:spAutoFit/>
+              </a:bodyPr>
+              <a:p>
+                <a:pPr algn="ctr">
+                  <a:defRPr/>
+                </a:pPr>
+                <mc:AlternateContent xmlns:mc="http://schemas.openxmlformats.org/markup-compatibility/2006" xmlns:m="http://schemas.openxmlformats.org/officeDocument/2006/math">
+                  <mc:Choice xmlns:a14="http://schemas.microsoft.com/office/drawing/2010/main" Requires="a14">
+                    <a14:m>
+                      <m:oMathPara>
+                        <m:oMathParaPr/>
+                        <m:oMath>
+                          <m:sSub>
+                            <m:sSubPr>
+                              <m:ctrlPr>
+                                <a:rPr lang="fr-FR" sz="2600" b="1" i="1" u="none" strike="noStrike" cap="none" spc="0">
+                                  <a:solidFill>
+                                    <a:schemeClr val="tx1"/>
+                                  </a:solidFill>
+                                  <a:latin typeface="Cambria Math"/>
+                                  <a:ea typeface="Cambria Math"/>
+                                  <a:cs typeface="Cambria Math"/>
+                                </a:rPr>
+                              </m:ctrlPr>
+                            </m:sSubPr>
+                            <m:e>
+                              <m:r>
+                                <m:rPr>
+                                  <m:sty m:val="bi"/>
+                                </m:rPr>
+                                <a:rPr lang="fr-FR" sz="2600" u="none" strike="noStrike" cap="none" spc="0">
+                                  <a:solidFill>
+                                    <a:schemeClr val="tx1"/>
+                                  </a:solidFill>
+                                  <a:latin typeface="Cambria Math"/>
+                                  <a:ea typeface="Cambria Math"/>
+                                  <a:cs typeface="Cambria Math"/>
+                                </a:rPr>
+                                <m:t>M</m:t>
+                              </m:r>
+                            </m:e>
+                            <m:sub>
+                              <m:r>
+                                <m:rPr>
+                                  <m:sty m:val="bi"/>
+                                </m:rPr>
+                                <a:rPr lang="fr-FR" sz="2600" u="none" strike="noStrike" cap="none" spc="0">
+                                  <a:solidFill>
+                                    <a:schemeClr val="tx1"/>
+                                  </a:solidFill>
+                                  <a:latin typeface="Cambria Math"/>
+                                  <a:ea typeface="Cambria Math"/>
+                                  <a:cs typeface="Cambria Math"/>
+                                </a:rPr>
+                                <m:t>X</m:t>
+                              </m:r>
+                            </m:sub>
+                          </m:sSub>
+                        </m:oMath>
+                      </m:oMathPara>
+                    </a14:m>
+                  </mc:Choice>
+                  <mc:Fallback/>
+                </mc:AlternateContent>
+                <a:endParaRPr sz="2600" b="1">
+                  <a:latin typeface="CMU Serif"/>
+                  <a:cs typeface="CMU Serif"/>
+                </a:endParaRPr>
+              </a:p>
+            </p:txBody>
+          </p:sp>
+          <p:sp>
+            <p:nvSpPr>
+              <p:cNvPr id="1123221556" name=""/>
+              <p:cNvSpPr/>
+              <p:nvPr/>
+            </p:nvSpPr>
+            <p:spPr bwMode="auto">
+              <a:xfrm rot="0" flipH="0" flipV="0">
+                <a:off x="0" y="0"/>
+                <a:ext cx="833436" cy="690561"/>
+              </a:xfrm>
+              <a:prstGeom prst="rect">
+                <a:avLst/>
+              </a:prstGeom>
+              <a:noFill/>
+              <a:ln w="28575" cap="flat" cmpd="sng" algn="ctr">
+                <a:solidFill>
+                  <a:schemeClr val="tx1"/>
+                </a:solidFill>
+                <a:prstDash val="solid"/>
+                <a:miter lim="800000"/>
+              </a:ln>
+            </p:spPr>
+            <p:style>
+              <a:lnRef idx="2">
+                <a:schemeClr val="accent1">
+                  <a:shade val="50000"/>
+                </a:schemeClr>
+              </a:lnRef>
+              <a:fillRef idx="1">
+                <a:schemeClr val="accent1"/>
+              </a:fillRef>
+              <a:effectRef idx="0">
+                <a:schemeClr val="accent1"/>
+              </a:effectRef>
+              <a:fontRef idx="minor">
+                <a:schemeClr val="lt1"/>
+              </a:fontRef>
+            </p:style>
+          </p:sp>
+        </p:grpSp>
+        <p:sp>
+          <p:nvSpPr>
+            <p:cNvPr id="1326713168" name=""/>
+            <p:cNvSpPr txBox="1"/>
+            <p:nvPr/>
+          </p:nvSpPr>
+          <p:spPr bwMode="auto">
+            <a:xfrm rot="0" flipH="0" flipV="0">
+              <a:off x="1903188" y="1267341"/>
+              <a:ext cx="678258" cy="488039"/>
+            </a:xfrm>
+            <a:prstGeom prst="rect">
+              <a:avLst/>
+            </a:prstGeom>
+            <a:noFill/>
+          </p:spPr>
+          <p:txBody>
+            <a:bodyPr vertOverflow="overflow" horzOverflow="overflow" vert="horz" wrap="square" lIns="91440" tIns="45720" rIns="91440" bIns="45720" numCol="1" spcCol="0" rtlCol="0" fromWordArt="0" anchor="t" anchorCtr="0" forceAA="0" upright="0" compatLnSpc="0">
+              <a:spAutoFit/>
+            </a:bodyPr>
+            <a:p>
+              <a:pPr algn="ctr">
+                <a:defRPr/>
+              </a:pPr>
+              <mc:AlternateContent xmlns:mc="http://schemas.openxmlformats.org/markup-compatibility/2006" xmlns:m="http://schemas.openxmlformats.org/officeDocument/2006/math">
+                <mc:Choice xmlns:a14="http://schemas.microsoft.com/office/drawing/2010/main" Requires="a14">
+                  <a14:m>
+                    <m:oMathPara>
+                      <m:oMathParaPr/>
+                      <m:oMath>
+                        <m:r>
+                          <m:rPr>
+                            <m:sty m:val="bi"/>
+                          </m:rPr>
+                          <a:rPr lang="fr-FR" sz="2600" u="none" strike="noStrike" cap="none" spc="0">
+                            <a:solidFill>
+                              <a:schemeClr val="tx1"/>
+                            </a:solidFill>
+                            <a:latin typeface="Cambria Math"/>
+                            <a:ea typeface="Cambria Math"/>
+                            <a:cs typeface="Cambria Math"/>
+                          </a:rPr>
+                          <m:t>CZ</m:t>
+                        </m:r>
+                      </m:oMath>
+                    </m:oMathPara>
+                  </a14:m>
+                </mc:Choice>
+                <mc:Fallback/>
+              </mc:AlternateContent>
+              <a:endParaRPr sz="2600" b="1">
+                <a:latin typeface="CMU Serif"/>
+                <a:cs typeface="CMU Serif"/>
+              </a:endParaRPr>
+            </a:p>
+          </p:txBody>
+        </p:sp>
+        <p:sp>
+          <p:nvSpPr>
+            <p:cNvPr id="376638007" name=""/>
+            <p:cNvSpPr/>
+            <p:nvPr/>
+          </p:nvSpPr>
+          <p:spPr bwMode="auto">
+            <a:xfrm rot="0" flipH="0" flipV="0">
+              <a:off x="3893046" y="0"/>
+              <a:ext cx="646337" cy="646337"/>
+            </a:xfrm>
+            <a:prstGeom prst="ellipse">
+              <a:avLst/>
+            </a:prstGeom>
+            <a:solidFill>
+              <a:schemeClr val="bg1"/>
+            </a:solidFill>
+            <a:ln w="44450" cap="flat" cmpd="sng" algn="ctr">
+              <a:solidFill>
+                <a:srgbClr val="000000"/>
+              </a:solidFill>
+              <a:prstDash val="sysDot"/>
+              <a:miter lim="800000"/>
+            </a:ln>
+          </p:spPr>
+          <p:style>
+            <a:lnRef idx="2">
+              <a:schemeClr val="accent1">
+                <a:shade val="50000"/>
+              </a:schemeClr>
+            </a:lnRef>
+            <a:fillRef idx="1">
+              <a:schemeClr val="accent1"/>
+            </a:fillRef>
+            <a:effectRef idx="0">
+              <a:schemeClr val="accent1"/>
+            </a:effectRef>
+            <a:fontRef idx="minor">
+              <a:schemeClr val="lt1"/>
+            </a:fontRef>
+          </p:style>
+        </p:sp>
+        <p:cxnSp>
+          <p:nvCxnSpPr>
+            <p:cNvPr id="1927848401" name=""/>
+            <p:cNvCxnSpPr/>
+            <p:nvPr/>
+          </p:nvCxnSpPr>
+          <p:spPr bwMode="auto">
+            <a:xfrm rot="10800000" flipH="0" flipV="0">
+              <a:off x="3250217" y="323169"/>
+              <a:ext cx="642827" cy="0"/>
+            </a:xfrm>
+            <a:prstGeom prst="line">
+              <a:avLst/>
+            </a:prstGeom>
+            <a:ln w="38100" cap="flat" cmpd="sng" algn="ctr">
+              <a:solidFill>
+                <a:schemeClr val="tx1"/>
+              </a:solidFill>
+              <a:prstDash val="solid"/>
+              <a:miter lim="800000"/>
+            </a:ln>
+          </p:spPr>
+          <p:style>
+            <a:lnRef idx="1">
+              <a:schemeClr val="accent1">
+                <a:shade val="50000"/>
+              </a:schemeClr>
+            </a:lnRef>
+            <a:fillRef idx="0">
+              <a:schemeClr val="accent1"/>
+            </a:fillRef>
+            <a:effectRef idx="0">
+              <a:schemeClr val="accent1"/>
+            </a:effectRef>
+            <a:fontRef idx="minor">
+              <a:schemeClr val="tx1"/>
+            </a:fontRef>
+          </p:style>
+        </p:cxnSp>
+        <p:sp>
+          <p:nvSpPr>
+            <p:cNvPr id="704602629" name=""/>
+            <p:cNvSpPr/>
+            <p:nvPr/>
+          </p:nvSpPr>
+          <p:spPr bwMode="auto">
+            <a:xfrm rot="0" flipH="0" flipV="0">
+              <a:off x="2589540" y="0"/>
+              <a:ext cx="646337" cy="646337"/>
+            </a:xfrm>
+            <a:prstGeom prst="ellipse">
+              <a:avLst/>
+            </a:prstGeom>
+            <a:solidFill>
+              <a:schemeClr val="bg1"/>
+            </a:solidFill>
+            <a:ln w="44450" cap="flat" cmpd="sng" algn="ctr">
+              <a:solidFill>
+                <a:schemeClr val="tx1"/>
+              </a:solidFill>
+              <a:prstDash val="solid"/>
+              <a:miter lim="800000"/>
+            </a:ln>
+          </p:spPr>
+          <p:style>
+            <a:lnRef idx="2">
+              <a:schemeClr val="accent1">
+                <a:shade val="50000"/>
+              </a:schemeClr>
+            </a:lnRef>
+            <a:fillRef idx="1">
+              <a:schemeClr val="accent1"/>
+            </a:fillRef>
+            <a:effectRef idx="0">
+              <a:schemeClr val="accent1"/>
+            </a:effectRef>
+            <a:fontRef idx="minor">
+              <a:schemeClr val="lt1"/>
+            </a:fontRef>
+          </p:style>
+          <p:txBody>
+            <a:bodyPr anchor="ctr"/>
+            <a:p>
+              <a:pPr algn="ctr">
+                <a:defRPr/>
+              </a:pPr>
+              <a:endParaRPr/>
+            </a:p>
+          </p:txBody>
+        </p:sp>
+        <p:grpSp>
+          <p:nvGrpSpPr>
+            <p:cNvPr id="2121156448" name=""/>
+            <p:cNvGrpSpPr/>
+            <p:nvPr/>
+          </p:nvGrpSpPr>
+          <p:grpSpPr bwMode="auto">
+            <a:xfrm rot="10800000">
+              <a:off x="0" y="0"/>
+              <a:ext cx="1949843" cy="646337"/>
+              <a:chOff x="0" y="0"/>
+              <a:chExt cx="1949843" cy="646337"/>
+            </a:xfrm>
+          </p:grpSpPr>
+          <p:sp>
+            <p:nvSpPr>
+              <p:cNvPr id="1231137783" name=""/>
+              <p:cNvSpPr/>
+              <p:nvPr/>
+            </p:nvSpPr>
+            <p:spPr bwMode="auto">
+              <a:xfrm rot="0" flipH="0" flipV="0">
+                <a:off x="1303506" y="0"/>
+                <a:ext cx="646337" cy="646337"/>
+              </a:xfrm>
+              <a:prstGeom prst="ellipse">
+                <a:avLst/>
+              </a:prstGeom>
+              <a:solidFill>
+                <a:schemeClr val="bg1"/>
+              </a:solidFill>
+              <a:ln w="44450" cap="flat" cmpd="sng" algn="ctr">
+                <a:solidFill>
+                  <a:srgbClr val="000000"/>
+                </a:solidFill>
+                <a:prstDash val="sysDot"/>
+                <a:miter lim="800000"/>
+              </a:ln>
+            </p:spPr>
+            <p:style>
+              <a:lnRef idx="2">
+                <a:schemeClr val="accent1">
+                  <a:shade val="50000"/>
+                </a:schemeClr>
+              </a:lnRef>
+              <a:fillRef idx="1">
+                <a:schemeClr val="accent1"/>
+              </a:fillRef>
+              <a:effectRef idx="0">
+                <a:schemeClr val="accent1"/>
+              </a:effectRef>
+              <a:fontRef idx="minor">
+                <a:schemeClr val="lt1"/>
+              </a:fontRef>
+            </p:style>
+          </p:sp>
+          <p:cxnSp>
+            <p:nvCxnSpPr>
+              <p:cNvPr id="1730213150" name=""/>
+              <p:cNvCxnSpPr/>
+              <p:nvPr/>
+            </p:nvCxnSpPr>
+            <p:spPr bwMode="auto">
+              <a:xfrm rot="10800000" flipH="0" flipV="0">
+                <a:off x="660676" y="323169"/>
+                <a:ext cx="642827" cy="0"/>
+              </a:xfrm>
+              <a:prstGeom prst="line">
+                <a:avLst/>
+              </a:prstGeom>
+              <a:ln w="38100" cap="flat" cmpd="sng" algn="ctr">
+                <a:solidFill>
+                  <a:schemeClr val="tx1"/>
+                </a:solidFill>
+                <a:prstDash val="solid"/>
+                <a:miter lim="800000"/>
+              </a:ln>
+            </p:spPr>
+            <p:style>
+              <a:lnRef idx="1">
+                <a:schemeClr val="accent1">
+                  <a:shade val="50000"/>
+                </a:schemeClr>
+              </a:lnRef>
+              <a:fillRef idx="0">
+                <a:schemeClr val="accent1"/>
+              </a:fillRef>
+              <a:effectRef idx="0">
+                <a:schemeClr val="accent1"/>
+              </a:effectRef>
+              <a:fontRef idx="minor">
+                <a:schemeClr val="tx1"/>
+              </a:fontRef>
+            </p:style>
+          </p:cxnSp>
+          <p:sp>
+            <p:nvSpPr>
+              <p:cNvPr id="944509448" name=""/>
+              <p:cNvSpPr/>
+              <p:nvPr/>
+            </p:nvSpPr>
+            <p:spPr bwMode="auto">
+              <a:xfrm rot="0" flipH="0" flipV="0">
+                <a:off x="0" y="0"/>
+                <a:ext cx="646337" cy="646337"/>
+              </a:xfrm>
+              <a:prstGeom prst="ellipse">
+                <a:avLst/>
+              </a:prstGeom>
+              <a:solidFill>
+                <a:schemeClr val="bg1"/>
+              </a:solidFill>
+              <a:ln w="44450" cap="flat" cmpd="sng" algn="ctr">
+                <a:solidFill>
+                  <a:schemeClr val="tx1"/>
+                </a:solidFill>
+                <a:prstDash val="solid"/>
+                <a:miter lim="800000"/>
+              </a:ln>
+            </p:spPr>
+            <p:style>
+              <a:lnRef idx="2">
+                <a:schemeClr val="accent1">
+                  <a:shade val="50000"/>
+                </a:schemeClr>
+              </a:lnRef>
+              <a:fillRef idx="1">
+                <a:schemeClr val="accent1"/>
+              </a:fillRef>
+              <a:effectRef idx="0">
+                <a:schemeClr val="accent1"/>
+              </a:effectRef>
+              <a:fontRef idx="minor">
+                <a:schemeClr val="lt1"/>
+              </a:fontRef>
+            </p:style>
+            <p:txBody>
+              <a:bodyPr anchor="ctr"/>
+              <a:p>
+                <a:pPr algn="ctr">
+                  <a:defRPr/>
+                </a:pPr>
+                <a:endParaRPr/>
+              </a:p>
+            </p:txBody>
+          </p:sp>
+        </p:grpSp>
+      </p:grpSp>
+      <p:grpSp>
+        <p:nvGrpSpPr>
+          <p:cNvPr id="603783711" name=""/>
+          <p:cNvGrpSpPr/>
+          <p:nvPr/>
+        </p:nvGrpSpPr>
+        <p:grpSpPr bwMode="auto">
+          <a:xfrm>
+            <a:off x="275503" y="1822369"/>
+            <a:ext cx="4194557" cy="1475046"/>
+            <a:chOff x="0" y="0"/>
+            <a:chExt cx="4194557" cy="1475046"/>
+          </a:xfrm>
+        </p:grpSpPr>
+        <p:sp>
+          <p:nvSpPr>
+            <p:cNvPr id="68577564" name=""/>
+            <p:cNvSpPr/>
+            <p:nvPr/>
+          </p:nvSpPr>
+          <p:spPr bwMode="auto">
+            <a:xfrm rot="0" flipH="0" flipV="0">
+              <a:off x="1289166" y="115282"/>
+              <a:ext cx="646338" cy="646338"/>
+            </a:xfrm>
+            <a:prstGeom prst="ellipse">
+              <a:avLst/>
+            </a:prstGeom>
+            <a:solidFill>
+              <a:schemeClr val="bg1"/>
+            </a:solidFill>
+            <a:ln w="44450" cap="flat" cmpd="sng" algn="ctr">
+              <a:solidFill>
+                <a:schemeClr val="tx1"/>
+              </a:solidFill>
+              <a:prstDash val="solid"/>
+              <a:miter lim="800000"/>
+            </a:ln>
+          </p:spPr>
+          <p:style>
+            <a:lnRef idx="2">
+              <a:schemeClr val="accent1">
+                <a:shade val="50000"/>
+              </a:schemeClr>
+            </a:lnRef>
+            <a:fillRef idx="1">
+              <a:schemeClr val="accent1"/>
+            </a:fillRef>
+            <a:effectRef idx="0">
+              <a:schemeClr val="accent1"/>
+            </a:effectRef>
+            <a:fontRef idx="minor">
+              <a:schemeClr val="lt1"/>
+            </a:fontRef>
+          </p:style>
+        </p:sp>
+        <p:sp>
+          <p:nvSpPr>
+            <p:cNvPr id="1776524966" name=""/>
+            <p:cNvSpPr/>
+            <p:nvPr/>
+          </p:nvSpPr>
+          <p:spPr bwMode="auto">
+            <a:xfrm rot="0" flipH="0" flipV="0">
+              <a:off x="1136910" y="0"/>
+              <a:ext cx="1898306" cy="863670"/>
+            </a:xfrm>
+            <a:prstGeom prst="flowChartAlternateProcess">
+              <a:avLst/>
+            </a:prstGeom>
+            <a:noFill/>
+            <a:ln w="57150" cap="flat" cmpd="sng" algn="ctr">
+              <a:solidFill>
+                <a:schemeClr val="tx1"/>
+              </a:solidFill>
+              <a:prstDash val="dash"/>
+              <a:miter lim="800000"/>
+            </a:ln>
+          </p:spPr>
+          <p:style>
+            <a:lnRef idx="2">
+              <a:schemeClr val="accent1">
+                <a:shade val="50000"/>
+              </a:schemeClr>
+            </a:lnRef>
+            <a:fillRef idx="1">
+              <a:schemeClr val="accent1"/>
+            </a:fillRef>
+            <a:effectRef idx="0">
+              <a:schemeClr val="accent1"/>
+            </a:effectRef>
+            <a:fontRef idx="minor">
+              <a:schemeClr val="lt1"/>
+            </a:fontRef>
+          </p:style>
+          <p:txBody>
+            <a:bodyPr anchor="ctr"/>
+            <a:p>
+              <a:pPr algn="ctr">
+                <a:defRPr/>
+              </a:pPr>
+              <a:endParaRPr/>
+            </a:p>
+          </p:txBody>
+        </p:sp>
+        <p:sp>
+          <p:nvSpPr>
+            <p:cNvPr id="1946300634" name=""/>
+            <p:cNvSpPr txBox="1"/>
+            <p:nvPr/>
+          </p:nvSpPr>
+          <p:spPr bwMode="auto">
+            <a:xfrm rot="0" flipH="0" flipV="0">
+              <a:off x="1095302" y="987006"/>
+              <a:ext cx="1982964" cy="488039"/>
+            </a:xfrm>
+            <a:prstGeom prst="rect">
+              <a:avLst/>
+            </a:prstGeom>
+            <a:noFill/>
+          </p:spPr>
+          <p:txBody>
+            <a:bodyPr vertOverflow="overflow" horzOverflow="overflow" vert="horz" wrap="square" lIns="91440" tIns="45720" rIns="91440" bIns="45720" numCol="1" spcCol="0" rtlCol="0" fromWordArt="0" anchor="t" anchorCtr="0" forceAA="0" upright="0" compatLnSpc="0">
+              <a:spAutoFit/>
+            </a:bodyPr>
+            <a:p>
+              <a:pPr algn="ctr">
+                <a:defRPr/>
+              </a:pPr>
+              <a:r>
+                <a:rPr lang="fr-FR" sz="2600" b="1">
+                  <a:latin typeface="CMU Serif"/>
+                  <a:ea typeface="CMU Serif"/>
+                  <a:cs typeface="CMU Serif"/>
+                </a:rPr>
+                <a:t>BSM</a:t>
+              </a:r>
+              <a:endParaRPr sz="2600" b="1">
+                <a:latin typeface="CMU Serif"/>
+                <a:cs typeface="CMU Serif"/>
+              </a:endParaRPr>
+            </a:p>
+          </p:txBody>
+        </p:sp>
+        <p:cxnSp>
+          <p:nvCxnSpPr>
+            <p:cNvPr id="219044935" name=""/>
+            <p:cNvCxnSpPr>
+              <a:stCxn id="68577564" idx="2"/>
+              <a:endCxn id="1225843040" idx="6"/>
+            </p:cNvCxnSpPr>
+            <p:nvPr/>
+          </p:nvCxnSpPr>
+          <p:spPr bwMode="auto">
+            <a:xfrm rot="10800000" flipH="0" flipV="0">
+              <a:off x="646337" y="438451"/>
+              <a:ext cx="642828" cy="0"/>
+            </a:xfrm>
+            <a:prstGeom prst="line">
+              <a:avLst/>
+            </a:prstGeom>
+            <a:ln w="38100" cap="flat" cmpd="sng" algn="ctr">
+              <a:solidFill>
+                <a:schemeClr val="tx1"/>
+              </a:solidFill>
+              <a:prstDash val="solid"/>
+              <a:miter lim="800000"/>
+            </a:ln>
+          </p:spPr>
+          <p:style>
+            <a:lnRef idx="1">
+              <a:schemeClr val="accent1">
+                <a:shade val="50000"/>
+              </a:schemeClr>
+            </a:lnRef>
+            <a:fillRef idx="0">
+              <a:schemeClr val="accent1"/>
+            </a:fillRef>
+            <a:effectRef idx="0">
+              <a:schemeClr val="accent1"/>
+            </a:effectRef>
+            <a:fontRef idx="minor">
+              <a:schemeClr val="tx1"/>
+            </a:fontRef>
+          </p:style>
+        </p:cxnSp>
+        <p:sp>
+          <p:nvSpPr>
+            <p:cNvPr id="1225843040" name=""/>
+            <p:cNvSpPr/>
+            <p:nvPr/>
+          </p:nvSpPr>
+          <p:spPr bwMode="auto">
+            <a:xfrm rot="0" flipH="0" flipV="0">
+              <a:off x="0" y="115282"/>
+              <a:ext cx="646338" cy="646338"/>
+            </a:xfrm>
+            <a:prstGeom prst="ellipse">
+              <a:avLst/>
+            </a:prstGeom>
+            <a:solidFill>
+              <a:schemeClr val="bg1"/>
+            </a:solidFill>
+            <a:ln w="44450" cap="flat" cmpd="sng" algn="ctr">
+              <a:solidFill>
+                <a:srgbClr val="000000"/>
+              </a:solidFill>
+              <a:prstDash val="sysDot"/>
+              <a:miter lim="800000"/>
+            </a:ln>
+          </p:spPr>
+          <p:style>
+            <a:lnRef idx="2">
+              <a:schemeClr val="accent1">
+                <a:shade val="50000"/>
+              </a:schemeClr>
+            </a:lnRef>
+            <a:fillRef idx="1">
+              <a:schemeClr val="accent1"/>
+            </a:fillRef>
+            <a:effectRef idx="0">
+              <a:schemeClr val="accent1"/>
+            </a:effectRef>
+            <a:fontRef idx="minor">
+              <a:schemeClr val="lt1"/>
+            </a:fontRef>
+          </p:style>
+          <p:txBody>
+            <a:bodyPr anchor="ctr"/>
+            <a:p>
+              <a:pPr algn="ctr">
+                <a:defRPr/>
+              </a:pPr>
+              <a:endParaRPr/>
+            </a:p>
+          </p:txBody>
+        </p:sp>
+        <p:sp>
+          <p:nvSpPr>
+            <p:cNvPr id="1796922232" name=""/>
+            <p:cNvSpPr/>
+            <p:nvPr/>
+          </p:nvSpPr>
+          <p:spPr bwMode="auto">
+            <a:xfrm rot="0" flipH="0" flipV="0">
+              <a:off x="3548219" y="115282"/>
+              <a:ext cx="646337" cy="646337"/>
+            </a:xfrm>
+            <a:prstGeom prst="ellipse">
+              <a:avLst/>
+            </a:prstGeom>
+            <a:solidFill>
+              <a:schemeClr val="bg1"/>
+            </a:solidFill>
+            <a:ln w="44450" cap="flat" cmpd="sng" algn="ctr">
+              <a:solidFill>
+                <a:srgbClr val="000000"/>
+              </a:solidFill>
+              <a:prstDash val="sysDot"/>
+              <a:miter lim="800000"/>
+            </a:ln>
+          </p:spPr>
+          <p:style>
+            <a:lnRef idx="2">
+              <a:schemeClr val="accent1">
+                <a:shade val="50000"/>
+              </a:schemeClr>
+            </a:lnRef>
+            <a:fillRef idx="1">
+              <a:schemeClr val="accent1"/>
+            </a:fillRef>
+            <a:effectRef idx="0">
+              <a:schemeClr val="accent1"/>
+            </a:effectRef>
+            <a:fontRef idx="minor">
+              <a:schemeClr val="lt1"/>
+            </a:fontRef>
+          </p:style>
+        </p:sp>
+        <p:cxnSp>
+          <p:nvCxnSpPr>
+            <p:cNvPr id="1526055426" name=""/>
+            <p:cNvCxnSpPr/>
+            <p:nvPr/>
+          </p:nvCxnSpPr>
+          <p:spPr bwMode="auto">
+            <a:xfrm rot="10800000" flipH="0" flipV="0">
+              <a:off x="2905390" y="438451"/>
+              <a:ext cx="642828" cy="0"/>
+            </a:xfrm>
+            <a:prstGeom prst="line">
+              <a:avLst/>
+            </a:prstGeom>
+            <a:ln w="38100" cap="flat" cmpd="sng" algn="ctr">
+              <a:solidFill>
+                <a:schemeClr val="tx1"/>
+              </a:solidFill>
+              <a:prstDash val="solid"/>
+              <a:miter lim="800000"/>
+            </a:ln>
+          </p:spPr>
+          <p:style>
+            <a:lnRef idx="1">
+              <a:schemeClr val="accent1">
+                <a:shade val="50000"/>
+              </a:schemeClr>
+            </a:lnRef>
+            <a:fillRef idx="0">
+              <a:schemeClr val="accent1"/>
+            </a:fillRef>
+            <a:effectRef idx="0">
+              <a:schemeClr val="accent1"/>
+            </a:effectRef>
+            <a:fontRef idx="minor">
+              <a:schemeClr val="tx1"/>
+            </a:fontRef>
+          </p:style>
+        </p:cxnSp>
+        <p:sp>
+          <p:nvSpPr>
+            <p:cNvPr id="1716574494" name=""/>
+            <p:cNvSpPr/>
+            <p:nvPr/>
+          </p:nvSpPr>
+          <p:spPr bwMode="auto">
+            <a:xfrm rot="0" flipH="0" flipV="0">
+              <a:off x="2259052" y="115282"/>
+              <a:ext cx="646337" cy="646337"/>
+            </a:xfrm>
+            <a:prstGeom prst="ellipse">
+              <a:avLst/>
+            </a:prstGeom>
+            <a:solidFill>
+              <a:schemeClr val="bg1"/>
+            </a:solidFill>
+            <a:ln w="44450" cap="flat" cmpd="sng" algn="ctr">
+              <a:solidFill>
+                <a:schemeClr val="tx1"/>
+              </a:solidFill>
+              <a:prstDash val="solid"/>
+              <a:miter lim="800000"/>
+            </a:ln>
+          </p:spPr>
+          <p:style>
+            <a:lnRef idx="2">
+              <a:schemeClr val="accent1">
+                <a:shade val="50000"/>
+              </a:schemeClr>
+            </a:lnRef>
+            <a:fillRef idx="1">
+              <a:schemeClr val="accent1"/>
+            </a:fillRef>
+            <a:effectRef idx="0">
+              <a:schemeClr val="accent1"/>
+            </a:effectRef>
+            <a:fontRef idx="minor">
+              <a:schemeClr val="lt1"/>
+            </a:fontRef>
+          </p:style>
+          <p:txBody>
+            <a:bodyPr anchor="ctr"/>
+            <a:p>
+              <a:pPr algn="ctr">
+                <a:defRPr/>
+              </a:pPr>
+              <a:endParaRPr/>
+            </a:p>
+          </p:txBody>
+        </p:sp>
+      </p:grpSp>
+      <p:grpSp>
+        <p:nvGrpSpPr>
+          <p:cNvPr id="25191136" name=""/>
+          <p:cNvGrpSpPr/>
+          <p:nvPr/>
+        </p:nvGrpSpPr>
+        <p:grpSpPr bwMode="auto">
+          <a:xfrm>
+            <a:off x="2415909" y="3971971"/>
+            <a:ext cx="1463752" cy="547233"/>
+            <a:chOff x="0" y="0"/>
+            <a:chExt cx="1463752" cy="547233"/>
+          </a:xfrm>
+        </p:grpSpPr>
+        <p:cxnSp>
+          <p:nvCxnSpPr>
+            <p:cNvPr id="1769987643" name=""/>
+            <p:cNvCxnSpPr/>
+            <p:nvPr/>
+          </p:nvCxnSpPr>
+          <p:spPr bwMode="auto">
+            <a:xfrm rot="0" flipH="0" flipV="0">
+              <a:off x="35074" y="547233"/>
+              <a:ext cx="1428678" cy="0"/>
+            </a:xfrm>
+            <a:prstGeom prst="line">
+              <a:avLst/>
+            </a:prstGeom>
+            <a:ln w="38100" cap="flat" cmpd="sng" algn="ctr">
+              <a:solidFill>
+                <a:srgbClr val="00FF73"/>
+              </a:solidFill>
+              <a:prstDash val="solid"/>
+              <a:miter lim="800000"/>
+              <a:tailEnd type="arrow" len="med"/>
+            </a:ln>
+          </p:spPr>
+          <p:style>
+            <a:lnRef idx="1">
+              <a:schemeClr val="accent1">
+                <a:shade val="50000"/>
+              </a:schemeClr>
+            </a:lnRef>
+            <a:fillRef idx="0">
+              <a:schemeClr val="accent1"/>
+            </a:fillRef>
+            <a:effectRef idx="0">
+              <a:schemeClr val="accent1"/>
+            </a:effectRef>
+            <a:fontRef idx="minor">
+              <a:schemeClr val="tx1"/>
+            </a:fontRef>
+          </p:style>
+        </p:cxnSp>
+        <p:sp>
+          <p:nvSpPr>
+            <p:cNvPr id="559617363" name=""/>
+            <p:cNvSpPr txBox="1"/>
+            <p:nvPr/>
+          </p:nvSpPr>
+          <p:spPr bwMode="auto">
+            <a:xfrm rot="0" flipH="0" flipV="0">
+              <a:off x="0" y="0"/>
+              <a:ext cx="1431222" cy="488039"/>
+            </a:xfrm>
+            <a:prstGeom prst="rect">
+              <a:avLst/>
+            </a:prstGeom>
+            <a:noFill/>
+          </p:spPr>
+          <p:txBody>
+            <a:bodyPr vertOverflow="overflow" horzOverflow="overflow" vert="horz" wrap="square" lIns="91440" tIns="45720" rIns="91440" bIns="45720" numCol="1" spcCol="0" rtlCol="0" fromWordArt="0" anchor="t" anchorCtr="0" forceAA="0" upright="0" compatLnSpc="0">
+              <a:spAutoFit/>
+            </a:bodyPr>
+            <a:p>
+              <a:pPr algn="ctr">
+                <a:defRPr/>
+              </a:pPr>
+              <a:r>
+                <a:rPr lang="fr-FR" sz="2600" b="1">
+                  <a:solidFill>
+                    <a:srgbClr val="00FF73"/>
+                  </a:solidFill>
+                  <a:latin typeface="CMU Serif"/>
+                  <a:ea typeface="CMU Serif"/>
+                  <a:cs typeface="CMU Serif"/>
+                </a:rPr>
+                <a:t>Success</a:t>
+              </a:r>
+              <a:endParaRPr sz="2600" b="1">
+                <a:solidFill>
+                  <a:srgbClr val="00FF73"/>
+                </a:solidFill>
+                <a:latin typeface="CMU Serif"/>
+                <a:cs typeface="CMU Serif"/>
+              </a:endParaRPr>
+            </a:p>
+          </p:txBody>
+        </p:sp>
+      </p:grpSp>
+      <p:sp>
+        <p:nvSpPr>
+          <p:cNvPr id="954284135" name=""/>
+          <p:cNvSpPr/>
+          <p:nvPr/>
+        </p:nvSpPr>
+        <p:spPr bwMode="auto">
+          <a:xfrm rot="0" flipH="0" flipV="0">
+            <a:off x="10691102" y="3368759"/>
+            <a:ext cx="646337" cy="646337"/>
+          </a:xfrm>
+          <a:prstGeom prst="ellipse">
+            <a:avLst/>
+          </a:prstGeom>
+          <a:solidFill>
+            <a:schemeClr val="bg1"/>
+          </a:solidFill>
+          <a:ln w="44450" cap="flat" cmpd="sng" algn="ctr">
+            <a:solidFill>
+              <a:srgbClr val="000000"/>
+            </a:solidFill>
+            <a:prstDash val="sysDot"/>
+            <a:miter lim="800000"/>
+          </a:ln>
+        </p:spPr>
+        <p:style>
+          <a:lnRef idx="2">
+            <a:schemeClr val="accent1">
+              <a:shade val="50000"/>
+            </a:schemeClr>
+          </a:lnRef>
+          <a:fillRef idx="1">
+            <a:schemeClr val="accent1"/>
+          </a:fillRef>
+          <a:effectRef idx="0">
+            <a:schemeClr val="accent1"/>
+          </a:effectRef>
+          <a:fontRef idx="minor">
+            <a:schemeClr val="lt1"/>
+          </a:fontRef>
+        </p:style>
+      </p:sp>
+      <p:sp>
+        <p:nvSpPr>
+          <p:cNvPr id="1532711330" name=""/>
+          <p:cNvSpPr/>
+          <p:nvPr/>
+        </p:nvSpPr>
+        <p:spPr bwMode="auto">
+          <a:xfrm rot="10800000" flipH="0" flipV="0">
+            <a:off x="8623681" y="3368759"/>
+            <a:ext cx="646337" cy="646337"/>
+          </a:xfrm>
+          <a:prstGeom prst="ellipse">
+            <a:avLst/>
+          </a:prstGeom>
+          <a:solidFill>
+            <a:schemeClr val="bg1"/>
+          </a:solidFill>
+          <a:ln w="44450" cap="flat" cmpd="sng" algn="ctr">
+            <a:solidFill>
+              <a:srgbClr val="000000"/>
+            </a:solidFill>
+            <a:prstDash val="sysDot"/>
+            <a:miter lim="800000"/>
+          </a:ln>
+        </p:spPr>
+        <p:style>
+          <a:lnRef idx="2">
+            <a:schemeClr val="accent1">
+              <a:shade val="50000"/>
+            </a:schemeClr>
+          </a:lnRef>
+          <a:fillRef idx="1">
+            <a:schemeClr val="accent1"/>
+          </a:fillRef>
+          <a:effectRef idx="0">
+            <a:schemeClr val="accent1"/>
+          </a:effectRef>
+          <a:fontRef idx="minor">
+            <a:schemeClr val="lt1"/>
+          </a:fontRef>
+        </p:style>
+      </p:sp>
+      <p:cxnSp>
+        <p:nvCxnSpPr>
+          <p:cNvPr id="1191023157" name=""/>
+          <p:cNvCxnSpPr>
+            <a:stCxn id="954284135" idx="2"/>
+            <a:endCxn id="1532711330" idx="2"/>
+          </p:cNvCxnSpPr>
+          <p:nvPr/>
+        </p:nvCxnSpPr>
+        <p:spPr bwMode="auto">
+          <a:xfrm rot="10800000" flipH="0" flipV="0">
+            <a:off x="9270019" y="3691928"/>
+            <a:ext cx="1421082" cy="0"/>
+          </a:xfrm>
+          <a:prstGeom prst="line">
+            <a:avLst/>
+          </a:prstGeom>
+          <a:ln w="57150" cap="flat" cmpd="sng" algn="ctr">
+            <a:solidFill>
+              <a:srgbClr val="00FF73"/>
+            </a:solidFill>
+            <a:prstDash val="solid"/>
+            <a:miter lim="800000"/>
+          </a:ln>
+        </p:spPr>
+        <p:style>
+          <a:lnRef idx="1">
+            <a:schemeClr val="accent1">
+              <a:shade val="50000"/>
+            </a:schemeClr>
+          </a:lnRef>
+          <a:fillRef idx="0">
+            <a:schemeClr val="accent1"/>
+          </a:fillRef>
+          <a:effectRef idx="0">
+            <a:schemeClr val="accent1"/>
+          </a:effectRef>
+          <a:fontRef idx="minor">
+            <a:schemeClr val="tx1"/>
+          </a:fontRef>
+        </p:style>
+      </p:cxnSp>
     </p:spTree>
   </p:cSld>
   <p:clrMapOvr>
@@ -4667,7 +6205,7 @@
       </p:grpSpPr>
       <p:sp>
         <p:nvSpPr>
-          <p:cNvPr id="1081410695" name=""/>
+          <p:cNvPr id="2070137245" name=""/>
           <p:cNvSpPr txBox="1"/>
           <p:nvPr/>
         </p:nvSpPr>
@@ -4699,7 +6237,7 @@
       </p:sp>
       <p:sp>
         <p:nvSpPr>
-          <p:cNvPr id="1404641680" name=""/>
+          <p:cNvPr id="1025282122" name=""/>
           <p:cNvSpPr txBox="1"/>
           <p:nvPr/>
         </p:nvSpPr>
@@ -4731,7 +6269,7 @@
       </p:sp>
       <p:grpSp>
         <p:nvGrpSpPr>
-          <p:cNvPr id="2069807846" name=""/>
+          <p:cNvPr id="36784867" name=""/>
           <p:cNvGrpSpPr/>
           <p:nvPr/>
         </p:nvGrpSpPr>
@@ -5899,7 +7437,7 @@
       </p:grpSp>
       <p:grpSp>
         <p:nvGrpSpPr>
-          <p:cNvPr id="1184638299" name=""/>
+          <p:cNvPr id="619297944" name=""/>
           <p:cNvGrpSpPr/>
           <p:nvPr/>
         </p:nvGrpSpPr>
@@ -10543,7 +12081,7 @@
       </p:grpSpPr>
       <p:sp>
         <p:nvSpPr>
-          <p:cNvPr id="505824395" name=""/>
+          <p:cNvPr id="76403983" name=""/>
           <p:cNvSpPr txBox="1"/>
           <p:nvPr/>
         </p:nvSpPr>
@@ -10575,7 +12113,7 @@
       </p:sp>
       <p:pic>
         <p:nvPicPr>
-          <p:cNvPr id="2076413520" name=""/>
+          <p:cNvPr id="1412512091" name=""/>
           <p:cNvPicPr>
             <a:picLocks noChangeAspect="1"/>
           </p:cNvPicPr>
@@ -10597,7 +12135,7 @@
       </p:pic>
       <p:sp>
         <p:nvSpPr>
-          <p:cNvPr id="2089461786" name=""/>
+          <p:cNvPr id="2137105155" name=""/>
           <p:cNvSpPr txBox="1"/>
           <p:nvPr/>
         </p:nvSpPr>
@@ -10666,7 +12204,7 @@
       </p:sp>
       <p:sp>
         <p:nvSpPr>
-          <p:cNvPr id="1218318881" name=""/>
+          <p:cNvPr id="452227528" name=""/>
           <p:cNvSpPr txBox="1"/>
           <p:nvPr/>
         </p:nvSpPr>
@@ -10731,7 +12269,7 @@
       </p:grpSpPr>
       <p:grpSp>
         <p:nvGrpSpPr>
-          <p:cNvPr id="1300829403" name=""/>
+          <p:cNvPr id="666865468" name=""/>
           <p:cNvGrpSpPr/>
           <p:nvPr/>
         </p:nvGrpSpPr>
@@ -10835,7 +12373,7 @@
       </p:grpSp>
       <p:sp>
         <p:nvSpPr>
-          <p:cNvPr id="655461926" name=""/>
+          <p:cNvPr id="49906224" name=""/>
           <p:cNvSpPr txBox="1"/>
           <p:nvPr/>
         </p:nvSpPr>
@@ -10867,7 +12405,7 @@
       </p:sp>
       <p:sp>
         <p:nvSpPr>
-          <p:cNvPr id="2140520989" name=""/>
+          <p:cNvPr id="770961881" name=""/>
           <p:cNvSpPr txBox="1"/>
           <p:nvPr/>
         </p:nvSpPr>
@@ -10899,7 +12437,7 @@
       </p:sp>
       <p:grpSp>
         <p:nvGrpSpPr>
-          <p:cNvPr id="793193433" name=""/>
+          <p:cNvPr id="1244145575" name=""/>
           <p:cNvGrpSpPr/>
           <p:nvPr/>
         </p:nvGrpSpPr>
@@ -12594,7 +14132,7 @@
       </p:grpSpPr>
       <p:grpSp>
         <p:nvGrpSpPr>
-          <p:cNvPr id="308144386" name=""/>
+          <p:cNvPr id="823117085" name=""/>
           <p:cNvGrpSpPr/>
           <p:nvPr/>
         </p:nvGrpSpPr>
@@ -13277,7 +14815,7 @@
       </p:grpSp>
       <p:sp>
         <p:nvSpPr>
-          <p:cNvPr id="402557225" name=""/>
+          <p:cNvPr id="1096336676" name=""/>
           <p:cNvSpPr txBox="1"/>
           <p:nvPr/>
         </p:nvSpPr>
@@ -13309,7 +14847,7 @@
       </p:sp>
       <p:grpSp>
         <p:nvGrpSpPr>
-          <p:cNvPr id="628693984" name=""/>
+          <p:cNvPr id="894542784" name=""/>
           <p:cNvGrpSpPr/>
           <p:nvPr/>
         </p:nvGrpSpPr>
@@ -17769,7 +19307,7 @@
       </p:grpSp>
       <p:grpSp>
         <p:nvGrpSpPr>
-          <p:cNvPr id="1144310930" name=""/>
+          <p:cNvPr id="728322217" name=""/>
           <p:cNvGrpSpPr/>
           <p:nvPr/>
         </p:nvGrpSpPr>
@@ -17869,7 +19407,7 @@
       </p:grpSp>
       <p:grpSp>
         <p:nvGrpSpPr>
-          <p:cNvPr id="1524654918" name=""/>
+          <p:cNvPr id="529584488" name=""/>
           <p:cNvGrpSpPr/>
           <p:nvPr/>
         </p:nvGrpSpPr>
@@ -17990,16 +19528,16 @@
       </p:grpSp>
       <p:grpSp>
         <p:nvGrpSpPr>
-          <p:cNvPr id="1726386834" name=""/>
+          <p:cNvPr id="1605437044" name=""/>
           <p:cNvGrpSpPr/>
           <p:nvPr/>
         </p:nvGrpSpPr>
         <p:grpSpPr bwMode="auto">
           <a:xfrm>
-            <a:off x="8126868" y="6295941"/>
-            <a:ext cx="3867607" cy="366119"/>
+            <a:off x="8126867" y="6295941"/>
+            <a:ext cx="3869404" cy="366119"/>
             <a:chOff x="0" y="0"/>
-            <a:chExt cx="3867607" cy="366119"/>
+            <a:chExt cx="3869404" cy="366119"/>
           </a:xfrm>
         </p:grpSpPr>
         <p:cxnSp>
@@ -18010,7 +19548,7 @@
           </p:nvCxnSpPr>
           <p:spPr bwMode="auto">
             <a:xfrm rot="0" flipH="1" flipV="0">
-              <a:off x="0" y="216960"/>
+              <a:off x="0" y="216959"/>
               <a:ext cx="808170" cy="0"/>
             </a:xfrm>
             <a:prstGeom prst="line">
@@ -18049,8 +19587,8 @@
           </p:nvSpPr>
           <p:spPr bwMode="auto">
             <a:xfrm rot="0" flipH="0" flipV="0">
-              <a:off x="886641" y="0"/>
-              <a:ext cx="2980964" cy="366119"/>
+              <a:off x="886640" y="0"/>
+              <a:ext cx="2982763" cy="366119"/>
             </a:xfrm>
             <a:prstGeom prst="rect">
               <a:avLst/>
@@ -18074,7 +19612,7 @@
                   <a:ea typeface="CMU Serif"/>
                   <a:cs typeface="CMU Serif"/>
                 </a:rPr>
-                <a:t>= Entanglement</a:t>
+                <a:t>= Entanglement Link</a:t>
               </a:r>
               <a:endParaRPr lang="fr-FR" b="1">
                 <a:solidFill>
@@ -18090,7 +19628,7 @@
       </p:grpSp>
       <p:grpSp>
         <p:nvGrpSpPr>
-          <p:cNvPr id="1712868132" name=""/>
+          <p:cNvPr id="188470231" name=""/>
           <p:cNvGrpSpPr/>
           <p:nvPr/>
         </p:nvGrpSpPr>
@@ -18189,6 +19727,15 @@
                     <a:schemeClr val="lt1"/>
                   </a:fontRef>
                 </p:style>
+                <p:txBody>
+                  <a:bodyPr anchor="ctr"/>
+                  <a:p>
+                    <a:pPr algn="ctr">
+                      <a:defRPr/>
+                    </a:pPr>
+                    <a:endParaRPr/>
+                  </a:p>
+                </p:txBody>
               </p:sp>
               <p:sp>
                 <p:nvSpPr>
@@ -22556,7 +24103,7 @@
       </p:grpSpPr>
       <p:sp>
         <p:nvSpPr>
-          <p:cNvPr id="479925220" name=""/>
+          <p:cNvPr id="417793582" name=""/>
           <p:cNvSpPr txBox="1"/>
           <p:nvPr/>
         </p:nvSpPr>
@@ -22592,13 +24139,13 @@
       </p:sp>
       <p:grpSp>
         <p:nvGrpSpPr>
-          <p:cNvPr id="295023531" name=""/>
+          <p:cNvPr id="1972798597" name=""/>
           <p:cNvGrpSpPr/>
           <p:nvPr/>
         </p:nvGrpSpPr>
         <p:grpSpPr bwMode="auto">
           <a:xfrm>
-            <a:off x="177688" y="4793660"/>
+            <a:off x="177687" y="1478226"/>
             <a:ext cx="11844780" cy="1666872"/>
             <a:chOff x="0" y="0"/>
             <a:chExt cx="11844780" cy="1666872"/>
@@ -27047,7 +28594,7 @@
       </p:grpSpPr>
       <p:sp>
         <p:nvSpPr>
-          <p:cNvPr id="611040321" name="Title 1"/>
+          <p:cNvPr id="267383169" name="Title 1"/>
           <p:cNvSpPr>
             <a:spLocks noGrp="1"/>
           </p:cNvSpPr>
@@ -27078,7 +28625,7 @@
       </p:sp>
       <p:grpSp>
         <p:nvGrpSpPr>
-          <p:cNvPr id="1560016957" name=""/>
+          <p:cNvPr id="1810295179" name=""/>
           <p:cNvGrpSpPr/>
           <p:nvPr/>
         </p:nvGrpSpPr>
@@ -32294,7 +33841,7 @@
       </p:grpSp>
       <p:grpSp>
         <p:nvGrpSpPr>
-          <p:cNvPr id="886245875" name=""/>
+          <p:cNvPr id="2128153659" name=""/>
           <p:cNvGrpSpPr/>
           <p:nvPr/>
         </p:nvGrpSpPr>
@@ -33572,6 +35119,15 @@
                       <a:schemeClr val="tx1"/>
                     </a:fontRef>
                   </p:style>
+                  <p:txBody>
+                    <a:bodyPr anchor="ctr"/>
+                    <a:p>
+                      <a:pPr algn="ctr">
+                        <a:defRPr/>
+                      </a:pPr>
+                      <a:endParaRPr/>
+                    </a:p>
+                  </p:txBody>
                 </p:sp>
               </p:grpSp>
             </p:grpSp>
@@ -33869,6 +35425,15 @@
                       <a:schemeClr val="tx1"/>
                     </a:fontRef>
                   </p:style>
+                  <p:txBody>
+                    <a:bodyPr anchor="ctr"/>
+                    <a:p>
+                      <a:pPr algn="ctr">
+                        <a:defRPr/>
+                      </a:pPr>
+                      <a:endParaRPr/>
+                    </a:p>
+                  </p:txBody>
                 </p:sp>
                 <p:sp>
                   <p:nvSpPr>
@@ -36277,7 +37842,7 @@
       </p:grpSp>
       <p:grpSp>
         <p:nvGrpSpPr>
-          <p:cNvPr id="1770787412" name=""/>
+          <p:cNvPr id="1825749931" name=""/>
           <p:cNvGrpSpPr/>
           <p:nvPr/>
         </p:nvGrpSpPr>
@@ -40755,7 +42320,7 @@
       </p:grpSpPr>
       <p:sp>
         <p:nvSpPr>
-          <p:cNvPr id="1439335853" name=""/>
+          <p:cNvPr id="2001974474" name=""/>
           <p:cNvSpPr txBox="1"/>
           <p:nvPr/>
         </p:nvSpPr>
@@ -40794,7 +42359,7 @@
       </p:sp>
       <p:sp>
         <p:nvSpPr>
-          <p:cNvPr id="1152344237" name=""/>
+          <p:cNvPr id="1196120772" name=""/>
           <p:cNvSpPr txBox="1"/>
           <p:nvPr/>
         </p:nvSpPr>
@@ -40859,7 +42424,7 @@
       </p:grpSpPr>
       <p:grpSp>
         <p:nvGrpSpPr>
-          <p:cNvPr id="966098489" name=""/>
+          <p:cNvPr id="608055758" name=""/>
           <p:cNvGrpSpPr/>
           <p:nvPr/>
         </p:nvGrpSpPr>
@@ -41774,7 +43339,7 @@
       </p:grpSp>
       <p:sp>
         <p:nvSpPr>
-          <p:cNvPr id="421662770" name=""/>
+          <p:cNvPr id="80698401" name=""/>
           <p:cNvSpPr txBox="1"/>
           <p:nvPr/>
         </p:nvSpPr>
@@ -41858,7 +43423,7 @@
       </p:grpSpPr>
       <p:sp>
         <p:nvSpPr>
-          <p:cNvPr id="1053807433" name=""/>
+          <p:cNvPr id="1875243515" name=""/>
           <p:cNvSpPr txBox="1"/>
           <p:nvPr/>
         </p:nvSpPr>
@@ -41890,7 +43455,7 @@
       </p:sp>
       <p:grpSp>
         <p:nvGrpSpPr>
-          <p:cNvPr id="1190919582" name=""/>
+          <p:cNvPr id="928387328" name=""/>
           <p:cNvGrpSpPr/>
           <p:nvPr/>
         </p:nvGrpSpPr>
@@ -43686,7 +45251,7 @@
       </p:grpSpPr>
       <p:sp>
         <p:nvSpPr>
-          <p:cNvPr id="956553955" name=""/>
+          <p:cNvPr id="2024158358" name=""/>
           <p:cNvSpPr txBox="1"/>
           <p:nvPr/>
         </p:nvSpPr>
@@ -43718,7 +45283,7 @@
       </p:sp>
       <p:grpSp>
         <p:nvGrpSpPr>
-          <p:cNvPr id="1518597930" name=""/>
+          <p:cNvPr id="1494290514" name=""/>
           <p:cNvGrpSpPr/>
           <p:nvPr/>
         </p:nvGrpSpPr>

</xml_diff>

<commit_message>
chore: remove temporary lock file and update design sheet presentation
</commit_message>
<xml_diff>
--- a/thesis/figures/design-doc/design_sheet.pptx
+++ b/thesis/figures/design-doc/design_sheet.pptx
@@ -144,7 +144,7 @@
       </p:grpSpPr>
       <p:sp>
         <p:nvSpPr>
-          <p:cNvPr id="918157145" name="Header Placeholder 1"/>
+          <p:cNvPr id="1343029013" name="Header Placeholder 1"/>
           <p:cNvSpPr>
             <a:spLocks noGrp="1"/>
           </p:cNvSpPr>
@@ -178,7 +178,7 @@
       </p:sp>
       <p:sp>
         <p:nvSpPr>
-          <p:cNvPr id="946068894" name="Date Placeholder 2"/>
+          <p:cNvPr id="1179657490" name="Date Placeholder 2"/>
           <p:cNvSpPr>
             <a:spLocks noGrp="1"/>
           </p:cNvSpPr>
@@ -216,7 +216,7 @@
       </p:sp>
       <p:sp>
         <p:nvSpPr>
-          <p:cNvPr id="482654392" name="Slide Image Placeholder 3"/>
+          <p:cNvPr id="309314310" name="Slide Image Placeholder 3"/>
           <p:cNvSpPr>
             <a:spLocks noChangeAspect="1" noGrp="1" noRot="1"/>
           </p:cNvSpPr>
@@ -252,7 +252,7 @@
       </p:sp>
       <p:sp>
         <p:nvSpPr>
-          <p:cNvPr id="1257292427" name="Notes Placeholder 4"/>
+          <p:cNvPr id="991895080" name="Notes Placeholder 4"/>
           <p:cNvSpPr>
             <a:spLocks noGrp="1"/>
           </p:cNvSpPr>
@@ -326,7 +326,7 @@
       </p:sp>
       <p:sp>
         <p:nvSpPr>
-          <p:cNvPr id="12718456" name="Footer Placeholder 5"/>
+          <p:cNvPr id="174559305" name="Footer Placeholder 5"/>
           <p:cNvSpPr>
             <a:spLocks noGrp="1"/>
           </p:cNvSpPr>
@@ -360,7 +360,7 @@
       </p:sp>
       <p:sp>
         <p:nvSpPr>
-          <p:cNvPr id="1426136000" name="Slide Number Placeholder 6"/>
+          <p:cNvPr id="428126860" name="Slide Number Placeholder 6"/>
           <p:cNvSpPr>
             <a:spLocks noGrp="1"/>
           </p:cNvSpPr>
@@ -513,7 +513,7 @@
       </p:grpSpPr>
       <p:sp>
         <p:nvSpPr>
-          <p:cNvPr id="1157841889" name="Slide Image Placeholder 1"/>
+          <p:cNvPr id="557236503" name="Slide Image Placeholder 1"/>
           <p:cNvSpPr>
             <a:spLocks noChangeAspect="1" noGrp="1" noRot="1"/>
           </p:cNvSpPr>
@@ -525,7 +525,7 @@
       </p:sp>
       <p:sp>
         <p:nvSpPr>
-          <p:cNvPr id="1161287235" name="Notes Placeholder 2"/>
+          <p:cNvPr id="18442943" name="Notes Placeholder 2"/>
           <p:cNvSpPr>
             <a:spLocks noGrp="1"/>
           </p:cNvSpPr>
@@ -547,7 +547,7 @@
       </p:sp>
       <p:sp>
         <p:nvSpPr>
-          <p:cNvPr id="1404407320" name="Slide Number Placeholder 3"/>
+          <p:cNvPr id="1762314229" name="Slide Number Placeholder 3"/>
           <p:cNvSpPr>
             <a:spLocks noGrp="1"/>
           </p:cNvSpPr>
@@ -598,7 +598,7 @@
       </p:grpSpPr>
       <p:sp>
         <p:nvSpPr>
-          <p:cNvPr id="612792469" name="Slide Image Placeholder 1"/>
+          <p:cNvPr id="1488767470" name="Slide Image Placeholder 1"/>
           <p:cNvSpPr>
             <a:spLocks noChangeAspect="1" noGrp="1" noRot="1"/>
           </p:cNvSpPr>
@@ -610,7 +610,7 @@
       </p:sp>
       <p:sp>
         <p:nvSpPr>
-          <p:cNvPr id="973511347" name="Notes Placeholder 2"/>
+          <p:cNvPr id="1031681455" name="Notes Placeholder 2"/>
           <p:cNvSpPr>
             <a:spLocks noGrp="1"/>
           </p:cNvSpPr>
@@ -632,7 +632,7 @@
       </p:sp>
       <p:sp>
         <p:nvSpPr>
-          <p:cNvPr id="1970037452" name="Slide Number Placeholder 3"/>
+          <p:cNvPr id="972785653" name="Slide Number Placeholder 3"/>
           <p:cNvSpPr>
             <a:spLocks noGrp="1"/>
           </p:cNvSpPr>
@@ -683,7 +683,7 @@
       </p:grpSpPr>
       <p:sp>
         <p:nvSpPr>
-          <p:cNvPr id="1300651503" name="Slide Image Placeholder 1"/>
+          <p:cNvPr id="1455533285" name="Slide Image Placeholder 1"/>
           <p:cNvSpPr>
             <a:spLocks noChangeAspect="1" noGrp="1" noRot="1"/>
           </p:cNvSpPr>
@@ -695,7 +695,7 @@
       </p:sp>
       <p:sp>
         <p:nvSpPr>
-          <p:cNvPr id="1150211180" name="Notes Placeholder 2"/>
+          <p:cNvPr id="400733766" name="Notes Placeholder 2"/>
           <p:cNvSpPr>
             <a:spLocks noGrp="1"/>
           </p:cNvSpPr>
@@ -717,7 +717,7 @@
       </p:sp>
       <p:sp>
         <p:nvSpPr>
-          <p:cNvPr id="1892474861" name="Slide Number Placeholder 3"/>
+          <p:cNvPr id="1792418009" name="Slide Number Placeholder 3"/>
           <p:cNvSpPr>
             <a:spLocks noGrp="1"/>
           </p:cNvSpPr>
@@ -768,7 +768,7 @@
       </p:grpSpPr>
       <p:sp>
         <p:nvSpPr>
-          <p:cNvPr id="31595438" name="Slide Image Placeholder 1"/>
+          <p:cNvPr id="1307360361" name="Slide Image Placeholder 1"/>
           <p:cNvSpPr>
             <a:spLocks noChangeAspect="1" noGrp="1" noRot="1"/>
           </p:cNvSpPr>
@@ -785,7 +785,7 @@
       </p:sp>
       <p:sp>
         <p:nvSpPr>
-          <p:cNvPr id="843325901" name="Notes Placeholder 2"/>
+          <p:cNvPr id="1127341405" name="Notes Placeholder 2"/>
           <p:cNvSpPr>
             <a:spLocks noGrp="1"/>
           </p:cNvSpPr>
@@ -810,7 +810,7 @@
       </p:sp>
       <p:sp>
         <p:nvSpPr>
-          <p:cNvPr id="1972697782" name="Slide Number Placeholder 3"/>
+          <p:cNvPr id="2089413708" name="Slide Number Placeholder 3"/>
           <p:cNvSpPr>
             <a:spLocks noGrp="1"/>
           </p:cNvSpPr>
@@ -861,7 +861,7 @@
       </p:grpSpPr>
       <p:sp>
         <p:nvSpPr>
-          <p:cNvPr id="1833731938" name="Slide Image Placeholder 1"/>
+          <p:cNvPr id="1680387035" name="Slide Image Placeholder 1"/>
           <p:cNvSpPr>
             <a:spLocks noChangeAspect="1" noGrp="1" noRot="1"/>
           </p:cNvSpPr>
@@ -873,7 +873,7 @@
       </p:sp>
       <p:sp>
         <p:nvSpPr>
-          <p:cNvPr id="305598864" name="Notes Placeholder 2"/>
+          <p:cNvPr id="1915578980" name="Notes Placeholder 2"/>
           <p:cNvSpPr>
             <a:spLocks noGrp="1"/>
           </p:cNvSpPr>
@@ -895,7 +895,7 @@
       </p:sp>
       <p:sp>
         <p:nvSpPr>
-          <p:cNvPr id="214833910" name="Slide Number Placeholder 3"/>
+          <p:cNvPr id="810796738" name="Slide Number Placeholder 3"/>
           <p:cNvSpPr>
             <a:spLocks noGrp="1"/>
           </p:cNvSpPr>
@@ -946,7 +946,7 @@
       </p:grpSpPr>
       <p:sp>
         <p:nvSpPr>
-          <p:cNvPr id="1166322066" name="Slide Image Placeholder 1"/>
+          <p:cNvPr id="842690296" name="Slide Image Placeholder 1"/>
           <p:cNvSpPr>
             <a:spLocks noChangeAspect="1" noGrp="1" noRot="1"/>
           </p:cNvSpPr>
@@ -958,7 +958,7 @@
       </p:sp>
       <p:sp>
         <p:nvSpPr>
-          <p:cNvPr id="1189260971" name="Notes Placeholder 2"/>
+          <p:cNvPr id="1036706523" name="Notes Placeholder 2"/>
           <p:cNvSpPr>
             <a:spLocks noGrp="1"/>
           </p:cNvSpPr>
@@ -980,7 +980,7 @@
       </p:sp>
       <p:sp>
         <p:nvSpPr>
-          <p:cNvPr id="1107478554" name="Slide Number Placeholder 3"/>
+          <p:cNvPr id="1099342980" name="Slide Number Placeholder 3"/>
           <p:cNvSpPr>
             <a:spLocks noGrp="1"/>
           </p:cNvSpPr>
@@ -1031,7 +1031,7 @@
       </p:grpSpPr>
       <p:sp>
         <p:nvSpPr>
-          <p:cNvPr id="389449791" name="Slide Image Placeholder 1"/>
+          <p:cNvPr id="1154302138" name="Slide Image Placeholder 1"/>
           <p:cNvSpPr>
             <a:spLocks noChangeAspect="1" noGrp="1" noRot="1"/>
           </p:cNvSpPr>
@@ -1043,7 +1043,7 @@
       </p:sp>
       <p:sp>
         <p:nvSpPr>
-          <p:cNvPr id="57071733" name="Notes Placeholder 2"/>
+          <p:cNvPr id="705266484" name="Notes Placeholder 2"/>
           <p:cNvSpPr>
             <a:spLocks noGrp="1"/>
           </p:cNvSpPr>
@@ -1065,7 +1065,7 @@
       </p:sp>
       <p:sp>
         <p:nvSpPr>
-          <p:cNvPr id="1772241560" name="Slide Number Placeholder 3"/>
+          <p:cNvPr id="1160005404" name="Slide Number Placeholder 3"/>
           <p:cNvSpPr>
             <a:spLocks noGrp="1"/>
           </p:cNvSpPr>
@@ -1116,7 +1116,7 @@
       </p:grpSpPr>
       <p:sp>
         <p:nvSpPr>
-          <p:cNvPr id="213914380" name="Slide Image Placeholder 1"/>
+          <p:cNvPr id="1689721257" name="Slide Image Placeholder 1"/>
           <p:cNvSpPr>
             <a:spLocks noChangeAspect="1" noGrp="1" noRot="1"/>
           </p:cNvSpPr>
@@ -1128,7 +1128,7 @@
       </p:sp>
       <p:sp>
         <p:nvSpPr>
-          <p:cNvPr id="1124995645" name="Notes Placeholder 2"/>
+          <p:cNvPr id="183302919" name="Notes Placeholder 2"/>
           <p:cNvSpPr>
             <a:spLocks noGrp="1"/>
           </p:cNvSpPr>
@@ -1150,7 +1150,7 @@
       </p:sp>
       <p:sp>
         <p:nvSpPr>
-          <p:cNvPr id="218030491" name="Slide Number Placeholder 3"/>
+          <p:cNvPr id="276496795" name="Slide Number Placeholder 3"/>
           <p:cNvSpPr>
             <a:spLocks noGrp="1"/>
           </p:cNvSpPr>
@@ -1201,7 +1201,7 @@
       </p:grpSpPr>
       <p:sp>
         <p:nvSpPr>
-          <p:cNvPr id="1520517744" name="Slide Image Placeholder 1"/>
+          <p:cNvPr id="749193744" name="Slide Image Placeholder 1"/>
           <p:cNvSpPr>
             <a:spLocks noChangeAspect="1" noGrp="1" noRot="1"/>
           </p:cNvSpPr>
@@ -1218,7 +1218,7 @@
       </p:sp>
       <p:sp>
         <p:nvSpPr>
-          <p:cNvPr id="1973392575" name="Notes Placeholder 2"/>
+          <p:cNvPr id="1596986250" name="Notes Placeholder 2"/>
           <p:cNvSpPr>
             <a:spLocks noGrp="1"/>
           </p:cNvSpPr>
@@ -1243,7 +1243,7 @@
       </p:sp>
       <p:sp>
         <p:nvSpPr>
-          <p:cNvPr id="916327446" name="Slide Number Placeholder 3"/>
+          <p:cNvPr id="1979531928" name="Slide Number Placeholder 3"/>
           <p:cNvSpPr>
             <a:spLocks noGrp="1"/>
           </p:cNvSpPr>
@@ -1294,7 +1294,7 @@
       </p:grpSpPr>
       <p:sp>
         <p:nvSpPr>
-          <p:cNvPr id="1312479250" name="Slide Image Placeholder 1"/>
+          <p:cNvPr id="1875661963" name="Slide Image Placeholder 1"/>
           <p:cNvSpPr>
             <a:spLocks noChangeAspect="1" noGrp="1" noRot="1"/>
           </p:cNvSpPr>
@@ -1311,7 +1311,7 @@
       </p:sp>
       <p:sp>
         <p:nvSpPr>
-          <p:cNvPr id="2069973378" name="Notes Placeholder 2"/>
+          <p:cNvPr id="902986" name="Notes Placeholder 2"/>
           <p:cNvSpPr>
             <a:spLocks noGrp="1"/>
           </p:cNvSpPr>
@@ -1336,7 +1336,7 @@
       </p:sp>
       <p:sp>
         <p:nvSpPr>
-          <p:cNvPr id="371117957" name="Slide Number Placeholder 3"/>
+          <p:cNvPr id="336002847" name="Slide Number Placeholder 3"/>
           <p:cNvSpPr>
             <a:spLocks noGrp="1"/>
           </p:cNvSpPr>
@@ -1387,7 +1387,7 @@
       </p:grpSpPr>
       <p:sp>
         <p:nvSpPr>
-          <p:cNvPr id="883115357" name="Slide Image Placeholder 1"/>
+          <p:cNvPr id="1996644424" name="Slide Image Placeholder 1"/>
           <p:cNvSpPr>
             <a:spLocks noChangeAspect="1" noGrp="1" noRot="1"/>
           </p:cNvSpPr>
@@ -1399,7 +1399,7 @@
       </p:sp>
       <p:sp>
         <p:nvSpPr>
-          <p:cNvPr id="613376470" name="Notes Placeholder 2"/>
+          <p:cNvPr id="755022510" name="Notes Placeholder 2"/>
           <p:cNvSpPr>
             <a:spLocks noGrp="1"/>
           </p:cNvSpPr>
@@ -1421,7 +1421,7 @@
       </p:sp>
       <p:sp>
         <p:nvSpPr>
-          <p:cNvPr id="1913439627" name="Slide Number Placeholder 3"/>
+          <p:cNvPr id="314585014" name="Slide Number Placeholder 3"/>
           <p:cNvSpPr>
             <a:spLocks noGrp="1"/>
           </p:cNvSpPr>
@@ -1472,7 +1472,7 @@
       </p:grpSpPr>
       <p:sp>
         <p:nvSpPr>
-          <p:cNvPr id="1342172529" name="Title 1"/>
+          <p:cNvPr id="601001437" name="Title 1"/>
           <p:cNvSpPr>
             <a:spLocks noGrp="1"/>
           </p:cNvSpPr>
@@ -1507,7 +1507,7 @@
       </p:sp>
       <p:sp>
         <p:nvSpPr>
-          <p:cNvPr id="865068928" name="Subtitle 2"/>
+          <p:cNvPr id="862640140" name="Subtitle 2"/>
           <p:cNvSpPr>
             <a:spLocks noGrp="1"/>
           </p:cNvSpPr>
@@ -1575,7 +1575,7 @@
       </p:sp>
       <p:sp>
         <p:nvSpPr>
-          <p:cNvPr id="381960484" name="Date Placeholder 3"/>
+          <p:cNvPr id="2018824175" name="Date Placeholder 3"/>
           <p:cNvSpPr>
             <a:spLocks noGrp="1"/>
           </p:cNvSpPr>
@@ -1601,7 +1601,7 @@
       </p:sp>
       <p:sp>
         <p:nvSpPr>
-          <p:cNvPr id="2029993515" name="Footer Placeholder 4"/>
+          <p:cNvPr id="1632747304" name="Footer Placeholder 4"/>
           <p:cNvSpPr>
             <a:spLocks noGrp="1"/>
           </p:cNvSpPr>
@@ -1623,7 +1623,7 @@
       </p:sp>
       <p:sp>
         <p:nvSpPr>
-          <p:cNvPr id="1793865467" name="Slide Number Placeholder 5"/>
+          <p:cNvPr id="1837371596" name="Slide Number Placeholder 5"/>
           <p:cNvSpPr>
             <a:spLocks noGrp="1"/>
           </p:cNvSpPr>
@@ -1674,7 +1674,7 @@
       </p:grpSpPr>
       <p:sp>
         <p:nvSpPr>
-          <p:cNvPr id="1493590933" name="Title 1"/>
+          <p:cNvPr id="44994175" name="Title 1"/>
           <p:cNvSpPr>
             <a:spLocks noGrp="1"/>
           </p:cNvSpPr>
@@ -1700,7 +1700,7 @@
       </p:sp>
       <p:sp>
         <p:nvSpPr>
-          <p:cNvPr id="134332089" name="Vertical Text Placeholder 2"/>
+          <p:cNvPr id="1461724567" name="Vertical Text Placeholder 2"/>
           <p:cNvSpPr>
             <a:spLocks noGrp="1"/>
           </p:cNvSpPr>
@@ -1766,7 +1766,7 @@
       </p:sp>
       <p:sp>
         <p:nvSpPr>
-          <p:cNvPr id="1395729805" name="Date Placeholder 3"/>
+          <p:cNvPr id="76503700" name="Date Placeholder 3"/>
           <p:cNvSpPr>
             <a:spLocks noGrp="1"/>
           </p:cNvSpPr>
@@ -1792,7 +1792,7 @@
       </p:sp>
       <p:sp>
         <p:nvSpPr>
-          <p:cNvPr id="555129954" name="Footer Placeholder 4"/>
+          <p:cNvPr id="135584094" name="Footer Placeholder 4"/>
           <p:cNvSpPr>
             <a:spLocks noGrp="1"/>
           </p:cNvSpPr>
@@ -1814,7 +1814,7 @@
       </p:sp>
       <p:sp>
         <p:nvSpPr>
-          <p:cNvPr id="95189028" name="Slide Number Placeholder 5"/>
+          <p:cNvPr id="1926362986" name="Slide Number Placeholder 5"/>
           <p:cNvSpPr>
             <a:spLocks noGrp="1"/>
           </p:cNvSpPr>
@@ -1865,7 +1865,7 @@
       </p:grpSpPr>
       <p:sp>
         <p:nvSpPr>
-          <p:cNvPr id="694476389" name="Vertical Title 1"/>
+          <p:cNvPr id="174684965" name="Vertical Title 1"/>
           <p:cNvSpPr>
             <a:spLocks noGrp="1"/>
           </p:cNvSpPr>
@@ -1896,7 +1896,7 @@
       </p:sp>
       <p:sp>
         <p:nvSpPr>
-          <p:cNvPr id="2080009970" name="Vertical Text Placeholder 2"/>
+          <p:cNvPr id="744109921" name="Vertical Text Placeholder 2"/>
           <p:cNvSpPr>
             <a:spLocks noGrp="1"/>
           </p:cNvSpPr>
@@ -1967,7 +1967,7 @@
       </p:sp>
       <p:sp>
         <p:nvSpPr>
-          <p:cNvPr id="602050585" name="Date Placeholder 3"/>
+          <p:cNvPr id="1790866073" name="Date Placeholder 3"/>
           <p:cNvSpPr>
             <a:spLocks noGrp="1"/>
           </p:cNvSpPr>
@@ -1993,7 +1993,7 @@
       </p:sp>
       <p:sp>
         <p:nvSpPr>
-          <p:cNvPr id="1475845269" name="Footer Placeholder 4"/>
+          <p:cNvPr id="1729889472" name="Footer Placeholder 4"/>
           <p:cNvSpPr>
             <a:spLocks noGrp="1"/>
           </p:cNvSpPr>
@@ -2015,7 +2015,7 @@
       </p:sp>
       <p:sp>
         <p:nvSpPr>
-          <p:cNvPr id="952422686" name="Slide Number Placeholder 5"/>
+          <p:cNvPr id="17700023" name="Slide Number Placeholder 5"/>
           <p:cNvSpPr>
             <a:spLocks noGrp="1"/>
           </p:cNvSpPr>
@@ -2066,7 +2066,7 @@
       </p:grpSpPr>
       <p:sp>
         <p:nvSpPr>
-          <p:cNvPr id="1818659817" name="Title 1"/>
+          <p:cNvPr id="332152997" name="Title 1"/>
           <p:cNvSpPr>
             <a:spLocks noGrp="1"/>
           </p:cNvSpPr>
@@ -2092,7 +2092,7 @@
       </p:sp>
       <p:sp>
         <p:nvSpPr>
-          <p:cNvPr id="1772628613" name="Content Placeholder 2"/>
+          <p:cNvPr id="1094797488" name="Content Placeholder 2"/>
           <p:cNvSpPr>
             <a:spLocks noGrp="1"/>
           </p:cNvSpPr>
@@ -2158,7 +2158,7 @@
       </p:sp>
       <p:sp>
         <p:nvSpPr>
-          <p:cNvPr id="182947560" name="Date Placeholder 3"/>
+          <p:cNvPr id="649923173" name="Date Placeholder 3"/>
           <p:cNvSpPr>
             <a:spLocks noGrp="1"/>
           </p:cNvSpPr>
@@ -2184,7 +2184,7 @@
       </p:sp>
       <p:sp>
         <p:nvSpPr>
-          <p:cNvPr id="1071828540" name="Footer Placeholder 4"/>
+          <p:cNvPr id="1638813567" name="Footer Placeholder 4"/>
           <p:cNvSpPr>
             <a:spLocks noGrp="1"/>
           </p:cNvSpPr>
@@ -2206,7 +2206,7 @@
       </p:sp>
       <p:sp>
         <p:nvSpPr>
-          <p:cNvPr id="1084283455" name="Slide Number Placeholder 5"/>
+          <p:cNvPr id="2024208758" name="Slide Number Placeholder 5"/>
           <p:cNvSpPr>
             <a:spLocks noGrp="1"/>
           </p:cNvSpPr>
@@ -2257,7 +2257,7 @@
       </p:grpSpPr>
       <p:sp>
         <p:nvSpPr>
-          <p:cNvPr id="1040523729" name="Title 1"/>
+          <p:cNvPr id="1971952144" name="Title 1"/>
           <p:cNvSpPr>
             <a:spLocks noGrp="1"/>
           </p:cNvSpPr>
@@ -2292,7 +2292,7 @@
       </p:sp>
       <p:sp>
         <p:nvSpPr>
-          <p:cNvPr id="1679885070" name="Text Placeholder 2"/>
+          <p:cNvPr id="1312903202" name="Text Placeholder 2"/>
           <p:cNvSpPr>
             <a:spLocks noGrp="1"/>
           </p:cNvSpPr>
@@ -2414,7 +2414,7 @@
       </p:sp>
       <p:sp>
         <p:nvSpPr>
-          <p:cNvPr id="1444694886" name="Date Placeholder 3"/>
+          <p:cNvPr id="1141312389" name="Date Placeholder 3"/>
           <p:cNvSpPr>
             <a:spLocks noGrp="1"/>
           </p:cNvSpPr>
@@ -2440,7 +2440,7 @@
       </p:sp>
       <p:sp>
         <p:nvSpPr>
-          <p:cNvPr id="160925536" name="Footer Placeholder 4"/>
+          <p:cNvPr id="1616332097" name="Footer Placeholder 4"/>
           <p:cNvSpPr>
             <a:spLocks noGrp="1"/>
           </p:cNvSpPr>
@@ -2462,7 +2462,7 @@
       </p:sp>
       <p:sp>
         <p:nvSpPr>
-          <p:cNvPr id="1810026963" name="Slide Number Placeholder 5"/>
+          <p:cNvPr id="18102688" name="Slide Number Placeholder 5"/>
           <p:cNvSpPr>
             <a:spLocks noGrp="1"/>
           </p:cNvSpPr>
@@ -2513,7 +2513,7 @@
       </p:grpSpPr>
       <p:sp>
         <p:nvSpPr>
-          <p:cNvPr id="1417379883" name="Title 1"/>
+          <p:cNvPr id="1297632205" name="Title 1"/>
           <p:cNvSpPr>
             <a:spLocks noGrp="1"/>
           </p:cNvSpPr>
@@ -2539,7 +2539,7 @@
       </p:sp>
       <p:sp>
         <p:nvSpPr>
-          <p:cNvPr id="334541167" name="Content Placeholder 2"/>
+          <p:cNvPr id="1385874111" name="Content Placeholder 2"/>
           <p:cNvSpPr>
             <a:spLocks noGrp="1"/>
           </p:cNvSpPr>
@@ -2610,7 +2610,7 @@
       </p:sp>
       <p:sp>
         <p:nvSpPr>
-          <p:cNvPr id="942890390" name="Content Placeholder 3"/>
+          <p:cNvPr id="366398654" name="Content Placeholder 3"/>
           <p:cNvSpPr>
             <a:spLocks noGrp="1"/>
           </p:cNvSpPr>
@@ -2681,7 +2681,7 @@
       </p:sp>
       <p:sp>
         <p:nvSpPr>
-          <p:cNvPr id="1941596895" name="Date Placeholder 4"/>
+          <p:cNvPr id="101947263" name="Date Placeholder 4"/>
           <p:cNvSpPr>
             <a:spLocks noGrp="1"/>
           </p:cNvSpPr>
@@ -2707,7 +2707,7 @@
       </p:sp>
       <p:sp>
         <p:nvSpPr>
-          <p:cNvPr id="893981287" name="Footer Placeholder 5"/>
+          <p:cNvPr id="1353423249" name="Footer Placeholder 5"/>
           <p:cNvSpPr>
             <a:spLocks noGrp="1"/>
           </p:cNvSpPr>
@@ -2729,7 +2729,7 @@
       </p:sp>
       <p:sp>
         <p:nvSpPr>
-          <p:cNvPr id="1340031170" name="Slide Number Placeholder 6"/>
+          <p:cNvPr id="481102046" name="Slide Number Placeholder 6"/>
           <p:cNvSpPr>
             <a:spLocks noGrp="1"/>
           </p:cNvSpPr>
@@ -2780,7 +2780,7 @@
       </p:grpSpPr>
       <p:sp>
         <p:nvSpPr>
-          <p:cNvPr id="2005591006" name="Title 1"/>
+          <p:cNvPr id="1483546450" name="Title 1"/>
           <p:cNvSpPr>
             <a:spLocks noGrp="1"/>
           </p:cNvSpPr>
@@ -2811,7 +2811,7 @@
       </p:sp>
       <p:sp>
         <p:nvSpPr>
-          <p:cNvPr id="778508420" name="Text Placeholder 2"/>
+          <p:cNvPr id="360848904" name="Text Placeholder 2"/>
           <p:cNvSpPr>
             <a:spLocks noGrp="1"/>
           </p:cNvSpPr>
@@ -2879,7 +2879,7 @@
       </p:sp>
       <p:sp>
         <p:nvSpPr>
-          <p:cNvPr id="1869095458" name="Content Placeholder 3"/>
+          <p:cNvPr id="1231245047" name="Content Placeholder 3"/>
           <p:cNvSpPr>
             <a:spLocks noGrp="1"/>
           </p:cNvSpPr>
@@ -2950,7 +2950,7 @@
       </p:sp>
       <p:sp>
         <p:nvSpPr>
-          <p:cNvPr id="40679671" name="Text Placeholder 4"/>
+          <p:cNvPr id="697224895" name="Text Placeholder 4"/>
           <p:cNvSpPr>
             <a:spLocks noGrp="1"/>
           </p:cNvSpPr>
@@ -3018,7 +3018,7 @@
       </p:sp>
       <p:sp>
         <p:nvSpPr>
-          <p:cNvPr id="1115841982" name="Content Placeholder 5"/>
+          <p:cNvPr id="1769075812" name="Content Placeholder 5"/>
           <p:cNvSpPr>
             <a:spLocks noGrp="1"/>
           </p:cNvSpPr>
@@ -3089,7 +3089,7 @@
       </p:sp>
       <p:sp>
         <p:nvSpPr>
-          <p:cNvPr id="1750683851" name="Date Placeholder 6"/>
+          <p:cNvPr id="2119605634" name="Date Placeholder 6"/>
           <p:cNvSpPr>
             <a:spLocks noGrp="1"/>
           </p:cNvSpPr>
@@ -3115,7 +3115,7 @@
       </p:sp>
       <p:sp>
         <p:nvSpPr>
-          <p:cNvPr id="874384588" name="Footer Placeholder 7"/>
+          <p:cNvPr id="1224368123" name="Footer Placeholder 7"/>
           <p:cNvSpPr>
             <a:spLocks noGrp="1"/>
           </p:cNvSpPr>
@@ -3137,7 +3137,7 @@
       </p:sp>
       <p:sp>
         <p:nvSpPr>
-          <p:cNvPr id="54041710" name="Slide Number Placeholder 8"/>
+          <p:cNvPr id="869018236" name="Slide Number Placeholder 8"/>
           <p:cNvSpPr>
             <a:spLocks noGrp="1"/>
           </p:cNvSpPr>
@@ -3188,7 +3188,7 @@
       </p:grpSpPr>
       <p:sp>
         <p:nvSpPr>
-          <p:cNvPr id="1824604249" name="Title 1"/>
+          <p:cNvPr id="797519684" name="Title 1"/>
           <p:cNvSpPr>
             <a:spLocks noGrp="1"/>
           </p:cNvSpPr>
@@ -3214,7 +3214,7 @@
       </p:sp>
       <p:sp>
         <p:nvSpPr>
-          <p:cNvPr id="820404490" name="Date Placeholder 2"/>
+          <p:cNvPr id="1435034316" name="Date Placeholder 2"/>
           <p:cNvSpPr>
             <a:spLocks noGrp="1"/>
           </p:cNvSpPr>
@@ -3240,7 +3240,7 @@
       </p:sp>
       <p:sp>
         <p:nvSpPr>
-          <p:cNvPr id="1773040963" name="Footer Placeholder 3"/>
+          <p:cNvPr id="1284381426" name="Footer Placeholder 3"/>
           <p:cNvSpPr>
             <a:spLocks noGrp="1"/>
           </p:cNvSpPr>
@@ -3262,7 +3262,7 @@
       </p:sp>
       <p:sp>
         <p:nvSpPr>
-          <p:cNvPr id="1761377903" name="Slide Number Placeholder 4"/>
+          <p:cNvPr id="560146466" name="Slide Number Placeholder 4"/>
           <p:cNvSpPr>
             <a:spLocks noGrp="1"/>
           </p:cNvSpPr>
@@ -3313,7 +3313,7 @@
       </p:grpSpPr>
       <p:sp>
         <p:nvSpPr>
-          <p:cNvPr id="336873383" name="Date Placeholder 1"/>
+          <p:cNvPr id="688484860" name="Date Placeholder 1"/>
           <p:cNvSpPr>
             <a:spLocks noGrp="1"/>
           </p:cNvSpPr>
@@ -3339,7 +3339,7 @@
       </p:sp>
       <p:sp>
         <p:nvSpPr>
-          <p:cNvPr id="1395687784" name="Footer Placeholder 2"/>
+          <p:cNvPr id="1140750031" name="Footer Placeholder 2"/>
           <p:cNvSpPr>
             <a:spLocks noGrp="1"/>
           </p:cNvSpPr>
@@ -3361,7 +3361,7 @@
       </p:sp>
       <p:sp>
         <p:nvSpPr>
-          <p:cNvPr id="1483558549" name="Slide Number Placeholder 3"/>
+          <p:cNvPr id="1566066957" name="Slide Number Placeholder 3"/>
           <p:cNvSpPr>
             <a:spLocks noGrp="1"/>
           </p:cNvSpPr>
@@ -3412,7 +3412,7 @@
       </p:grpSpPr>
       <p:sp>
         <p:nvSpPr>
-          <p:cNvPr id="1323537279" name="Title 1"/>
+          <p:cNvPr id="339959800" name="Title 1"/>
           <p:cNvSpPr>
             <a:spLocks noGrp="1"/>
           </p:cNvSpPr>
@@ -3447,7 +3447,7 @@
       </p:sp>
       <p:sp>
         <p:nvSpPr>
-          <p:cNvPr id="1738543507" name="Content Placeholder 2"/>
+          <p:cNvPr id="1731379306" name="Content Placeholder 2"/>
           <p:cNvSpPr>
             <a:spLocks noGrp="1"/>
           </p:cNvSpPr>
@@ -3546,7 +3546,7 @@
       </p:sp>
       <p:sp>
         <p:nvSpPr>
-          <p:cNvPr id="1435539446" name="Text Placeholder 3"/>
+          <p:cNvPr id="1398045818" name="Text Placeholder 3"/>
           <p:cNvSpPr>
             <a:spLocks noGrp="1"/>
           </p:cNvSpPr>
@@ -3614,7 +3614,7 @@
       </p:sp>
       <p:sp>
         <p:nvSpPr>
-          <p:cNvPr id="552228747" name="Date Placeholder 4"/>
+          <p:cNvPr id="1989101361" name="Date Placeholder 4"/>
           <p:cNvSpPr>
             <a:spLocks noGrp="1"/>
           </p:cNvSpPr>
@@ -3640,7 +3640,7 @@
       </p:sp>
       <p:sp>
         <p:nvSpPr>
-          <p:cNvPr id="976009191" name="Footer Placeholder 5"/>
+          <p:cNvPr id="102479125" name="Footer Placeholder 5"/>
           <p:cNvSpPr>
             <a:spLocks noGrp="1"/>
           </p:cNvSpPr>
@@ -3662,7 +3662,7 @@
       </p:sp>
       <p:sp>
         <p:nvSpPr>
-          <p:cNvPr id="802395349" name="Slide Number Placeholder 6"/>
+          <p:cNvPr id="884900276" name="Slide Number Placeholder 6"/>
           <p:cNvSpPr>
             <a:spLocks noGrp="1"/>
           </p:cNvSpPr>
@@ -3713,7 +3713,7 @@
       </p:grpSpPr>
       <p:sp>
         <p:nvSpPr>
-          <p:cNvPr id="888792608" name="Title 1"/>
+          <p:cNvPr id="755921141" name="Title 1"/>
           <p:cNvSpPr>
             <a:spLocks noGrp="1"/>
           </p:cNvSpPr>
@@ -3748,7 +3748,7 @@
       </p:sp>
       <p:sp>
         <p:nvSpPr>
-          <p:cNvPr id="1355416305" name="Picture Placeholder 2"/>
+          <p:cNvPr id="1945281561" name="Picture Placeholder 2"/>
           <p:cNvSpPr>
             <a:spLocks noChangeAspect="1" noGrp="1"/>
           </p:cNvSpPr>
@@ -3816,7 +3816,7 @@
       </p:sp>
       <p:sp>
         <p:nvSpPr>
-          <p:cNvPr id="428222917" name="Text Placeholder 3"/>
+          <p:cNvPr id="313277968" name="Text Placeholder 3"/>
           <p:cNvSpPr>
             <a:spLocks noGrp="1"/>
           </p:cNvSpPr>
@@ -3884,7 +3884,7 @@
       </p:sp>
       <p:sp>
         <p:nvSpPr>
-          <p:cNvPr id="392298697" name="Date Placeholder 4"/>
+          <p:cNvPr id="1633634788" name="Date Placeholder 4"/>
           <p:cNvSpPr>
             <a:spLocks noGrp="1"/>
           </p:cNvSpPr>
@@ -3910,7 +3910,7 @@
       </p:sp>
       <p:sp>
         <p:nvSpPr>
-          <p:cNvPr id="183412190" name="Footer Placeholder 5"/>
+          <p:cNvPr id="466128788" name="Footer Placeholder 5"/>
           <p:cNvSpPr>
             <a:spLocks noGrp="1"/>
           </p:cNvSpPr>
@@ -3932,7 +3932,7 @@
       </p:sp>
       <p:sp>
         <p:nvSpPr>
-          <p:cNvPr id="1583778553" name="Slide Number Placeholder 6"/>
+          <p:cNvPr id="258105859" name="Slide Number Placeholder 6"/>
           <p:cNvSpPr>
             <a:spLocks noGrp="1"/>
           </p:cNvSpPr>
@@ -3988,7 +3988,7 @@
       </p:grpSpPr>
       <p:sp>
         <p:nvSpPr>
-          <p:cNvPr id="1057787583" name="Title Placeholder 1"/>
+          <p:cNvPr id="976332875" name="Title Placeholder 1"/>
           <p:cNvSpPr>
             <a:spLocks noGrp="1"/>
           </p:cNvSpPr>
@@ -4024,7 +4024,7 @@
       </p:sp>
       <p:sp>
         <p:nvSpPr>
-          <p:cNvPr id="450459896" name="Text Placeholder 2"/>
+          <p:cNvPr id="65112589" name="Text Placeholder 2"/>
           <p:cNvSpPr>
             <a:spLocks noGrp="1"/>
           </p:cNvSpPr>
@@ -4100,7 +4100,7 @@
       </p:sp>
       <p:sp>
         <p:nvSpPr>
-          <p:cNvPr id="1386139044" name="Date Placeholder 3"/>
+          <p:cNvPr id="220656352" name="Date Placeholder 3"/>
           <p:cNvSpPr>
             <a:spLocks noGrp="1"/>
           </p:cNvSpPr>
@@ -4144,7 +4144,7 @@
       </p:sp>
       <p:sp>
         <p:nvSpPr>
-          <p:cNvPr id="1228144471" name="Footer Placeholder 4"/>
+          <p:cNvPr id="688220260" name="Footer Placeholder 4"/>
           <p:cNvSpPr>
             <a:spLocks noGrp="1"/>
           </p:cNvSpPr>
@@ -4184,7 +4184,7 @@
       </p:sp>
       <p:sp>
         <p:nvSpPr>
-          <p:cNvPr id="1044487589" name="Slide Number Placeholder 5"/>
+          <p:cNvPr id="1918555977" name="Slide Number Placeholder 5"/>
           <p:cNvSpPr>
             <a:spLocks noGrp="1"/>
           </p:cNvSpPr>
@@ -4544,7 +4544,7 @@
       </p:grpSpPr>
       <p:sp>
         <p:nvSpPr>
-          <p:cNvPr id="703775657" name="Title 1"/>
+          <p:cNvPr id="1618095597" name="Title 1"/>
           <p:cNvSpPr>
             <a:spLocks noGrp="1"/>
           </p:cNvSpPr>
@@ -4570,7 +4570,7 @@
       </p:sp>
       <p:sp>
         <p:nvSpPr>
-          <p:cNvPr id="113147391" name=""/>
+          <p:cNvPr id="590340036" name=""/>
           <p:cNvSpPr txBox="1"/>
           <p:nvPr/>
         </p:nvSpPr>
@@ -4602,7 +4602,7 @@
       </p:sp>
       <p:sp>
         <p:nvSpPr>
-          <p:cNvPr id="442582762" name=""/>
+          <p:cNvPr id="976446348" name=""/>
           <p:cNvSpPr txBox="1"/>
           <p:nvPr/>
         </p:nvSpPr>
@@ -5239,7 +5239,7 @@
         </p:grpSp>
         <p:sp>
           <p:nvSpPr>
-            <p:cNvPr id="477744683" name=""/>
+            <p:cNvPr id="248328113" name=""/>
             <p:cNvSpPr txBox="1"/>
             <p:nvPr/>
           </p:nvSpPr>
@@ -5720,10 +5720,10 @@
         </p:sp>
         <p:cxnSp>
           <p:nvCxnSpPr>
-            <p:cNvPr id="116108060" name=""/>
+            <p:cNvPr id="598528214" name=""/>
             <p:cNvCxnSpPr>
               <a:stCxn id="68577564" idx="2"/>
-              <a:endCxn id="1492409434" idx="6"/>
+              <a:endCxn id="821952228" idx="6"/>
             </p:cNvCxnSpPr>
             <p:nvPr/>
           </p:nvCxnSpPr>
@@ -5762,7 +5762,7 @@
         </p:cxnSp>
         <p:sp>
           <p:nvSpPr>
-            <p:cNvPr id="1492409434" name=""/>
+            <p:cNvPr id="821952228" name=""/>
             <p:cNvSpPr/>
             <p:nvPr/>
           </p:nvSpPr>
@@ -5960,7 +5960,7 @@
         </p:grpSpPr>
         <p:cxnSp>
           <p:nvCxnSpPr>
-            <p:cNvPr id="1556524077" name=""/>
+            <p:cNvPr id="1317720132" name=""/>
             <p:cNvCxnSpPr/>
             <p:nvPr/>
           </p:nvCxnSpPr>
@@ -6000,7 +6000,7 @@
         </p:cxnSp>
         <p:sp>
           <p:nvSpPr>
-            <p:cNvPr id="1469162914" name=""/>
+            <p:cNvPr id="1148850855" name=""/>
             <p:cNvSpPr txBox="1"/>
             <p:nvPr/>
           </p:nvSpPr>
@@ -6205,7 +6205,7 @@
       </p:grpSpPr>
       <p:sp>
         <p:nvSpPr>
-          <p:cNvPr id="51471625" name=""/>
+          <p:cNvPr id="2003358991" name=""/>
           <p:cNvSpPr txBox="1"/>
           <p:nvPr/>
         </p:nvSpPr>
@@ -6237,7 +6237,7 @@
       </p:sp>
       <p:sp>
         <p:nvSpPr>
-          <p:cNvPr id="178466562" name=""/>
+          <p:cNvPr id="2094080839" name=""/>
           <p:cNvSpPr txBox="1"/>
           <p:nvPr/>
         </p:nvSpPr>
@@ -6269,7 +6269,7 @@
       </p:sp>
       <p:grpSp>
         <p:nvGrpSpPr>
-          <p:cNvPr id="1411489628" name=""/>
+          <p:cNvPr id="815162303" name=""/>
           <p:cNvGrpSpPr/>
           <p:nvPr/>
         </p:nvGrpSpPr>
@@ -12051,7 +12051,7 @@
       </p:grpSpPr>
       <p:sp>
         <p:nvSpPr>
-          <p:cNvPr id="176645702" name=""/>
+          <p:cNvPr id="895032433" name=""/>
           <p:cNvSpPr txBox="1"/>
           <p:nvPr/>
         </p:nvSpPr>
@@ -12083,7 +12083,7 @@
       </p:sp>
       <p:pic>
         <p:nvPicPr>
-          <p:cNvPr id="318138740" name=""/>
+          <p:cNvPr id="104359353" name=""/>
           <p:cNvPicPr>
             <a:picLocks noChangeAspect="1"/>
           </p:cNvPicPr>
@@ -12095,7 +12095,7 @@
         </p:blipFill>
         <p:spPr bwMode="auto">
           <a:xfrm flipH="0" flipV="0">
-            <a:off x="3071571" y="1781855"/>
+            <a:off x="6029764" y="1356631"/>
             <a:ext cx="5347560" cy="1369026"/>
           </a:xfrm>
           <a:prstGeom prst="rect">
@@ -12105,7 +12105,7 @@
       </p:pic>
       <p:sp>
         <p:nvSpPr>
-          <p:cNvPr id="994882815" name=""/>
+          <p:cNvPr id="609584244" name=""/>
           <p:cNvSpPr txBox="1"/>
           <p:nvPr/>
         </p:nvSpPr>
@@ -12174,13 +12174,13 @@
       </p:sp>
       <p:sp>
         <p:nvSpPr>
-          <p:cNvPr id="889816611" name=""/>
+          <p:cNvPr id="398622439" name=""/>
           <p:cNvSpPr txBox="1"/>
           <p:nvPr/>
         </p:nvSpPr>
         <p:spPr bwMode="auto">
           <a:xfrm rot="0" flipH="0" flipV="0">
-            <a:off x="3791475" y="4000497"/>
+            <a:off x="6921117" y="5565318"/>
             <a:ext cx="3564853" cy="1463400"/>
           </a:xfrm>
           <a:prstGeom prst="rect">
@@ -12204,6 +12204,633 @@
           </a:p>
         </p:txBody>
       </p:sp>
+      <p:grpSp>
+        <p:nvGrpSpPr>
+          <p:cNvPr id="1459335106" name=""/>
+          <p:cNvGrpSpPr/>
+          <p:nvPr/>
+        </p:nvGrpSpPr>
+        <p:grpSpPr bwMode="auto">
+          <a:xfrm>
+            <a:off x="1174129" y="2388765"/>
+            <a:ext cx="3974220" cy="3337515"/>
+            <a:chOff x="0" y="0"/>
+            <a:chExt cx="3974220" cy="3337515"/>
+          </a:xfrm>
+        </p:grpSpPr>
+        <p:grpSp>
+          <p:nvGrpSpPr>
+            <p:cNvPr id="419697780" name=""/>
+            <p:cNvGrpSpPr/>
+            <p:nvPr/>
+          </p:nvGrpSpPr>
+          <p:grpSpPr bwMode="auto">
+            <a:xfrm rot="10800000">
+              <a:off x="0" y="0"/>
+              <a:ext cx="3974220" cy="3337515"/>
+              <a:chOff x="0" y="0"/>
+              <a:chExt cx="3974220" cy="3337515"/>
+            </a:xfrm>
+          </p:grpSpPr>
+          <p:cxnSp>
+            <p:nvCxnSpPr>
+              <p:cNvPr id="1266803932" name=""/>
+              <p:cNvCxnSpPr/>
+              <p:nvPr/>
+            </p:nvCxnSpPr>
+            <p:spPr bwMode="auto">
+              <a:xfrm rot="10800000" flipH="0" flipV="0">
+                <a:off x="2436300" y="1668754"/>
+                <a:ext cx="805230" cy="0"/>
+              </a:xfrm>
+              <a:prstGeom prst="line">
+                <a:avLst/>
+              </a:prstGeom>
+              <a:ln w="38100" cap="flat" cmpd="sng" algn="ctr">
+                <a:solidFill>
+                  <a:srgbClr val="000000"/>
+                </a:solidFill>
+                <a:prstDash val="solid"/>
+                <a:miter lim="800000"/>
+              </a:ln>
+            </p:spPr>
+            <p:style>
+              <a:lnRef idx="1">
+                <a:schemeClr val="accent1">
+                  <a:shade val="50000"/>
+                </a:schemeClr>
+              </a:lnRef>
+              <a:fillRef idx="0">
+                <a:schemeClr val="accent1"/>
+              </a:fillRef>
+              <a:effectRef idx="0">
+                <a:schemeClr val="accent1"/>
+              </a:effectRef>
+              <a:fontRef idx="minor">
+                <a:schemeClr val="tx1"/>
+              </a:fontRef>
+            </p:style>
+          </p:cxnSp>
+          <p:cxnSp>
+            <p:nvCxnSpPr>
+              <p:cNvPr id="158614045" name=""/>
+              <p:cNvCxnSpPr/>
+              <p:nvPr/>
+            </p:nvCxnSpPr>
+            <p:spPr bwMode="auto">
+              <a:xfrm rot="16199998" flipH="0" flipV="1">
+                <a:off x="2370880" y="431759"/>
+                <a:ext cx="1043366" cy="912529"/>
+              </a:xfrm>
+              <a:prstGeom prst="line">
+                <a:avLst/>
+              </a:prstGeom>
+              <a:ln w="38100" cap="flat" cmpd="sng" algn="ctr">
+                <a:solidFill>
+                  <a:srgbClr val="000000"/>
+                </a:solidFill>
+                <a:prstDash val="solid"/>
+                <a:miter lim="800000"/>
+              </a:ln>
+            </p:spPr>
+            <p:style>
+              <a:lnRef idx="1">
+                <a:schemeClr val="accent1">
+                  <a:shade val="50000"/>
+                </a:schemeClr>
+              </a:lnRef>
+              <a:fillRef idx="0">
+                <a:schemeClr val="accent1"/>
+              </a:fillRef>
+              <a:effectRef idx="0">
+                <a:schemeClr val="accent1"/>
+              </a:effectRef>
+              <a:fontRef idx="minor">
+                <a:schemeClr val="tx1"/>
+              </a:fontRef>
+            </p:style>
+          </p:cxnSp>
+          <p:cxnSp>
+            <p:nvCxnSpPr>
+              <p:cNvPr id="1273209217" name=""/>
+              <p:cNvCxnSpPr/>
+              <p:nvPr/>
+            </p:nvCxnSpPr>
+            <p:spPr bwMode="auto">
+              <a:xfrm rot="5399997" flipH="0" flipV="0">
+                <a:off x="2370882" y="1993221"/>
+                <a:ext cx="1043364" cy="912529"/>
+              </a:xfrm>
+              <a:prstGeom prst="line">
+                <a:avLst/>
+              </a:prstGeom>
+              <a:ln w="38100" cap="flat" cmpd="sng" algn="ctr">
+                <a:solidFill>
+                  <a:srgbClr val="000000"/>
+                </a:solidFill>
+                <a:prstDash val="solid"/>
+                <a:miter lim="800000"/>
+              </a:ln>
+            </p:spPr>
+            <p:style>
+              <a:lnRef idx="1">
+                <a:schemeClr val="accent1">
+                  <a:shade val="50000"/>
+                </a:schemeClr>
+              </a:lnRef>
+              <a:fillRef idx="0">
+                <a:schemeClr val="accent1"/>
+              </a:fillRef>
+              <a:effectRef idx="0">
+                <a:schemeClr val="accent1"/>
+              </a:effectRef>
+              <a:fontRef idx="minor">
+                <a:schemeClr val="tx1"/>
+              </a:fontRef>
+            </p:style>
+          </p:cxnSp>
+          <p:sp>
+            <p:nvSpPr>
+              <p:cNvPr id="330069749" name=""/>
+              <p:cNvSpPr/>
+              <p:nvPr/>
+            </p:nvSpPr>
+            <p:spPr bwMode="auto">
+              <a:xfrm rot="0" flipH="0" flipV="0">
+                <a:off x="3241530" y="1302407"/>
+                <a:ext cx="732690" cy="732690"/>
+              </a:xfrm>
+              <a:prstGeom prst="ellipse">
+                <a:avLst/>
+              </a:prstGeom>
+              <a:solidFill>
+                <a:srgbClr val="E173FF"/>
+              </a:solidFill>
+              <a:ln w="38100" cap="flat" cmpd="sng" algn="ctr">
+                <a:solidFill>
+                  <a:srgbClr val="000000"/>
+                </a:solidFill>
+                <a:prstDash val="solid"/>
+                <a:miter lim="800000"/>
+              </a:ln>
+            </p:spPr>
+            <p:style>
+              <a:lnRef idx="2">
+                <a:schemeClr val="accent1">
+                  <a:shade val="50000"/>
+                </a:schemeClr>
+              </a:lnRef>
+              <a:fillRef idx="1">
+                <a:schemeClr val="accent1"/>
+              </a:fillRef>
+              <a:effectRef idx="0">
+                <a:schemeClr val="accent1"/>
+              </a:effectRef>
+              <a:fontRef idx="minor">
+                <a:schemeClr val="lt1"/>
+              </a:fontRef>
+            </p:style>
+          </p:sp>
+          <p:cxnSp>
+            <p:nvCxnSpPr>
+              <p:cNvPr id="2075436910" name=""/>
+              <p:cNvCxnSpPr/>
+              <p:nvPr/>
+            </p:nvCxnSpPr>
+            <p:spPr bwMode="auto">
+              <a:xfrm rot="10800000" flipH="0" flipV="0">
+                <a:off x="732690" y="2971170"/>
+                <a:ext cx="970920" cy="0"/>
+              </a:xfrm>
+              <a:prstGeom prst="line">
+                <a:avLst/>
+              </a:prstGeom>
+              <a:ln w="38100" cap="flat" cmpd="sng" algn="ctr">
+                <a:solidFill>
+                  <a:schemeClr val="tx1"/>
+                </a:solidFill>
+                <a:prstDash val="solid"/>
+                <a:miter lim="800000"/>
+              </a:ln>
+            </p:spPr>
+            <p:style>
+              <a:lnRef idx="1">
+                <a:schemeClr val="accent1">
+                  <a:shade val="50000"/>
+                </a:schemeClr>
+              </a:lnRef>
+              <a:fillRef idx="0">
+                <a:schemeClr val="accent1"/>
+              </a:fillRef>
+              <a:effectRef idx="0">
+                <a:schemeClr val="accent1"/>
+              </a:effectRef>
+              <a:fontRef idx="minor">
+                <a:schemeClr val="tx1"/>
+              </a:fontRef>
+            </p:style>
+          </p:cxnSp>
+          <p:cxnSp>
+            <p:nvCxnSpPr>
+              <p:cNvPr id="1310543906" name=""/>
+              <p:cNvCxnSpPr/>
+              <p:nvPr/>
+            </p:nvCxnSpPr>
+            <p:spPr bwMode="auto">
+              <a:xfrm rot="10800000" flipH="0" flipV="1">
+                <a:off x="732690" y="1668753"/>
+                <a:ext cx="970920" cy="0"/>
+              </a:xfrm>
+              <a:prstGeom prst="line">
+                <a:avLst/>
+              </a:prstGeom>
+              <a:ln w="38100" cap="flat" cmpd="sng" algn="ctr">
+                <a:solidFill>
+                  <a:schemeClr val="tx1"/>
+                </a:solidFill>
+                <a:prstDash val="solid"/>
+                <a:miter lim="800000"/>
+              </a:ln>
+            </p:spPr>
+            <p:style>
+              <a:lnRef idx="1">
+                <a:schemeClr val="accent1">
+                  <a:shade val="50000"/>
+                </a:schemeClr>
+              </a:lnRef>
+              <a:fillRef idx="0">
+                <a:schemeClr val="accent1"/>
+              </a:fillRef>
+              <a:effectRef idx="0">
+                <a:schemeClr val="accent1"/>
+              </a:effectRef>
+              <a:fontRef idx="minor">
+                <a:schemeClr val="tx1"/>
+              </a:fontRef>
+            </p:style>
+          </p:cxnSp>
+          <p:cxnSp>
+            <p:nvCxnSpPr>
+              <p:cNvPr id="149862053" name=""/>
+              <p:cNvCxnSpPr/>
+              <p:nvPr/>
+            </p:nvCxnSpPr>
+            <p:spPr bwMode="auto">
+              <a:xfrm rot="10800000" flipH="0" flipV="0">
+                <a:off x="732690" y="366345"/>
+                <a:ext cx="970920" cy="0"/>
+              </a:xfrm>
+              <a:prstGeom prst="line">
+                <a:avLst/>
+              </a:prstGeom>
+              <a:ln w="38100" cap="flat" cmpd="sng" algn="ctr">
+                <a:solidFill>
+                  <a:schemeClr val="tx1"/>
+                </a:solidFill>
+                <a:prstDash val="solid"/>
+                <a:miter lim="800000"/>
+              </a:ln>
+            </p:spPr>
+            <p:style>
+              <a:lnRef idx="1">
+                <a:schemeClr val="accent1">
+                  <a:shade val="50000"/>
+                </a:schemeClr>
+              </a:lnRef>
+              <a:fillRef idx="0">
+                <a:schemeClr val="accent1"/>
+              </a:fillRef>
+              <a:effectRef idx="0">
+                <a:schemeClr val="accent1"/>
+              </a:effectRef>
+              <a:fontRef idx="minor">
+                <a:schemeClr val="tx1"/>
+              </a:fontRef>
+            </p:style>
+          </p:cxnSp>
+          <p:grpSp>
+            <p:nvGrpSpPr>
+              <p:cNvPr id="2146914998" name=""/>
+              <p:cNvGrpSpPr/>
+              <p:nvPr/>
+            </p:nvGrpSpPr>
+            <p:grpSpPr bwMode="auto">
+              <a:xfrm>
+                <a:off x="0" y="0"/>
+                <a:ext cx="732690" cy="3337515"/>
+                <a:chOff x="0" y="0"/>
+                <a:chExt cx="732690" cy="3337515"/>
+              </a:xfrm>
+            </p:grpSpPr>
+            <p:sp>
+              <p:nvSpPr>
+                <p:cNvPr id="1694970102" name=""/>
+                <p:cNvSpPr/>
+                <p:nvPr/>
+              </p:nvSpPr>
+              <p:spPr bwMode="auto">
+                <a:xfrm rot="0" flipH="0" flipV="0">
+                  <a:off x="0" y="2604825"/>
+                  <a:ext cx="732690" cy="732690"/>
+                </a:xfrm>
+                <a:prstGeom prst="ellipse">
+                  <a:avLst/>
+                </a:prstGeom>
+                <a:solidFill>
+                  <a:srgbClr val="FF4C4C"/>
+                </a:solidFill>
+                <a:ln w="38100" cap="flat" cmpd="sng" algn="ctr">
+                  <a:solidFill>
+                    <a:srgbClr val="000000"/>
+                  </a:solidFill>
+                  <a:prstDash val="solid"/>
+                  <a:miter lim="800000"/>
+                </a:ln>
+              </p:spPr>
+              <p:style>
+                <a:lnRef idx="2">
+                  <a:schemeClr val="accent1">
+                    <a:shade val="50000"/>
+                  </a:schemeClr>
+                </a:lnRef>
+                <a:fillRef idx="1">
+                  <a:schemeClr val="accent1"/>
+                </a:fillRef>
+                <a:effectRef idx="0">
+                  <a:schemeClr val="accent1"/>
+                </a:effectRef>
+                <a:fontRef idx="minor">
+                  <a:schemeClr val="lt1"/>
+                </a:fontRef>
+              </p:style>
+            </p:sp>
+            <p:sp>
+              <p:nvSpPr>
+                <p:cNvPr id="674672311" name=""/>
+                <p:cNvSpPr/>
+                <p:nvPr/>
+              </p:nvSpPr>
+              <p:spPr bwMode="auto">
+                <a:xfrm rot="0" flipH="0" flipV="0">
+                  <a:off x="0" y="1302407"/>
+                  <a:ext cx="732690" cy="732690"/>
+                </a:xfrm>
+                <a:prstGeom prst="ellipse">
+                  <a:avLst/>
+                </a:prstGeom>
+                <a:solidFill>
+                  <a:srgbClr val="FF4C4C"/>
+                </a:solidFill>
+                <a:ln w="38100" cap="flat" cmpd="sng" algn="ctr">
+                  <a:solidFill>
+                    <a:srgbClr val="000000"/>
+                  </a:solidFill>
+                  <a:prstDash val="solid"/>
+                  <a:miter lim="800000"/>
+                </a:ln>
+              </p:spPr>
+              <p:style>
+                <a:lnRef idx="2">
+                  <a:schemeClr val="accent1">
+                    <a:shade val="50000"/>
+                  </a:schemeClr>
+                </a:lnRef>
+                <a:fillRef idx="1">
+                  <a:schemeClr val="accent1"/>
+                </a:fillRef>
+                <a:effectRef idx="0">
+                  <a:schemeClr val="accent1"/>
+                </a:effectRef>
+                <a:fontRef idx="minor">
+                  <a:schemeClr val="lt1"/>
+                </a:fontRef>
+              </p:style>
+            </p:sp>
+            <p:sp>
+              <p:nvSpPr>
+                <p:cNvPr id="239901396" name=""/>
+                <p:cNvSpPr/>
+                <p:nvPr/>
+              </p:nvSpPr>
+              <p:spPr bwMode="auto">
+                <a:xfrm rot="0" flipH="0" flipV="0">
+                  <a:off x="0" y="0"/>
+                  <a:ext cx="732690" cy="732690"/>
+                </a:xfrm>
+                <a:prstGeom prst="ellipse">
+                  <a:avLst/>
+                </a:prstGeom>
+                <a:solidFill>
+                  <a:srgbClr val="FF4C4C"/>
+                </a:solidFill>
+                <a:ln w="38100" cap="flat" cmpd="sng" algn="ctr">
+                  <a:solidFill>
+                    <a:srgbClr val="000000"/>
+                  </a:solidFill>
+                  <a:prstDash val="solid"/>
+                  <a:miter lim="800000"/>
+                </a:ln>
+              </p:spPr>
+              <p:style>
+                <a:lnRef idx="2">
+                  <a:schemeClr val="accent1">
+                    <a:shade val="50000"/>
+                  </a:schemeClr>
+                </a:lnRef>
+                <a:fillRef idx="1">
+                  <a:schemeClr val="accent1"/>
+                </a:fillRef>
+                <a:effectRef idx="0">
+                  <a:schemeClr val="accent1"/>
+                </a:effectRef>
+                <a:fontRef idx="minor">
+                  <a:schemeClr val="lt1"/>
+                </a:fontRef>
+              </p:style>
+            </p:sp>
+          </p:grpSp>
+          <p:grpSp>
+            <p:nvGrpSpPr>
+              <p:cNvPr id="234930104" name=""/>
+              <p:cNvGrpSpPr/>
+              <p:nvPr/>
+            </p:nvGrpSpPr>
+            <p:grpSpPr bwMode="auto">
+              <a:xfrm>
+                <a:off x="1703610" y="0"/>
+                <a:ext cx="732690" cy="3337515"/>
+                <a:chOff x="0" y="0"/>
+                <a:chExt cx="732690" cy="3337515"/>
+              </a:xfrm>
+            </p:grpSpPr>
+            <p:sp>
+              <p:nvSpPr>
+                <p:cNvPr id="1521834786" name=""/>
+                <p:cNvSpPr/>
+                <p:nvPr/>
+              </p:nvSpPr>
+              <p:spPr bwMode="auto">
+                <a:xfrm rot="0" flipH="0" flipV="0">
+                  <a:off x="0" y="2604825"/>
+                  <a:ext cx="732690" cy="732690"/>
+                </a:xfrm>
+                <a:prstGeom prst="ellipse">
+                  <a:avLst/>
+                </a:prstGeom>
+                <a:solidFill>
+                  <a:srgbClr val="FFC926"/>
+                </a:solidFill>
+                <a:ln w="38100" cap="flat" cmpd="sng" algn="ctr">
+                  <a:solidFill>
+                    <a:schemeClr val="tx1"/>
+                  </a:solidFill>
+                  <a:prstDash val="sysDash"/>
+                  <a:miter lim="800000"/>
+                </a:ln>
+              </p:spPr>
+              <p:style>
+                <a:lnRef idx="2">
+                  <a:schemeClr val="accent1">
+                    <a:shade val="50000"/>
+                  </a:schemeClr>
+                </a:lnRef>
+                <a:fillRef idx="1">
+                  <a:schemeClr val="accent1"/>
+                </a:fillRef>
+                <a:effectRef idx="0">
+                  <a:schemeClr val="accent1"/>
+                </a:effectRef>
+                <a:fontRef idx="minor">
+                  <a:schemeClr val="lt1"/>
+                </a:fontRef>
+              </p:style>
+            </p:sp>
+            <p:sp>
+              <p:nvSpPr>
+                <p:cNvPr id="226617674" name=""/>
+                <p:cNvSpPr/>
+                <p:nvPr/>
+              </p:nvSpPr>
+              <p:spPr bwMode="auto">
+                <a:xfrm rot="0" flipH="0" flipV="0">
+                  <a:off x="0" y="1302407"/>
+                  <a:ext cx="732690" cy="732690"/>
+                </a:xfrm>
+                <a:prstGeom prst="ellipse">
+                  <a:avLst/>
+                </a:prstGeom>
+                <a:solidFill>
+                  <a:srgbClr val="FFC926"/>
+                </a:solidFill>
+                <a:ln w="38100" cap="flat" cmpd="sng" algn="ctr">
+                  <a:solidFill>
+                    <a:schemeClr val="tx1"/>
+                  </a:solidFill>
+                  <a:prstDash val="sysDash"/>
+                  <a:miter lim="800000"/>
+                </a:ln>
+              </p:spPr>
+              <p:style>
+                <a:lnRef idx="2">
+                  <a:schemeClr val="accent1">
+                    <a:shade val="50000"/>
+                  </a:schemeClr>
+                </a:lnRef>
+                <a:fillRef idx="1">
+                  <a:schemeClr val="accent1"/>
+                </a:fillRef>
+                <a:effectRef idx="0">
+                  <a:schemeClr val="accent1"/>
+                </a:effectRef>
+                <a:fontRef idx="minor">
+                  <a:schemeClr val="lt1"/>
+                </a:fontRef>
+              </p:style>
+            </p:sp>
+            <p:sp>
+              <p:nvSpPr>
+                <p:cNvPr id="1461347968" name=""/>
+                <p:cNvSpPr/>
+                <p:nvPr/>
+              </p:nvSpPr>
+              <p:spPr bwMode="auto">
+                <a:xfrm rot="0" flipH="0" flipV="0">
+                  <a:off x="0" y="0"/>
+                  <a:ext cx="732690" cy="732690"/>
+                </a:xfrm>
+                <a:prstGeom prst="ellipse">
+                  <a:avLst/>
+                </a:prstGeom>
+                <a:solidFill>
+                  <a:srgbClr val="FFC926"/>
+                </a:solidFill>
+                <a:ln w="38100" cap="flat" cmpd="sng" algn="ctr">
+                  <a:solidFill>
+                    <a:schemeClr val="tx1"/>
+                  </a:solidFill>
+                  <a:prstDash val="sysDash"/>
+                  <a:miter lim="800000"/>
+                </a:ln>
+              </p:spPr>
+              <p:style>
+                <a:lnRef idx="2">
+                  <a:schemeClr val="accent1">
+                    <a:shade val="50000"/>
+                  </a:schemeClr>
+                </a:lnRef>
+                <a:fillRef idx="1">
+                  <a:schemeClr val="accent1"/>
+                </a:fillRef>
+                <a:effectRef idx="0">
+                  <a:schemeClr val="accent1"/>
+                </a:effectRef>
+                <a:fontRef idx="minor">
+                  <a:schemeClr val="lt1"/>
+                </a:fontRef>
+              </p:style>
+            </p:sp>
+          </p:grpSp>
+        </p:grpSp>
+        <p:sp>
+          <p:nvSpPr>
+            <p:cNvPr id="1420594127" name=""/>
+            <p:cNvSpPr txBox="1"/>
+            <p:nvPr/>
+          </p:nvSpPr>
+          <p:spPr bwMode="auto">
+            <a:xfrm rot="5400000" flipH="0" flipV="0">
+              <a:off x="2578581" y="2013102"/>
+              <a:ext cx="667964" cy="640440"/>
+            </a:xfrm>
+            <a:prstGeom prst="rect">
+              <a:avLst/>
+            </a:prstGeom>
+            <a:noFill/>
+          </p:spPr>
+          <p:txBody>
+            <a:bodyPr vertOverflow="overflow" horzOverflow="overflow" vert="horz" wrap="square" lIns="91440" tIns="45720" rIns="91440" bIns="45720" numCol="1" spcCol="0" rtlCol="0" fromWordArt="0" anchor="t" anchorCtr="0" forceAA="0" upright="0" compatLnSpc="0">
+              <a:spAutoFit/>
+            </a:bodyPr>
+            <a:p>
+              <a:pPr>
+                <a:defRPr/>
+              </a:pPr>
+              <a:r>
+                <a:rPr lang="fr-FR" sz="3600" b="1" i="0" u="none" strike="noStrike" cap="none" spc="0">
+                  <a:solidFill>
+                    <a:schemeClr val="tx1"/>
+                  </a:solidFill>
+                  <a:latin typeface="Arial"/>
+                  <a:ea typeface="Arial"/>
+                  <a:cs typeface="Arial"/>
+                </a:rPr>
+                <a:t>…</a:t>
+              </a:r>
+              <a:endParaRPr sz="3600" b="1"/>
+            </a:p>
+          </p:txBody>
+        </p:sp>
+      </p:grpSp>
     </p:spTree>
   </p:cSld>
   <p:clrMapOvr>
@@ -12239,7 +12866,7 @@
       </p:grpSpPr>
       <p:grpSp>
         <p:nvGrpSpPr>
-          <p:cNvPr id="1740658564" name=""/>
+          <p:cNvPr id="2048457100" name=""/>
           <p:cNvGrpSpPr/>
           <p:nvPr/>
         </p:nvGrpSpPr>
@@ -12343,7 +12970,7 @@
       </p:grpSp>
       <p:sp>
         <p:nvSpPr>
-          <p:cNvPr id="738559756" name=""/>
+          <p:cNvPr id="1112301152" name=""/>
           <p:cNvSpPr txBox="1"/>
           <p:nvPr/>
         </p:nvSpPr>
@@ -12375,7 +13002,7 @@
       </p:sp>
       <p:sp>
         <p:nvSpPr>
-          <p:cNvPr id="1969459542" name=""/>
+          <p:cNvPr id="1278269367" name=""/>
           <p:cNvSpPr txBox="1"/>
           <p:nvPr/>
         </p:nvSpPr>
@@ -12407,7 +13034,7 @@
       </p:sp>
       <p:grpSp>
         <p:nvGrpSpPr>
-          <p:cNvPr id="573429268" name=""/>
+          <p:cNvPr id="2058754467" name=""/>
           <p:cNvGrpSpPr/>
           <p:nvPr/>
         </p:nvGrpSpPr>
@@ -14102,7 +14729,7 @@
       </p:grpSpPr>
       <p:grpSp>
         <p:nvGrpSpPr>
-          <p:cNvPr id="742979200" name=""/>
+          <p:cNvPr id="676876407" name=""/>
           <p:cNvGrpSpPr/>
           <p:nvPr/>
         </p:nvGrpSpPr>
@@ -14785,7 +15412,7 @@
       </p:grpSp>
       <p:sp>
         <p:nvSpPr>
-          <p:cNvPr id="1727417419" name=""/>
+          <p:cNvPr id="342588448" name=""/>
           <p:cNvSpPr txBox="1"/>
           <p:nvPr/>
         </p:nvSpPr>
@@ -14817,7 +15444,7 @@
       </p:sp>
       <p:grpSp>
         <p:nvGrpSpPr>
-          <p:cNvPr id="487833784" name=""/>
+          <p:cNvPr id="1437926951" name=""/>
           <p:cNvGrpSpPr/>
           <p:nvPr/>
         </p:nvGrpSpPr>
@@ -19277,7 +19904,7 @@
       </p:grpSp>
       <p:grpSp>
         <p:nvGrpSpPr>
-          <p:cNvPr id="595459597" name=""/>
+          <p:cNvPr id="968491312" name=""/>
           <p:cNvGrpSpPr/>
           <p:nvPr/>
         </p:nvGrpSpPr>
@@ -19377,7 +20004,7 @@
       </p:grpSp>
       <p:grpSp>
         <p:nvGrpSpPr>
-          <p:cNvPr id="1135205795" name=""/>
+          <p:cNvPr id="946282690" name=""/>
           <p:cNvGrpSpPr/>
           <p:nvPr/>
         </p:nvGrpSpPr>
@@ -19498,7 +20125,7 @@
       </p:grpSp>
       <p:grpSp>
         <p:nvGrpSpPr>
-          <p:cNvPr id="1781807955" name=""/>
+          <p:cNvPr id="1621752170" name=""/>
           <p:cNvGrpSpPr/>
           <p:nvPr/>
         </p:nvGrpSpPr>
@@ -19598,7 +20225,7 @@
       </p:grpSp>
       <p:grpSp>
         <p:nvGrpSpPr>
-          <p:cNvPr id="1217454441" name=""/>
+          <p:cNvPr id="1607258687" name=""/>
           <p:cNvGrpSpPr/>
           <p:nvPr/>
         </p:nvGrpSpPr>
@@ -24073,7 +24700,7 @@
       </p:grpSpPr>
       <p:sp>
         <p:nvSpPr>
-          <p:cNvPr id="1710965340" name=""/>
+          <p:cNvPr id="1447950883" name=""/>
           <p:cNvSpPr txBox="1"/>
           <p:nvPr/>
         </p:nvSpPr>
@@ -24109,7 +24736,7 @@
       </p:sp>
       <p:grpSp>
         <p:nvGrpSpPr>
-          <p:cNvPr id="777633638" name=""/>
+          <p:cNvPr id="1004851217" name=""/>
           <p:cNvGrpSpPr/>
           <p:nvPr/>
         </p:nvGrpSpPr>
@@ -28564,7 +29191,7 @@
       </p:grpSpPr>
       <p:sp>
         <p:nvSpPr>
-          <p:cNvPr id="670772857" name="Title 1"/>
+          <p:cNvPr id="2077499199" name="Title 1"/>
           <p:cNvSpPr>
             <a:spLocks noGrp="1"/>
           </p:cNvSpPr>
@@ -28595,7 +29222,7 @@
       </p:sp>
       <p:grpSp>
         <p:nvGrpSpPr>
-          <p:cNvPr id="209844712" name=""/>
+          <p:cNvPr id="168862555" name=""/>
           <p:cNvGrpSpPr/>
           <p:nvPr/>
         </p:nvGrpSpPr>
@@ -33811,7 +34438,7 @@
       </p:grpSp>
       <p:grpSp>
         <p:nvGrpSpPr>
-          <p:cNvPr id="567582028" name=""/>
+          <p:cNvPr id="1697103319" name=""/>
           <p:cNvGrpSpPr/>
           <p:nvPr/>
         </p:nvGrpSpPr>
@@ -37812,7 +38439,7 @@
       </p:grpSp>
       <p:grpSp>
         <p:nvGrpSpPr>
-          <p:cNvPr id="802323550" name=""/>
+          <p:cNvPr id="1023838203" name=""/>
           <p:cNvGrpSpPr/>
           <p:nvPr/>
         </p:nvGrpSpPr>
@@ -42290,7 +42917,7 @@
       </p:grpSpPr>
       <p:sp>
         <p:nvSpPr>
-          <p:cNvPr id="1783667222" name=""/>
+          <p:cNvPr id="647033449" name=""/>
           <p:cNvSpPr txBox="1"/>
           <p:nvPr/>
         </p:nvSpPr>
@@ -42329,7 +42956,7 @@
       </p:sp>
       <p:sp>
         <p:nvSpPr>
-          <p:cNvPr id="744868824" name=""/>
+          <p:cNvPr id="75862885" name=""/>
           <p:cNvSpPr txBox="1"/>
           <p:nvPr/>
         </p:nvSpPr>
@@ -42394,7 +43021,7 @@
       </p:grpSpPr>
       <p:grpSp>
         <p:nvGrpSpPr>
-          <p:cNvPr id="1588206537" name=""/>
+          <p:cNvPr id="1633169796" name=""/>
           <p:cNvGrpSpPr/>
           <p:nvPr/>
         </p:nvGrpSpPr>
@@ -43309,7 +43936,7 @@
       </p:grpSp>
       <p:sp>
         <p:nvSpPr>
-          <p:cNvPr id="2072270419" name=""/>
+          <p:cNvPr id="67846459" name=""/>
           <p:cNvSpPr txBox="1"/>
           <p:nvPr/>
         </p:nvSpPr>
@@ -43393,7 +44020,7 @@
       </p:grpSpPr>
       <p:sp>
         <p:nvSpPr>
-          <p:cNvPr id="1276196233" name=""/>
+          <p:cNvPr id="1785833437" name=""/>
           <p:cNvSpPr txBox="1"/>
           <p:nvPr/>
         </p:nvSpPr>
@@ -43425,7 +44052,7 @@
       </p:sp>
       <p:grpSp>
         <p:nvGrpSpPr>
-          <p:cNvPr id="876916244" name=""/>
+          <p:cNvPr id="1775944520" name=""/>
           <p:cNvGrpSpPr/>
           <p:nvPr/>
         </p:nvGrpSpPr>
@@ -45221,7 +45848,7 @@
       </p:grpSpPr>
       <p:sp>
         <p:nvSpPr>
-          <p:cNvPr id="1801146361" name=""/>
+          <p:cNvPr id="840822102" name=""/>
           <p:cNvSpPr txBox="1"/>
           <p:nvPr/>
         </p:nvSpPr>
@@ -45253,7 +45880,7 @@
       </p:sp>
       <p:grpSp>
         <p:nvGrpSpPr>
-          <p:cNvPr id="1478663884" name=""/>
+          <p:cNvPr id="1610068536" name=""/>
           <p:cNvGrpSpPr/>
           <p:nvPr/>
         </p:nvGrpSpPr>

</xml_diff>